<commit_message>
add much better design
</commit_message>
<xml_diff>
--- a/deliverables/monthly_executive_deck.pptx
+++ b/deliverables/monthly_executive_deck.pptx
@@ -2,18 +2,18 @@
 <file path=ppt/presentation.xml><?xml version="1.0" encoding="utf-8"?>
 <p:presentation xmlns:p="http://schemas.openxmlformats.org/presentationml/2006/main">
   <p:sldMasterIdLst>
-    <p:sldMasterId xmlns:r="http://schemas.openxmlformats.org/officeDocument/2006/relationships" id="2147483648" r:id="R2ab0ebabb2c84c22"/>
+    <p:sldMasterId xmlns:r="http://schemas.openxmlformats.org/officeDocument/2006/relationships" id="2147483648" r:id="R595d956a85be4f4a"/>
   </p:sldMasterIdLst>
   <p:notesMasterIdLst>
-    <p:notesMasterId xmlns:r="http://schemas.openxmlformats.org/officeDocument/2006/relationships" r:id="R0e6564313a1942c4"/>
+    <p:notesMasterId xmlns:r="http://schemas.openxmlformats.org/officeDocument/2006/relationships" r:id="R325153df789c46cf"/>
   </p:notesMasterIdLst>
   <p:sldIdLst>
-    <p:sldId xmlns:r="http://schemas.openxmlformats.org/officeDocument/2006/relationships" id="256" r:id="R1ade6f275e364942"/>
-    <p:sldId xmlns:r="http://schemas.openxmlformats.org/officeDocument/2006/relationships" id="257" r:id="Rd017f5f17d1a409d"/>
-    <p:sldId xmlns:r="http://schemas.openxmlformats.org/officeDocument/2006/relationships" id="258" r:id="R9b6c1713d81d4dd4"/>
-    <p:sldId xmlns:r="http://schemas.openxmlformats.org/officeDocument/2006/relationships" id="259" r:id="R471f454a50a24b0e"/>
-    <p:sldId xmlns:r="http://schemas.openxmlformats.org/officeDocument/2006/relationships" id="260" r:id="Ra60b999339be4dfe"/>
-    <p:sldId xmlns:r="http://schemas.openxmlformats.org/officeDocument/2006/relationships" id="261" r:id="R469d30efb5a7448b"/>
+    <p:sldId xmlns:r="http://schemas.openxmlformats.org/officeDocument/2006/relationships" id="256" r:id="R75de0b4b37a24116"/>
+    <p:sldId xmlns:r="http://schemas.openxmlformats.org/officeDocument/2006/relationships" id="257" r:id="R19b28f3176a44e93"/>
+    <p:sldId xmlns:r="http://schemas.openxmlformats.org/officeDocument/2006/relationships" id="258" r:id="R67bf64ee242f4679"/>
+    <p:sldId xmlns:r="http://schemas.openxmlformats.org/officeDocument/2006/relationships" id="259" r:id="R6cb3b0e084f842c8"/>
+    <p:sldId xmlns:r="http://schemas.openxmlformats.org/officeDocument/2006/relationships" id="260" r:id="R3ea11a3066df4351"/>
+    <p:sldId xmlns:r="http://schemas.openxmlformats.org/officeDocument/2006/relationships" id="261" r:id="R200987fec2f943d2"/>
   </p:sldIdLst>
   <p:sldSz cx="12192000" cy="6858000"/>
   <p:notesSz cx="6858000" cy="9144000"/>
@@ -936,7 +936,7 @@
   </p:cSld>
   <p:clrMap bg1="lt1" tx1="dk1" bg2="lt2" tx2="dk2" accent1="accent1" accent2="accent2" accent3="accent3" accent4="accent4" accent5="accent5" accent6="accent6" hlink="hlink" folHlink="folHlink"/>
   <p:sldLayoutIdLst>
-    <p:sldLayoutId xmlns:r="http://schemas.openxmlformats.org/officeDocument/2006/relationships" id="2147483649" r:id="R2b527ac73ee143aa"/>
+    <p:sldLayoutId xmlns:r="http://schemas.openxmlformats.org/officeDocument/2006/relationships" id="2147483649" r:id="R4dc72d49d0c8404c"/>
   </p:sldLayoutIdLst>
   <p:txStyles>
     <p:titleStyle>
@@ -1487,7 +1487,7 @@
           <p:cNvPr id="1" name="">
             <a:extLst xmlns:a="http://schemas.openxmlformats.org/drawingml/2006/main">
               <a:ext uri="{FF2B5EF4-FFF2-40B4-BE49-F238E27FC236}">
-                <a16:creationId xmlns:a16="http://schemas.microsoft.com/office/drawing/2014/main" id="{ADDC0D57-8E4E-42FB-8564-0E2517BC883E}"/>
+                <a16:creationId xmlns:a16="http://schemas.microsoft.com/office/drawing/2014/main" id="{7B0DEDDC-FC35-4447-AA50-21C5D43E7FC1}"/>
               </a:ext>
             </a:extLst>
           </p:cNvPr>
@@ -1537,7 +1537,7 @@
           <p:cNvPr id="2" name="">
             <a:extLst xmlns:a="http://schemas.openxmlformats.org/drawingml/2006/main">
               <a:ext uri="{FF2B5EF4-FFF2-40B4-BE49-F238E27FC236}">
-                <a16:creationId xmlns:a16="http://schemas.microsoft.com/office/drawing/2014/main" id="{28322596-CBA9-4A8F-9865-C5A9C69DABD6}"/>
+                <a16:creationId xmlns:a16="http://schemas.microsoft.com/office/drawing/2014/main" id="{6F833499-8758-4AA5-A009-8A06E7DB1A56}"/>
               </a:ext>
             </a:extLst>
           </p:cNvPr>
@@ -1587,7 +1587,7 @@
           <p:cNvPr id="3" name="">
             <a:extLst xmlns:a="http://schemas.openxmlformats.org/drawingml/2006/main">
               <a:ext uri="{FF2B5EF4-FFF2-40B4-BE49-F238E27FC236}">
-                <a16:creationId xmlns:a16="http://schemas.microsoft.com/office/drawing/2014/main" id="{D5D85B0A-1F82-43E1-AFEC-91B847C5B6FA}"/>
+                <a16:creationId xmlns:a16="http://schemas.microsoft.com/office/drawing/2014/main" id="{D3AB8801-E00D-402A-9A6C-C425CA17CF90}"/>
               </a:ext>
             </a:extLst>
           </p:cNvPr>
@@ -1620,7 +1620,7 @@
           <p:cNvPr id="4" name="">
             <a:extLst xmlns:a="http://schemas.openxmlformats.org/drawingml/2006/main">
               <a:ext uri="{FF2B5EF4-FFF2-40B4-BE49-F238E27FC236}">
-                <a16:creationId xmlns:a16="http://schemas.microsoft.com/office/drawing/2014/main" id="{3C10A808-8A08-4E64-BD20-2AB1576D5AE6}"/>
+                <a16:creationId xmlns:a16="http://schemas.microsoft.com/office/drawing/2014/main" id="{8326B2A0-36F6-4E50-AF11-E9768BE93C3B}"/>
               </a:ext>
             </a:extLst>
           </p:cNvPr>
@@ -1660,7 +1660,7 @@
                   <a:srgbClr val="111111"/>
                 </a:solidFill>
               </a:rPr>
-              <a:t>2</a:t>
+              <a:t>3</a:t>
             </a:r>
           </a:p>
         </p:txBody>
@@ -1670,7 +1670,7 @@
           <p:cNvPr id="5" name="">
             <a:extLst xmlns:a="http://schemas.openxmlformats.org/drawingml/2006/main">
               <a:ext uri="{FF2B5EF4-FFF2-40B4-BE49-F238E27FC236}">
-                <a16:creationId xmlns:a16="http://schemas.microsoft.com/office/drawing/2014/main" id="{0D1510E5-DB03-4E99-9C26-AAD4B6B14B49}"/>
+                <a16:creationId xmlns:a16="http://schemas.microsoft.com/office/drawing/2014/main" id="{76E3DB91-3168-476F-96C3-33DAD89F929E}"/>
               </a:ext>
             </a:extLst>
           </p:cNvPr>
@@ -1720,7 +1720,7 @@
           <p:cNvPr id="6" name="">
             <a:extLst xmlns:a="http://schemas.openxmlformats.org/drawingml/2006/main">
               <a:ext uri="{FF2B5EF4-FFF2-40B4-BE49-F238E27FC236}">
-                <a16:creationId xmlns:a16="http://schemas.microsoft.com/office/drawing/2014/main" id="{43F61B74-0BEF-4402-9220-69D01F550E36}"/>
+                <a16:creationId xmlns:a16="http://schemas.microsoft.com/office/drawing/2014/main" id="{1B0FFD92-EC8D-4EDF-968E-32A9E996901E}"/>
               </a:ext>
             </a:extLst>
           </p:cNvPr>
@@ -1753,7 +1753,7 @@
           <p:cNvPr id="7" name="">
             <a:extLst xmlns:a="http://schemas.openxmlformats.org/drawingml/2006/main">
               <a:ext uri="{FF2B5EF4-FFF2-40B4-BE49-F238E27FC236}">
-                <a16:creationId xmlns:a16="http://schemas.microsoft.com/office/drawing/2014/main" id="{30666043-6205-48F8-A1BB-AE841FFC7A2C}"/>
+                <a16:creationId xmlns:a16="http://schemas.microsoft.com/office/drawing/2014/main" id="{749108A8-ADB0-4037-9911-BAA9A0EF25F8}"/>
               </a:ext>
             </a:extLst>
           </p:cNvPr>
@@ -1793,7 +1793,7 @@
                   <a:srgbClr val="111111"/>
                 </a:solidFill>
               </a:rPr>
-              <a:t>0</a:t>
+              <a:t>1</a:t>
             </a:r>
           </a:p>
         </p:txBody>
@@ -1803,7 +1803,7 @@
           <p:cNvPr id="8" name="">
             <a:extLst xmlns:a="http://schemas.openxmlformats.org/drawingml/2006/main">
               <a:ext uri="{FF2B5EF4-FFF2-40B4-BE49-F238E27FC236}">
-                <a16:creationId xmlns:a16="http://schemas.microsoft.com/office/drawing/2014/main" id="{0FA897C3-DB9B-49A4-9748-3DC3B5936C75}"/>
+                <a16:creationId xmlns:a16="http://schemas.microsoft.com/office/drawing/2014/main" id="{9509BC83-4A47-4C7F-BA2E-8E08B89483F4}"/>
               </a:ext>
             </a:extLst>
           </p:cNvPr>
@@ -1853,7 +1853,7 @@
           <p:cNvPr id="9" name="">
             <a:extLst xmlns:a="http://schemas.openxmlformats.org/drawingml/2006/main">
               <a:ext uri="{FF2B5EF4-FFF2-40B4-BE49-F238E27FC236}">
-                <a16:creationId xmlns:a16="http://schemas.microsoft.com/office/drawing/2014/main" id="{351AB3DE-4808-409D-A5A9-BBD41A6E837A}"/>
+                <a16:creationId xmlns:a16="http://schemas.microsoft.com/office/drawing/2014/main" id="{6CB88E03-F659-4039-A603-3E433C02A80E}"/>
               </a:ext>
             </a:extLst>
           </p:cNvPr>
@@ -1886,7 +1886,7 @@
           <p:cNvPr id="10" name="">
             <a:extLst xmlns:a="http://schemas.openxmlformats.org/drawingml/2006/main">
               <a:ext uri="{FF2B5EF4-FFF2-40B4-BE49-F238E27FC236}">
-                <a16:creationId xmlns:a16="http://schemas.microsoft.com/office/drawing/2014/main" id="{5EA2B784-0955-4F53-AB48-C88EBFB9712B}"/>
+                <a16:creationId xmlns:a16="http://schemas.microsoft.com/office/drawing/2014/main" id="{4ED74D12-FE8C-4270-8A4D-1470F851277C}"/>
               </a:ext>
             </a:extLst>
           </p:cNvPr>
@@ -1936,7 +1936,7 @@
           <p:cNvPr id="11" name="">
             <a:extLst xmlns:a="http://schemas.openxmlformats.org/drawingml/2006/main">
               <a:ext uri="{FF2B5EF4-FFF2-40B4-BE49-F238E27FC236}">
-                <a16:creationId xmlns:a16="http://schemas.microsoft.com/office/drawing/2014/main" id="{7EAAB6E2-59DB-4F05-83D7-D029841C6106}"/>
+                <a16:creationId xmlns:a16="http://schemas.microsoft.com/office/drawing/2014/main" id="{B248AFDC-9B35-4B35-A246-B71B4620042F}"/>
               </a:ext>
             </a:extLst>
           </p:cNvPr>
@@ -1986,7 +1986,7 @@
           <p:cNvPr id="12" name="">
             <a:extLst xmlns:a="http://schemas.openxmlformats.org/drawingml/2006/main">
               <a:ext uri="{FF2B5EF4-FFF2-40B4-BE49-F238E27FC236}">
-                <a16:creationId xmlns:a16="http://schemas.microsoft.com/office/drawing/2014/main" id="{667342D4-73FB-4797-87E6-C5E18917E4F1}"/>
+                <a16:creationId xmlns:a16="http://schemas.microsoft.com/office/drawing/2014/main" id="{7060880F-EF85-49FF-BC6E-5D9CB62AEB85}"/>
               </a:ext>
             </a:extLst>
           </p:cNvPr>
@@ -2019,7 +2019,7 @@
           <p:cNvPr id="13" name="">
             <a:extLst xmlns:a="http://schemas.openxmlformats.org/drawingml/2006/main">
               <a:ext uri="{FF2B5EF4-FFF2-40B4-BE49-F238E27FC236}">
-                <a16:creationId xmlns:a16="http://schemas.microsoft.com/office/drawing/2014/main" id="{DE6277D3-5953-4EE9-B69B-B78CB948B28E}"/>
+                <a16:creationId xmlns:a16="http://schemas.microsoft.com/office/drawing/2014/main" id="{4BCC39E8-39B2-4C78-97CC-FB1976CA3617}"/>
               </a:ext>
             </a:extLst>
           </p:cNvPr>
@@ -2069,7 +2069,7 @@
           <p:cNvPr id="14" name="">
             <a:extLst xmlns:a="http://schemas.openxmlformats.org/drawingml/2006/main">
               <a:ext uri="{FF2B5EF4-FFF2-40B4-BE49-F238E27FC236}">
-                <a16:creationId xmlns:a16="http://schemas.microsoft.com/office/drawing/2014/main" id="{CC045AB4-3950-46FE-87A3-A8E212BA586E}"/>
+                <a16:creationId xmlns:a16="http://schemas.microsoft.com/office/drawing/2014/main" id="{F8AD2E71-CFED-40EE-81BA-F3C816213A16}"/>
               </a:ext>
             </a:extLst>
           </p:cNvPr>
@@ -2119,7 +2119,7 @@
           <p:cNvPr id="15" name="">
             <a:extLst xmlns:a="http://schemas.openxmlformats.org/drawingml/2006/main">
               <a:ext uri="{FF2B5EF4-FFF2-40B4-BE49-F238E27FC236}">
-                <a16:creationId xmlns:a16="http://schemas.microsoft.com/office/drawing/2014/main" id="{F78C036D-E385-4155-B1BF-18093856510D}"/>
+                <a16:creationId xmlns:a16="http://schemas.microsoft.com/office/drawing/2014/main" id="{37C203CD-7F62-4F5A-A653-430B1981D3ED}"/>
               </a:ext>
             </a:extLst>
           </p:cNvPr>
@@ -2152,7 +2152,7 @@
           <p:cNvPr id="16" name="">
             <a:extLst xmlns:a="http://schemas.openxmlformats.org/drawingml/2006/main">
               <a:ext uri="{FF2B5EF4-FFF2-40B4-BE49-F238E27FC236}">
-                <a16:creationId xmlns:a16="http://schemas.microsoft.com/office/drawing/2014/main" id="{B6CAAD41-6EA3-495D-A721-9F220610C10A}"/>
+                <a16:creationId xmlns:a16="http://schemas.microsoft.com/office/drawing/2014/main" id="{C9C3FE92-FF2D-411D-845E-46A35B047539}"/>
               </a:ext>
             </a:extLst>
           </p:cNvPr>
@@ -2192,7 +2192,7 @@
                   <a:srgbClr val="111111"/>
                 </a:solidFill>
               </a:rPr>
-              <a:t>100% of analyzed views are currently red, which indicates that schedule recovery and execution control need executive attention before the next client reporting cycle.</a:t>
+              <a:t>66.7% of analyzed views are currently red, which indicates that schedule recovery and execution control need executive attention before the next client reporting cycle.</a:t>
             </a:r>
           </a:p>
         </p:txBody>
@@ -2202,7 +2202,7 @@
           <p:cNvPr id="17" name="">
             <a:extLst xmlns:a="http://schemas.openxmlformats.org/drawingml/2006/main">
               <a:ext uri="{FF2B5EF4-FFF2-40B4-BE49-F238E27FC236}">
-                <a16:creationId xmlns:a16="http://schemas.microsoft.com/office/drawing/2014/main" id="{97578AC3-ABD8-4FC9-B769-7AC9189909E6}"/>
+                <a16:creationId xmlns:a16="http://schemas.microsoft.com/office/drawing/2014/main" id="{EF2AE0DE-70F3-4672-947F-4A3C2ABB9B5A}"/>
               </a:ext>
             </a:extLst>
           </p:cNvPr>
@@ -2235,7 +2235,7 @@
           <p:cNvPr id="18" name="">
             <a:extLst xmlns:a="http://schemas.openxmlformats.org/drawingml/2006/main">
               <a:ext uri="{FF2B5EF4-FFF2-40B4-BE49-F238E27FC236}">
-                <a16:creationId xmlns:a16="http://schemas.microsoft.com/office/drawing/2014/main" id="{043862A7-6A6C-4B5B-8ECB-D8E1C6557942}"/>
+                <a16:creationId xmlns:a16="http://schemas.microsoft.com/office/drawing/2014/main" id="{2AC22219-3FAC-4DB0-B266-D9D5EA55D203}"/>
               </a:ext>
             </a:extLst>
           </p:cNvPr>
@@ -2285,7 +2285,7 @@
           <p:cNvPr id="19" name="">
             <a:extLst xmlns:a="http://schemas.openxmlformats.org/drawingml/2006/main">
               <a:ext uri="{FF2B5EF4-FFF2-40B4-BE49-F238E27FC236}">
-                <a16:creationId xmlns:a16="http://schemas.microsoft.com/office/drawing/2014/main" id="{9B12AA66-8EAD-4163-B143-77B80F9304CE}"/>
+                <a16:creationId xmlns:a16="http://schemas.microsoft.com/office/drawing/2014/main" id="{3A374A8F-1E3E-47C7-B162-BA6F9FA42126}"/>
               </a:ext>
             </a:extLst>
           </p:cNvPr>
@@ -2325,7 +2325,7 @@
                   <a:srgbClr val="111111"/>
                 </a:solidFill>
               </a:rPr>
-              <a:t>Risk is the most common lead driver.</a:t>
+              <a:t>Schedule is the most common lead driver.</a:t>
             </a:r>
           </a:p>
           <a:p xmlns:a="http://schemas.openxmlformats.org/drawingml/2006/main">
@@ -2347,7 +2347,7 @@
                   <a:srgbClr val="111111"/>
                 </a:solidFill>
               </a:rPr>
-              <a:t>Schedule pressure is the next-most common concern across the current plans.</a:t>
+              <a:t>Milestone pressure is the next-most common concern across the current plans.</a:t>
             </a:r>
           </a:p>
           <a:p xmlns:a="http://schemas.openxmlformats.org/drawingml/2006/main">
@@ -2369,7 +2369,7 @@
                   <a:srgbClr val="111111"/>
                 </a:solidFill>
               </a:rPr>
-              <a:t>UniSan S2P implementation remains red and should stay on the next escalation review list.</a:t>
+              <a:t>CRM Upgrade remains red and should stay on the next escalation review list.</a:t>
             </a:r>
           </a:p>
         </p:txBody>
@@ -2379,7 +2379,7 @@
           <p:cNvPr id="20" name="">
             <a:extLst xmlns:a="http://schemas.openxmlformats.org/drawingml/2006/main">
               <a:ext uri="{FF2B5EF4-FFF2-40B4-BE49-F238E27FC236}">
-                <a16:creationId xmlns:a16="http://schemas.microsoft.com/office/drawing/2014/main" id="{32C9B8A1-5706-457D-928C-5E6F517CC2B4}"/>
+                <a16:creationId xmlns:a16="http://schemas.microsoft.com/office/drawing/2014/main" id="{828E7153-1852-4C0C-8EDF-084EED16B872}"/>
               </a:ext>
             </a:extLst>
           </p:cNvPr>
@@ -2427,7 +2427,7 @@
     </p:spTree>
     <p:extLst>
       <p:ext uri="{BB962C8B-B14F-4D97-AF65-F5344CB8AC3E}">
-        <p14:creationId xmlns:p14="http://schemas.microsoft.com/office/powerpoint/2010/main" val="534806886"/>
+        <p14:creationId xmlns:p14="http://schemas.microsoft.com/office/powerpoint/2010/main" val="668411986"/>
       </p:ext>
     </p:extLst>
   </p:cSld>
@@ -2458,7 +2458,7 @@
           <p:cNvPr id="1" name="">
             <a:extLst xmlns:a="http://schemas.openxmlformats.org/drawingml/2006/main">
               <a:ext uri="{FF2B5EF4-FFF2-40B4-BE49-F238E27FC236}">
-                <a16:creationId xmlns:a16="http://schemas.microsoft.com/office/drawing/2014/main" id="{40AB7601-964A-49C2-8731-687B6025F4D0}"/>
+                <a16:creationId xmlns:a16="http://schemas.microsoft.com/office/drawing/2014/main" id="{7EDA2381-03F1-4675-A05B-10EF0055B0B5}"/>
               </a:ext>
             </a:extLst>
           </p:cNvPr>
@@ -2508,7 +2508,7 @@
           <p:cNvPr id="2" name="">
             <a:extLst xmlns:a="http://schemas.openxmlformats.org/drawingml/2006/main">
               <a:ext uri="{FF2B5EF4-FFF2-40B4-BE49-F238E27FC236}">
-                <a16:creationId xmlns:a16="http://schemas.microsoft.com/office/drawing/2014/main" id="{EC97A506-0714-4059-9EDF-687CC0CFEB2E}"/>
+                <a16:creationId xmlns:a16="http://schemas.microsoft.com/office/drawing/2014/main" id="{8AE3CBAB-5FE0-4BF8-A6D9-B09C8E786D0F}"/>
               </a:ext>
             </a:extLst>
           </p:cNvPr>
@@ -2558,7 +2558,7 @@
           <p:cNvPr id="3" name="">
             <a:extLst xmlns:a="http://schemas.openxmlformats.org/drawingml/2006/main">
               <a:ext uri="{FF2B5EF4-FFF2-40B4-BE49-F238E27FC236}">
-                <a16:creationId xmlns:a16="http://schemas.microsoft.com/office/drawing/2014/main" id="{53C8FFD4-F7AB-4175-8944-B1AF2E1FE82D}"/>
+                <a16:creationId xmlns:a16="http://schemas.microsoft.com/office/drawing/2014/main" id="{01DD9BAD-4C8C-4612-A130-8E6713554C44}"/>
               </a:ext>
             </a:extLst>
           </p:cNvPr>
@@ -2591,7 +2591,7 @@
           <p:cNvPr id="4" name="">
             <a:extLst xmlns:a="http://schemas.openxmlformats.org/drawingml/2006/main">
               <a:ext uri="{FF2B5EF4-FFF2-40B4-BE49-F238E27FC236}">
-                <a16:creationId xmlns:a16="http://schemas.microsoft.com/office/drawing/2014/main" id="{B6225A4D-4BA4-43B7-9D76-E451F3DC27AE}"/>
+                <a16:creationId xmlns:a16="http://schemas.microsoft.com/office/drawing/2014/main" id="{60F46B7D-3AC5-4B58-A117-92399CBF7131}"/>
               </a:ext>
             </a:extLst>
           </p:cNvPr>
@@ -2641,7 +2641,7 @@
           <p:cNvPr id="5" name="">
             <a:extLst xmlns:a="http://schemas.openxmlformats.org/drawingml/2006/main">
               <a:ext uri="{FF2B5EF4-FFF2-40B4-BE49-F238E27FC236}">
-                <a16:creationId xmlns:a16="http://schemas.microsoft.com/office/drawing/2014/main" id="{3E4C7DD9-19D8-4765-9660-7C3C829D09B8}"/>
+                <a16:creationId xmlns:a16="http://schemas.microsoft.com/office/drawing/2014/main" id="{233788C4-DDDE-4222-B2FC-351B76E4BD6F}"/>
               </a:ext>
             </a:extLst>
           </p:cNvPr>
@@ -2674,7 +2674,7 @@
           <p:cNvPr id="6" name="">
             <a:extLst xmlns:a="http://schemas.openxmlformats.org/drawingml/2006/main">
               <a:ext uri="{FF2B5EF4-FFF2-40B4-BE49-F238E27FC236}">
-                <a16:creationId xmlns:a16="http://schemas.microsoft.com/office/drawing/2014/main" id="{226A8A44-8D83-4657-BAEB-F55035E59778}"/>
+                <a16:creationId xmlns:a16="http://schemas.microsoft.com/office/drawing/2014/main" id="{4E5F5ED0-B230-45F6-8AF5-66CDEF6AB08E}"/>
               </a:ext>
             </a:extLst>
           </p:cNvPr>
@@ -2714,7 +2714,7 @@
                   <a:srgbClr val="111111"/>
                 </a:solidFill>
               </a:rPr>
-              <a:t>0</a:t>
+              <a:t>1</a:t>
             </a:r>
           </a:p>
         </p:txBody>
@@ -2724,7 +2724,7 @@
           <p:cNvPr id="7" name="">
             <a:extLst xmlns:a="http://schemas.openxmlformats.org/drawingml/2006/main">
               <a:ext uri="{FF2B5EF4-FFF2-40B4-BE49-F238E27FC236}">
-                <a16:creationId xmlns:a16="http://schemas.microsoft.com/office/drawing/2014/main" id="{E8ED9A27-F1D8-42C5-8A73-5F9BB1CECE94}"/>
+                <a16:creationId xmlns:a16="http://schemas.microsoft.com/office/drawing/2014/main" id="{D6B6CA71-B609-4143-9B5B-3C99AD80E197}"/>
               </a:ext>
             </a:extLst>
           </p:cNvPr>
@@ -2774,7 +2774,7 @@
           <p:cNvPr id="8" name="">
             <a:extLst xmlns:a="http://schemas.openxmlformats.org/drawingml/2006/main">
               <a:ext uri="{FF2B5EF4-FFF2-40B4-BE49-F238E27FC236}">
-                <a16:creationId xmlns:a16="http://schemas.microsoft.com/office/drawing/2014/main" id="{28F07442-FE62-4549-99F6-EB240C611FA0}"/>
+                <a16:creationId xmlns:a16="http://schemas.microsoft.com/office/drawing/2014/main" id="{D3263FF4-C954-4511-B94C-89A246D6A11A}"/>
               </a:ext>
             </a:extLst>
           </p:cNvPr>
@@ -2807,7 +2807,7 @@
           <p:cNvPr id="9" name="">
             <a:extLst xmlns:a="http://schemas.openxmlformats.org/drawingml/2006/main">
               <a:ext uri="{FF2B5EF4-FFF2-40B4-BE49-F238E27FC236}">
-                <a16:creationId xmlns:a16="http://schemas.microsoft.com/office/drawing/2014/main" id="{AACF83F6-3014-48FE-A480-379742BE9DC3}"/>
+                <a16:creationId xmlns:a16="http://schemas.microsoft.com/office/drawing/2014/main" id="{A379927E-F905-4D61-94E0-AEDA51A32EC4}"/>
               </a:ext>
             </a:extLst>
           </p:cNvPr>
@@ -2857,7 +2857,7 @@
           <p:cNvPr id="10" name="">
             <a:extLst xmlns:a="http://schemas.openxmlformats.org/drawingml/2006/main">
               <a:ext uri="{FF2B5EF4-FFF2-40B4-BE49-F238E27FC236}">
-                <a16:creationId xmlns:a16="http://schemas.microsoft.com/office/drawing/2014/main" id="{6ADFAAD2-6EFA-4C74-A048-8ACA8A63C05E}"/>
+                <a16:creationId xmlns:a16="http://schemas.microsoft.com/office/drawing/2014/main" id="{682AFFE1-5A88-424B-B3A3-B986FD83B64A}"/>
               </a:ext>
             </a:extLst>
           </p:cNvPr>
@@ -2907,7 +2907,7 @@
           <p:cNvPr id="11" name="">
             <a:extLst xmlns:a="http://schemas.openxmlformats.org/drawingml/2006/main">
               <a:ext uri="{FF2B5EF4-FFF2-40B4-BE49-F238E27FC236}">
-                <a16:creationId xmlns:a16="http://schemas.microsoft.com/office/drawing/2014/main" id="{2FB1E99F-133C-423F-A382-35E946699D40}"/>
+                <a16:creationId xmlns:a16="http://schemas.microsoft.com/office/drawing/2014/main" id="{5BBC34AB-1CC5-4F22-8979-214919CD5ACB}"/>
               </a:ext>
             </a:extLst>
           </p:cNvPr>
@@ -2940,7 +2940,7 @@
           <p:cNvPr id="12" name="">
             <a:extLst xmlns:a="http://schemas.openxmlformats.org/drawingml/2006/main">
               <a:ext uri="{FF2B5EF4-FFF2-40B4-BE49-F238E27FC236}">
-                <a16:creationId xmlns:a16="http://schemas.microsoft.com/office/drawing/2014/main" id="{D0A1116C-2792-4D99-80C3-8317C57EAAC2}"/>
+                <a16:creationId xmlns:a16="http://schemas.microsoft.com/office/drawing/2014/main" id="{F80598B4-A5BE-4153-A9CA-6313A0D1F102}"/>
               </a:ext>
             </a:extLst>
           </p:cNvPr>
@@ -2990,7 +2990,7 @@
           <p:cNvPr id="13" name="">
             <a:extLst xmlns:a="http://schemas.openxmlformats.org/drawingml/2006/main">
               <a:ext uri="{FF2B5EF4-FFF2-40B4-BE49-F238E27FC236}">
-                <a16:creationId xmlns:a16="http://schemas.microsoft.com/office/drawing/2014/main" id="{ACEFA37F-B9BB-4A50-965F-1C7F9D3CB277}"/>
+                <a16:creationId xmlns:a16="http://schemas.microsoft.com/office/drawing/2014/main" id="{BCE9F609-1663-48EE-9639-80747A291D7E}"/>
               </a:ext>
             </a:extLst>
           </p:cNvPr>
@@ -3040,7 +3040,7 @@
           <p:cNvPr id="14" name="">
             <a:extLst xmlns:a="http://schemas.openxmlformats.org/drawingml/2006/main">
               <a:ext uri="{FF2B5EF4-FFF2-40B4-BE49-F238E27FC236}">
-                <a16:creationId xmlns:a16="http://schemas.microsoft.com/office/drawing/2014/main" id="{24CB2609-418A-42D5-ABFA-9778EBFF54D4}"/>
+                <a16:creationId xmlns:a16="http://schemas.microsoft.com/office/drawing/2014/main" id="{C7A1FD20-09FD-4F1D-8D67-0BA4B02C12DB}"/>
               </a:ext>
             </a:extLst>
           </p:cNvPr>
@@ -3080,7 +3080,7 @@
                   <a:srgbClr val="111111"/>
                 </a:solidFill>
               </a:rPr>
-              <a:t>2 project plans were analyzed in this run, and every current view is red or amber-weighted enough to need active leadership attention.</a:t>
+              <a:t>3 project plans were analyzed in this run, and every current view is red or amber-weighted enough to need active leadership attention.</a:t>
             </a:r>
           </a:p>
         </p:txBody>
@@ -3090,7 +3090,7 @@
           <p:cNvPr id="15" name="">
             <a:extLst xmlns:a="http://schemas.openxmlformats.org/drawingml/2006/main">
               <a:ext uri="{FF2B5EF4-FFF2-40B4-BE49-F238E27FC236}">
-                <a16:creationId xmlns:a16="http://schemas.microsoft.com/office/drawing/2014/main" id="{471B2214-72FD-48EF-BDB0-75DA99855418}"/>
+                <a16:creationId xmlns:a16="http://schemas.microsoft.com/office/drawing/2014/main" id="{BA12E91A-0931-4E30-95E8-5464D6011FFD}"/>
               </a:ext>
             </a:extLst>
           </p:cNvPr>
@@ -3123,7 +3123,7 @@
           <p:cNvPr id="16" name="">
             <a:extLst xmlns:a="http://schemas.openxmlformats.org/drawingml/2006/main">
               <a:ext uri="{FF2B5EF4-FFF2-40B4-BE49-F238E27FC236}">
-                <a16:creationId xmlns:a16="http://schemas.microsoft.com/office/drawing/2014/main" id="{36B4A8B6-57C6-4B6B-8438-D6CBD1D9D088}"/>
+                <a16:creationId xmlns:a16="http://schemas.microsoft.com/office/drawing/2014/main" id="{1419EF69-1B30-4575-B4BC-7CD433CC4579}"/>
               </a:ext>
             </a:extLst>
           </p:cNvPr>
@@ -3163,7 +3163,7 @@
                   <a:srgbClr val="111111"/>
                 </a:solidFill>
               </a:rPr>
-              <a:t>53/100</a:t>
+              <a:t>62.1/100</a:t>
             </a:r>
           </a:p>
         </p:txBody>
@@ -3173,7 +3173,7 @@
           <p:cNvPr id="17" name="">
             <a:extLst xmlns:a="http://schemas.openxmlformats.org/drawingml/2006/main">
               <a:ext uri="{FF2B5EF4-FFF2-40B4-BE49-F238E27FC236}">
-                <a16:creationId xmlns:a16="http://schemas.microsoft.com/office/drawing/2014/main" id="{691F73EF-856E-42F7-9C4A-E498AF32B516}"/>
+                <a16:creationId xmlns:a16="http://schemas.microsoft.com/office/drawing/2014/main" id="{449A27FA-EE00-4874-96FC-CE493356AA76}"/>
               </a:ext>
             </a:extLst>
           </p:cNvPr>
@@ -3223,7 +3223,7 @@
           <p:cNvPr id="18" name="">
             <a:extLst xmlns:a="http://schemas.openxmlformats.org/drawingml/2006/main">
               <a:ext uri="{FF2B5EF4-FFF2-40B4-BE49-F238E27FC236}">
-                <a16:creationId xmlns:a16="http://schemas.microsoft.com/office/drawing/2014/main" id="{15BC5BE8-438C-442C-B6D9-85C9C6B45821}"/>
+                <a16:creationId xmlns:a16="http://schemas.microsoft.com/office/drawing/2014/main" id="{3E7C9604-7487-411A-B709-1077FD3BD629}"/>
               </a:ext>
             </a:extLst>
           </p:cNvPr>
@@ -3256,7 +3256,7 @@
           <p:cNvPr id="19" name="">
             <a:extLst xmlns:a="http://schemas.openxmlformats.org/drawingml/2006/main">
               <a:ext uri="{FF2B5EF4-FFF2-40B4-BE49-F238E27FC236}">
-                <a16:creationId xmlns:a16="http://schemas.microsoft.com/office/drawing/2014/main" id="{435C3656-619D-47F5-BFE6-467F48589BDA}"/>
+                <a16:creationId xmlns:a16="http://schemas.microsoft.com/office/drawing/2014/main" id="{A3885531-7E19-4A7A-A582-46B28C7D41BE}"/>
               </a:ext>
             </a:extLst>
           </p:cNvPr>
@@ -3296,7 +3296,7 @@
                   <a:srgbClr val="D9481C"/>
                 </a:solidFill>
               </a:rPr>
-              <a:t>50%</a:t>
+              <a:t>67%</a:t>
             </a:r>
           </a:p>
         </p:txBody>
@@ -3306,7 +3306,7 @@
           <p:cNvPr id="20" name="">
             <a:extLst xmlns:a="http://schemas.openxmlformats.org/drawingml/2006/main">
               <a:ext uri="{FF2B5EF4-FFF2-40B4-BE49-F238E27FC236}">
-                <a16:creationId xmlns:a16="http://schemas.microsoft.com/office/drawing/2014/main" id="{73539E5C-2850-4568-9F2C-C2D6EDE20FBA}"/>
+                <a16:creationId xmlns:a16="http://schemas.microsoft.com/office/drawing/2014/main" id="{E1837A2D-CCC8-49BC-8704-E17A2B202DFB}"/>
               </a:ext>
             </a:extLst>
           </p:cNvPr>
@@ -3356,7 +3356,7 @@
           <p:cNvPr id="21" name="">
             <a:extLst xmlns:a="http://schemas.openxmlformats.org/drawingml/2006/main">
               <a:ext uri="{FF2B5EF4-FFF2-40B4-BE49-F238E27FC236}">
-                <a16:creationId xmlns:a16="http://schemas.microsoft.com/office/drawing/2014/main" id="{DF7DB569-E737-4124-BF75-DE2322DF61B6}"/>
+                <a16:creationId xmlns:a16="http://schemas.microsoft.com/office/drawing/2014/main" id="{EF083EEA-1235-4E78-87D1-A5FC37419F40}"/>
               </a:ext>
             </a:extLst>
           </p:cNvPr>
@@ -3396,7 +3396,7 @@
                   <a:srgbClr val="111111"/>
                 </a:solidFill>
               </a:rPr>
-              <a:t>The average score across all 2 analyzed project plans is 53/100. Validation against the embedded workbook health labels holds at 50%, which is directionally useful for leadership screening while keeping the reasoning transparent.</a:t>
+              <a:t>The average score across all 3 analyzed project plans is 62.1/100. Validation against the embedded workbook health labels holds at 67%, which is directionally useful for leadership screening while keeping the reasoning transparent.</a:t>
             </a:r>
           </a:p>
         </p:txBody>
@@ -3406,7 +3406,7 @@
           <p:cNvPr id="22" name="">
             <a:extLst xmlns:a="http://schemas.openxmlformats.org/drawingml/2006/main">
               <a:ext uri="{FF2B5EF4-FFF2-40B4-BE49-F238E27FC236}">
-                <a16:creationId xmlns:a16="http://schemas.microsoft.com/office/drawing/2014/main" id="{B0689360-1243-4ADF-8778-A5DB777E4E58}"/>
+                <a16:creationId xmlns:a16="http://schemas.microsoft.com/office/drawing/2014/main" id="{5C974AFF-4135-4EF9-BD40-3FA203255408}"/>
               </a:ext>
             </a:extLst>
           </p:cNvPr>
@@ -3454,7 +3454,7 @@
     </p:spTree>
     <p:extLst>
       <p:ext uri="{BB962C8B-B14F-4D97-AF65-F5344CB8AC3E}">
-        <p14:creationId xmlns:p14="http://schemas.microsoft.com/office/powerpoint/2010/main" val="60542511"/>
+        <p14:creationId xmlns:p14="http://schemas.microsoft.com/office/powerpoint/2010/main" val="1303688035"/>
       </p:ext>
     </p:extLst>
   </p:cSld>
@@ -3485,7 +3485,7 @@
           <p:cNvPr id="1" name="">
             <a:extLst xmlns:a="http://schemas.openxmlformats.org/drawingml/2006/main">
               <a:ext uri="{FF2B5EF4-FFF2-40B4-BE49-F238E27FC236}">
-                <a16:creationId xmlns:a16="http://schemas.microsoft.com/office/drawing/2014/main" id="{CB20F222-2D80-4E6A-8EF9-C0A6396AB356}"/>
+                <a16:creationId xmlns:a16="http://schemas.microsoft.com/office/drawing/2014/main" id="{ABB406FE-7731-4A86-89EB-C379C05C91A5}"/>
               </a:ext>
             </a:extLst>
           </p:cNvPr>
@@ -3535,7 +3535,7 @@
           <p:cNvPr id="2" name="">
             <a:extLst xmlns:a="http://schemas.openxmlformats.org/drawingml/2006/main">
               <a:ext uri="{FF2B5EF4-FFF2-40B4-BE49-F238E27FC236}">
-                <a16:creationId xmlns:a16="http://schemas.microsoft.com/office/drawing/2014/main" id="{645C06B2-A06E-4D84-93BB-53ED381ACFF0}"/>
+                <a16:creationId xmlns:a16="http://schemas.microsoft.com/office/drawing/2014/main" id="{B530DBA2-08D8-4CCB-920A-53D24CC982E5}"/>
               </a:ext>
             </a:extLst>
           </p:cNvPr>
@@ -3585,7 +3585,7 @@
           <p:cNvPr id="3" name="">
             <a:extLst xmlns:a="http://schemas.openxmlformats.org/drawingml/2006/main">
               <a:ext uri="{FF2B5EF4-FFF2-40B4-BE49-F238E27FC236}">
-                <a16:creationId xmlns:a16="http://schemas.microsoft.com/office/drawing/2014/main" id="{68F7AC64-B2E4-469D-94E5-972605132700}"/>
+                <a16:creationId xmlns:a16="http://schemas.microsoft.com/office/drawing/2014/main" id="{615C9E9B-66B6-4E3F-BFF6-C3991AE7CD86}"/>
               </a:ext>
             </a:extLst>
           </p:cNvPr>
@@ -3618,7 +3618,7 @@
           <p:cNvPr id="4" name="">
             <a:extLst xmlns:a="http://schemas.openxmlformats.org/drawingml/2006/main">
               <a:ext uri="{FF2B5EF4-FFF2-40B4-BE49-F238E27FC236}">
-                <a16:creationId xmlns:a16="http://schemas.microsoft.com/office/drawing/2014/main" id="{D1D94697-AB36-497E-AE83-D22E8C00870E}"/>
+                <a16:creationId xmlns:a16="http://schemas.microsoft.com/office/drawing/2014/main" id="{743A0755-5DC4-4656-9147-83941C829049}"/>
               </a:ext>
             </a:extLst>
           </p:cNvPr>
@@ -3658,7 +3658,7 @@
                   <a:srgbClr val="111111"/>
                 </a:solidFill>
               </a:rPr>
-              <a:t>0</a:t>
+              <a:t>2</a:t>
             </a:r>
           </a:p>
         </p:txBody>
@@ -3668,7 +3668,7 @@
           <p:cNvPr id="5" name="">
             <a:extLst xmlns:a="http://schemas.openxmlformats.org/drawingml/2006/main">
               <a:ext uri="{FF2B5EF4-FFF2-40B4-BE49-F238E27FC236}">
-                <a16:creationId xmlns:a16="http://schemas.microsoft.com/office/drawing/2014/main" id="{7737EC84-C9D6-4920-8C71-C6ACD583ED8B}"/>
+                <a16:creationId xmlns:a16="http://schemas.microsoft.com/office/drawing/2014/main" id="{6E0F6A42-EFDB-4DAF-AD75-3F17AA8A70B5}"/>
               </a:ext>
             </a:extLst>
           </p:cNvPr>
@@ -3718,7 +3718,7 @@
           <p:cNvPr id="6" name="">
             <a:extLst xmlns:a="http://schemas.openxmlformats.org/drawingml/2006/main">
               <a:ext uri="{FF2B5EF4-FFF2-40B4-BE49-F238E27FC236}">
-                <a16:creationId xmlns:a16="http://schemas.microsoft.com/office/drawing/2014/main" id="{7EC1839F-E7F4-4C44-83FB-0600C76D68F0}"/>
+                <a16:creationId xmlns:a16="http://schemas.microsoft.com/office/drawing/2014/main" id="{C4539A0A-55DA-49AB-8348-B67ECD23AAFF}"/>
               </a:ext>
             </a:extLst>
           </p:cNvPr>
@@ -3751,7 +3751,7 @@
           <p:cNvPr id="7" name="">
             <a:extLst xmlns:a="http://schemas.openxmlformats.org/drawingml/2006/main">
               <a:ext uri="{FF2B5EF4-FFF2-40B4-BE49-F238E27FC236}">
-                <a16:creationId xmlns:a16="http://schemas.microsoft.com/office/drawing/2014/main" id="{060A59F1-B380-4D3E-9EBE-00A051959222}"/>
+                <a16:creationId xmlns:a16="http://schemas.microsoft.com/office/drawing/2014/main" id="{683C5CA2-9358-4F78-8C03-43B75C9585A9}"/>
               </a:ext>
             </a:extLst>
           </p:cNvPr>
@@ -3801,7 +3801,7 @@
           <p:cNvPr id="8" name="">
             <a:extLst xmlns:a="http://schemas.openxmlformats.org/drawingml/2006/main">
               <a:ext uri="{FF2B5EF4-FFF2-40B4-BE49-F238E27FC236}">
-                <a16:creationId xmlns:a16="http://schemas.microsoft.com/office/drawing/2014/main" id="{F7B79C7D-E002-4E8F-A379-F5A3288B4F47}"/>
+                <a16:creationId xmlns:a16="http://schemas.microsoft.com/office/drawing/2014/main" id="{B74BE78B-79A5-4539-BCFA-82B35102A879}"/>
               </a:ext>
             </a:extLst>
           </p:cNvPr>
@@ -3851,7 +3851,7 @@
           <p:cNvPr id="9" name="">
             <a:extLst xmlns:a="http://schemas.openxmlformats.org/drawingml/2006/main">
               <a:ext uri="{FF2B5EF4-FFF2-40B4-BE49-F238E27FC236}">
-                <a16:creationId xmlns:a16="http://schemas.microsoft.com/office/drawing/2014/main" id="{BD56CDD2-3025-4758-9F21-863300E86392}"/>
+                <a16:creationId xmlns:a16="http://schemas.microsoft.com/office/drawing/2014/main" id="{085938A7-DE2E-48E5-8F26-B80DDAB50F2D}"/>
               </a:ext>
             </a:extLst>
           </p:cNvPr>
@@ -3884,7 +3884,7 @@
           <p:cNvPr id="10" name="">
             <a:extLst xmlns:a="http://schemas.openxmlformats.org/drawingml/2006/main">
               <a:ext uri="{FF2B5EF4-FFF2-40B4-BE49-F238E27FC236}">
-                <a16:creationId xmlns:a16="http://schemas.microsoft.com/office/drawing/2014/main" id="{6BE64D20-EB08-4A62-ADCE-CC8A29A3023D}"/>
+                <a16:creationId xmlns:a16="http://schemas.microsoft.com/office/drawing/2014/main" id="{F3439A7E-B42D-45A8-BDBB-850FCB908216}"/>
               </a:ext>
             </a:extLst>
           </p:cNvPr>
@@ -3924,7 +3924,7 @@
                   <a:srgbClr val="111111"/>
                 </a:solidFill>
               </a:rPr>
-              <a:t>2</a:t>
+              <a:t>1</a:t>
             </a:r>
           </a:p>
         </p:txBody>
@@ -3934,7 +3934,7 @@
           <p:cNvPr id="11" name="">
             <a:extLst xmlns:a="http://schemas.openxmlformats.org/drawingml/2006/main">
               <a:ext uri="{FF2B5EF4-FFF2-40B4-BE49-F238E27FC236}">
-                <a16:creationId xmlns:a16="http://schemas.microsoft.com/office/drawing/2014/main" id="{55C8B4DA-589F-453E-853F-8F546BA9A93A}"/>
+                <a16:creationId xmlns:a16="http://schemas.microsoft.com/office/drawing/2014/main" id="{761C5E63-C403-4D64-A374-A88B8C38DF6D}"/>
               </a:ext>
             </a:extLst>
           </p:cNvPr>
@@ -3984,7 +3984,7 @@
           <p:cNvPr id="12" name="">
             <a:extLst xmlns:a="http://schemas.openxmlformats.org/drawingml/2006/main">
               <a:ext uri="{FF2B5EF4-FFF2-40B4-BE49-F238E27FC236}">
-                <a16:creationId xmlns:a16="http://schemas.microsoft.com/office/drawing/2014/main" id="{54414D61-FC6E-4528-8480-0AF72EE84104}"/>
+                <a16:creationId xmlns:a16="http://schemas.microsoft.com/office/drawing/2014/main" id="{02B71FAE-E558-4B13-B49D-3CC926192010}"/>
               </a:ext>
             </a:extLst>
           </p:cNvPr>
@@ -4017,7 +4017,7 @@
           <p:cNvPr id="13" name="">
             <a:extLst xmlns:a="http://schemas.openxmlformats.org/drawingml/2006/main">
               <a:ext uri="{FF2B5EF4-FFF2-40B4-BE49-F238E27FC236}">
-                <a16:creationId xmlns:a16="http://schemas.microsoft.com/office/drawing/2014/main" id="{7D87F481-1E90-4E2D-B0C9-0A7FF0509E4A}"/>
+                <a16:creationId xmlns:a16="http://schemas.microsoft.com/office/drawing/2014/main" id="{DA2073F2-C82A-4D2E-B37C-71A3EAFCC48B}"/>
               </a:ext>
             </a:extLst>
           </p:cNvPr>
@@ -4057,7 +4057,7 @@
                   <a:srgbClr val="111111"/>
                 </a:solidFill>
               </a:rPr>
-              <a:t>0</a:t>
+              <a:t>2</a:t>
             </a:r>
           </a:p>
         </p:txBody>
@@ -4067,7 +4067,7 @@
           <p:cNvPr id="14" name="">
             <a:extLst xmlns:a="http://schemas.openxmlformats.org/drawingml/2006/main">
               <a:ext uri="{FF2B5EF4-FFF2-40B4-BE49-F238E27FC236}">
-                <a16:creationId xmlns:a16="http://schemas.microsoft.com/office/drawing/2014/main" id="{104C4A53-B233-4466-B37F-AEB34F612D23}"/>
+                <a16:creationId xmlns:a16="http://schemas.microsoft.com/office/drawing/2014/main" id="{2ED30618-1504-4462-820A-F7E53E09C7E7}"/>
               </a:ext>
             </a:extLst>
           </p:cNvPr>
@@ -4117,7 +4117,7 @@
           <p:cNvPr id="15" name="">
             <a:extLst xmlns:a="http://schemas.openxmlformats.org/drawingml/2006/main">
               <a:ext uri="{FF2B5EF4-FFF2-40B4-BE49-F238E27FC236}">
-                <a16:creationId xmlns:a16="http://schemas.microsoft.com/office/drawing/2014/main" id="{9777CA67-F63B-4E78-B9AC-AE3E851831C4}"/>
+                <a16:creationId xmlns:a16="http://schemas.microsoft.com/office/drawing/2014/main" id="{34046990-F428-400A-B255-2087138D8DA1}"/>
               </a:ext>
             </a:extLst>
           </p:cNvPr>
@@ -4150,7 +4150,7 @@
           <p:cNvPr id="16" name="">
             <a:extLst xmlns:a="http://schemas.openxmlformats.org/drawingml/2006/main">
               <a:ext uri="{FF2B5EF4-FFF2-40B4-BE49-F238E27FC236}">
-                <a16:creationId xmlns:a16="http://schemas.microsoft.com/office/drawing/2014/main" id="{7B7D92D1-633A-4662-8167-F9FD32786715}"/>
+                <a16:creationId xmlns:a16="http://schemas.microsoft.com/office/drawing/2014/main" id="{9F4A0770-59FC-401B-8461-FDD891363CAC}"/>
               </a:ext>
             </a:extLst>
           </p:cNvPr>
@@ -4200,7 +4200,7 @@
           <p:cNvPr id="17" name="">
             <a:extLst xmlns:a="http://schemas.openxmlformats.org/drawingml/2006/main">
               <a:ext uri="{FF2B5EF4-FFF2-40B4-BE49-F238E27FC236}">
-                <a16:creationId xmlns:a16="http://schemas.microsoft.com/office/drawing/2014/main" id="{A441B762-442C-4948-82C9-9BEBDDB4727C}"/>
+                <a16:creationId xmlns:a16="http://schemas.microsoft.com/office/drawing/2014/main" id="{A9CA6DB2-1BE0-464F-A3D1-BCCED8ED5FCC}"/>
               </a:ext>
             </a:extLst>
           </p:cNvPr>
@@ -4240,7 +4240,7 @@
                   <a:srgbClr val="111111"/>
                 </a:solidFill>
               </a:rPr>
-              <a:t>1 projects are already more than two weeks behind, and 0 are spending ahead of delivery progress.</a:t>
+              <a:t>1 projects are already more than two weeks behind, and 2 are spending ahead of delivery progress.</a:t>
             </a:r>
           </a:p>
           <a:p xmlns:a="http://schemas.openxmlformats.org/drawingml/2006/main">
@@ -4262,7 +4262,7 @@
                   <a:srgbClr val="111111"/>
                 </a:solidFill>
               </a:rPr>
-              <a:t>0 projects also carry two or more critical blockers, which means the schedule risk is likely to stay elevated unless escalation gets faster.</a:t>
+              <a:t>1 projects also carry two or more critical blockers, which means the schedule risk is likely to stay elevated unless escalation gets faster.</a:t>
             </a:r>
           </a:p>
           <a:p xmlns:a="http://schemas.openxmlformats.org/drawingml/2006/main">
@@ -4294,7 +4294,7 @@
           <p:cNvPr id="18" name="">
             <a:extLst xmlns:a="http://schemas.openxmlformats.org/drawingml/2006/main">
               <a:ext uri="{FF2B5EF4-FFF2-40B4-BE49-F238E27FC236}">
-                <a16:creationId xmlns:a16="http://schemas.microsoft.com/office/drawing/2014/main" id="{B7570D65-573E-4F97-BAE2-E7E39452592B}"/>
+                <a16:creationId xmlns:a16="http://schemas.microsoft.com/office/drawing/2014/main" id="{04AF907C-5C02-4461-A42F-55510A15B2BE}"/>
               </a:ext>
             </a:extLst>
           </p:cNvPr>
@@ -4342,7 +4342,7 @@
     </p:spTree>
     <p:extLst>
       <p:ext uri="{BB962C8B-B14F-4D97-AF65-F5344CB8AC3E}">
-        <p14:creationId xmlns:p14="http://schemas.microsoft.com/office/powerpoint/2010/main" val="235180324"/>
+        <p14:creationId xmlns:p14="http://schemas.microsoft.com/office/powerpoint/2010/main" val="545443733"/>
       </p:ext>
     </p:extLst>
   </p:cSld>
@@ -4373,7 +4373,7 @@
           <p:cNvPr id="1" name="">
             <a:extLst xmlns:a="http://schemas.openxmlformats.org/drawingml/2006/main">
               <a:ext uri="{FF2B5EF4-FFF2-40B4-BE49-F238E27FC236}">
-                <a16:creationId xmlns:a16="http://schemas.microsoft.com/office/drawing/2014/main" id="{1CE2C505-7D32-432F-9A9E-915A477D9816}"/>
+                <a16:creationId xmlns:a16="http://schemas.microsoft.com/office/drawing/2014/main" id="{F167B432-ED01-4633-92D4-95DC6227693A}"/>
               </a:ext>
             </a:extLst>
           </p:cNvPr>
@@ -4423,7 +4423,7 @@
           <p:cNvPr id="2" name="">
             <a:extLst xmlns:a="http://schemas.openxmlformats.org/drawingml/2006/main">
               <a:ext uri="{FF2B5EF4-FFF2-40B4-BE49-F238E27FC236}">
-                <a16:creationId xmlns:a16="http://schemas.microsoft.com/office/drawing/2014/main" id="{098D87C4-8B92-43AA-BAF7-722675B94EFD}"/>
+                <a16:creationId xmlns:a16="http://schemas.microsoft.com/office/drawing/2014/main" id="{EE7CD353-3957-40F2-99B1-424698345602}"/>
               </a:ext>
             </a:extLst>
           </p:cNvPr>
@@ -4564,7 +4564,7 @@
                             <a:srgbClr val="111111"/>
                           </a:solidFill>
                         </a:rPr>
-                        <a:t>Zycus - UniSan S2P Implementation</a:t>
+                        <a:t>CRM Upgrade</a:t>
                       </a:r>
                     </a:p>
                   </a:txBody>
@@ -4581,7 +4581,7 @@
                             <a:srgbClr val="111111"/>
                           </a:solidFill>
                         </a:rPr>
-                        <a:t>68.1</a:t>
+                        <a:t>91.1</a:t>
                       </a:r>
                     </a:p>
                   </a:txBody>
@@ -4598,7 +4598,7 @@
                             <a:srgbClr val="111111"/>
                           </a:solidFill>
                         </a:rPr>
-                        <a:t>About 61% of the plan duration has elapsed, while blended progress is 44% and 22% of due tasks are still incomplete</a:t>
+                        <a:t>Progress trails plan by 26 points and the project is 18 days behind schedule</a:t>
                       </a:r>
                     </a:p>
                   </a:txBody>
@@ -4617,7 +4617,7 @@
                             <a:srgbClr val="111111"/>
                           </a:solidFill>
                         </a:rPr>
-                        <a:t>Zycus - Titan S2P Implementation</a:t>
+                        <a:t>ERP Migration</a:t>
                       </a:r>
                     </a:p>
                   </a:txBody>
@@ -4634,7 +4634,7 @@
                             <a:srgbClr val="111111"/>
                           </a:solidFill>
                         </a:rPr>
-                        <a:t>38</a:t>
+                        <a:t>74.4</a:t>
                       </a:r>
                     </a:p>
                   </a:txBody>
@@ -4651,7 +4651,7 @@
                             <a:srgbClr val="111111"/>
                           </a:solidFill>
                         </a:rPr>
-                        <a:t>The plan carries 16 critical risks and 24 high risks</a:t>
+                        <a:t>Progress trails plan by 15 points and the project is 12 days behind schedule</a:t>
                       </a:r>
                     </a:p>
                   </a:txBody>
@@ -4667,7 +4667,7 @@
           <p:cNvPr id="4" name="">
             <a:extLst xmlns:a="http://schemas.openxmlformats.org/drawingml/2006/main">
               <a:ext uri="{FF2B5EF4-FFF2-40B4-BE49-F238E27FC236}">
-                <a16:creationId xmlns:a16="http://schemas.microsoft.com/office/drawing/2014/main" id="{113E4159-F180-4673-BA47-F17A7F555F10}"/>
+                <a16:creationId xmlns:a16="http://schemas.microsoft.com/office/drawing/2014/main" id="{48DFAAF1-97D9-416E-A5A7-33DE583C4CF5}"/>
               </a:ext>
             </a:extLst>
           </p:cNvPr>
@@ -4717,7 +4717,7 @@
           <p:cNvPr id="5" name="">
             <a:extLst xmlns:a="http://schemas.openxmlformats.org/drawingml/2006/main">
               <a:ext uri="{FF2B5EF4-FFF2-40B4-BE49-F238E27FC236}">
-                <a16:creationId xmlns:a16="http://schemas.microsoft.com/office/drawing/2014/main" id="{3D876D3F-96AF-4584-A331-B457B127A3D8}"/>
+                <a16:creationId xmlns:a16="http://schemas.microsoft.com/office/drawing/2014/main" id="{463BA8A1-2263-4D06-A76A-4844837D876E}"/>
               </a:ext>
             </a:extLst>
           </p:cNvPr>
@@ -4765,7 +4765,7 @@
     </p:spTree>
     <p:extLst>
       <p:ext uri="{BB962C8B-B14F-4D97-AF65-F5344CB8AC3E}">
-        <p14:creationId xmlns:p14="http://schemas.microsoft.com/office/powerpoint/2010/main" val="1603940003"/>
+        <p14:creationId xmlns:p14="http://schemas.microsoft.com/office/powerpoint/2010/main" val="904876465"/>
       </p:ext>
     </p:extLst>
   </p:cSld>
@@ -4796,7 +4796,7 @@
           <p:cNvPr id="1" name="">
             <a:extLst xmlns:a="http://schemas.openxmlformats.org/drawingml/2006/main">
               <a:ext uri="{FF2B5EF4-FFF2-40B4-BE49-F238E27FC236}">
-                <a16:creationId xmlns:a16="http://schemas.microsoft.com/office/drawing/2014/main" id="{0C158679-828D-499F-BF5A-3711BA469F59}"/>
+                <a16:creationId xmlns:a16="http://schemas.microsoft.com/office/drawing/2014/main" id="{C705EA5A-EA5F-4603-BBE7-8272E3F31CE5}"/>
               </a:ext>
             </a:extLst>
           </p:cNvPr>
@@ -4846,7 +4846,7 @@
           <p:cNvPr id="2" name="">
             <a:extLst xmlns:a="http://schemas.openxmlformats.org/drawingml/2006/main">
               <a:ext uri="{FF2B5EF4-FFF2-40B4-BE49-F238E27FC236}">
-                <a16:creationId xmlns:a16="http://schemas.microsoft.com/office/drawing/2014/main" id="{E54064D8-406B-48EE-9374-4C0686783CA4}"/>
+                <a16:creationId xmlns:a16="http://schemas.microsoft.com/office/drawing/2014/main" id="{DBD426AA-6DA0-4D72-889C-175BD70734E5}"/>
               </a:ext>
             </a:extLst>
           </p:cNvPr>
@@ -4896,7 +4896,7 @@
           <p:cNvPr id="3" name="">
             <a:extLst xmlns:a="http://schemas.openxmlformats.org/drawingml/2006/main">
               <a:ext uri="{FF2B5EF4-FFF2-40B4-BE49-F238E27FC236}">
-                <a16:creationId xmlns:a16="http://schemas.microsoft.com/office/drawing/2014/main" id="{93139DA9-3632-4AC1-A470-E8D8E9FA0643}"/>
+                <a16:creationId xmlns:a16="http://schemas.microsoft.com/office/drawing/2014/main" id="{68249BD0-F641-4942-B40F-397CE32D717B}"/>
               </a:ext>
             </a:extLst>
           </p:cNvPr>
@@ -4929,7 +4929,7 @@
           <p:cNvPr id="4" name="">
             <a:extLst xmlns:a="http://schemas.openxmlformats.org/drawingml/2006/main">
               <a:ext uri="{FF2B5EF4-FFF2-40B4-BE49-F238E27FC236}">
-                <a16:creationId xmlns:a16="http://schemas.microsoft.com/office/drawing/2014/main" id="{35151922-0D8C-49B4-AA8B-DA24A6E9B8DE}"/>
+                <a16:creationId xmlns:a16="http://schemas.microsoft.com/office/drawing/2014/main" id="{33EBDC5C-80B1-492C-BB89-2DAAD8F46272}"/>
               </a:ext>
             </a:extLst>
           </p:cNvPr>
@@ -4979,7 +4979,7 @@
           <p:cNvPr id="5" name="">
             <a:extLst xmlns:a="http://schemas.openxmlformats.org/drawingml/2006/main">
               <a:ext uri="{FF2B5EF4-FFF2-40B4-BE49-F238E27FC236}">
-                <a16:creationId xmlns:a16="http://schemas.microsoft.com/office/drawing/2014/main" id="{759A8D5A-2CAD-4A11-949C-A5D364A3D350}"/>
+                <a16:creationId xmlns:a16="http://schemas.microsoft.com/office/drawing/2014/main" id="{C0434819-9B71-408D-A868-E23736B19B06}"/>
               </a:ext>
             </a:extLst>
           </p:cNvPr>
@@ -5029,7 +5029,7 @@
           <p:cNvPr id="6" name="">
             <a:extLst xmlns:a="http://schemas.openxmlformats.org/drawingml/2006/main">
               <a:ext uri="{FF2B5EF4-FFF2-40B4-BE49-F238E27FC236}">
-                <a16:creationId xmlns:a16="http://schemas.microsoft.com/office/drawing/2014/main" id="{E6CFA521-94AB-4148-ADCD-13ED5B31BE3D}"/>
+                <a16:creationId xmlns:a16="http://schemas.microsoft.com/office/drawing/2014/main" id="{EFDBFD05-41AA-4EB0-A692-42789BD33035}"/>
               </a:ext>
             </a:extLst>
           </p:cNvPr>
@@ -5079,7 +5079,7 @@
           <p:cNvPr id="7" name="">
             <a:extLst xmlns:a="http://schemas.openxmlformats.org/drawingml/2006/main">
               <a:ext uri="{FF2B5EF4-FFF2-40B4-BE49-F238E27FC236}">
-                <a16:creationId xmlns:a16="http://schemas.microsoft.com/office/drawing/2014/main" id="{EF6AC1D6-15A2-4AD5-92E0-562D196AD369}"/>
+                <a16:creationId xmlns:a16="http://schemas.microsoft.com/office/drawing/2014/main" id="{815EEEFA-7847-44A8-98DD-DF0A170C615B}"/>
               </a:ext>
             </a:extLst>
           </p:cNvPr>
@@ -5112,7 +5112,7 @@
           <p:cNvPr id="8" name="">
             <a:extLst xmlns:a="http://schemas.openxmlformats.org/drawingml/2006/main">
               <a:ext uri="{FF2B5EF4-FFF2-40B4-BE49-F238E27FC236}">
-                <a16:creationId xmlns:a16="http://schemas.microsoft.com/office/drawing/2014/main" id="{ABA60C06-72B1-4D88-B093-D7EF06347ED3}"/>
+                <a16:creationId xmlns:a16="http://schemas.microsoft.com/office/drawing/2014/main" id="{26809348-C924-4D3D-85E8-9D81038FB133}"/>
               </a:ext>
             </a:extLst>
           </p:cNvPr>
@@ -5162,7 +5162,7 @@
           <p:cNvPr id="9" name="">
             <a:extLst xmlns:a="http://schemas.openxmlformats.org/drawingml/2006/main">
               <a:ext uri="{FF2B5EF4-FFF2-40B4-BE49-F238E27FC236}">
-                <a16:creationId xmlns:a16="http://schemas.microsoft.com/office/drawing/2014/main" id="{C6B12935-0F12-4644-890C-CF40E0CE3BFC}"/>
+                <a16:creationId xmlns:a16="http://schemas.microsoft.com/office/drawing/2014/main" id="{288800AB-6B31-4C45-9319-B71168A63DC7}"/>
               </a:ext>
             </a:extLst>
           </p:cNvPr>
@@ -5212,7 +5212,7 @@
           <p:cNvPr id="10" name="">
             <a:extLst xmlns:a="http://schemas.openxmlformats.org/drawingml/2006/main">
               <a:ext uri="{FF2B5EF4-FFF2-40B4-BE49-F238E27FC236}">
-                <a16:creationId xmlns:a16="http://schemas.microsoft.com/office/drawing/2014/main" id="{690DF75C-5EF3-4D3C-8B1E-F3E7BECC516B}"/>
+                <a16:creationId xmlns:a16="http://schemas.microsoft.com/office/drawing/2014/main" id="{12D34AF7-435B-4514-B99B-FB9832B3E01F}"/>
               </a:ext>
             </a:extLst>
           </p:cNvPr>
@@ -5262,7 +5262,7 @@
           <p:cNvPr id="11" name="">
             <a:extLst xmlns:a="http://schemas.openxmlformats.org/drawingml/2006/main">
               <a:ext uri="{FF2B5EF4-FFF2-40B4-BE49-F238E27FC236}">
-                <a16:creationId xmlns:a16="http://schemas.microsoft.com/office/drawing/2014/main" id="{A6D2EECF-F4C2-4382-9517-E86F40C27E0F}"/>
+                <a16:creationId xmlns:a16="http://schemas.microsoft.com/office/drawing/2014/main" id="{C06461FC-8C29-4608-89C8-874D4CC0013F}"/>
               </a:ext>
             </a:extLst>
           </p:cNvPr>
@@ -5295,7 +5295,7 @@
           <p:cNvPr id="12" name="">
             <a:extLst xmlns:a="http://schemas.openxmlformats.org/drawingml/2006/main">
               <a:ext uri="{FF2B5EF4-FFF2-40B4-BE49-F238E27FC236}">
-                <a16:creationId xmlns:a16="http://schemas.microsoft.com/office/drawing/2014/main" id="{B004F47D-DA02-40AB-AF45-2E0977734FE6}"/>
+                <a16:creationId xmlns:a16="http://schemas.microsoft.com/office/drawing/2014/main" id="{1278BEA8-72CE-4ABC-9B80-A1049D1A6938}"/>
               </a:ext>
             </a:extLst>
           </p:cNvPr>
@@ -5345,7 +5345,7 @@
           <p:cNvPr id="13" name="">
             <a:extLst xmlns:a="http://schemas.openxmlformats.org/drawingml/2006/main">
               <a:ext uri="{FF2B5EF4-FFF2-40B4-BE49-F238E27FC236}">
-                <a16:creationId xmlns:a16="http://schemas.microsoft.com/office/drawing/2014/main" id="{7654CB3A-083B-47EE-A415-89951BC6670B}"/>
+                <a16:creationId xmlns:a16="http://schemas.microsoft.com/office/drawing/2014/main" id="{C37C4B9C-24FA-4035-8BCF-1D504D56E319}"/>
               </a:ext>
             </a:extLst>
           </p:cNvPr>
@@ -5395,7 +5395,7 @@
           <p:cNvPr id="14" name="">
             <a:extLst xmlns:a="http://schemas.openxmlformats.org/drawingml/2006/main">
               <a:ext uri="{FF2B5EF4-FFF2-40B4-BE49-F238E27FC236}">
-                <a16:creationId xmlns:a16="http://schemas.microsoft.com/office/drawing/2014/main" id="{0A96ACB8-67F1-4EA6-88BA-23ED5910B894}"/>
+                <a16:creationId xmlns:a16="http://schemas.microsoft.com/office/drawing/2014/main" id="{C73B7B86-B7F7-4537-9C3D-CD31E13ACB1C}"/>
               </a:ext>
             </a:extLst>
           </p:cNvPr>
@@ -5445,7 +5445,7 @@
           <p:cNvPr id="15" name="">
             <a:extLst xmlns:a="http://schemas.openxmlformats.org/drawingml/2006/main">
               <a:ext uri="{FF2B5EF4-FFF2-40B4-BE49-F238E27FC236}">
-                <a16:creationId xmlns:a16="http://schemas.microsoft.com/office/drawing/2014/main" id="{D016499D-EFC0-4BE7-8BC5-E31AC11F9C21}"/>
+                <a16:creationId xmlns:a16="http://schemas.microsoft.com/office/drawing/2014/main" id="{DB027060-31F8-4F05-9100-CCE11D888705}"/>
               </a:ext>
             </a:extLst>
           </p:cNvPr>
@@ -5493,7 +5493,7 @@
     </p:spTree>
     <p:extLst>
       <p:ext uri="{BB962C8B-B14F-4D97-AF65-F5344CB8AC3E}">
-        <p14:creationId xmlns:p14="http://schemas.microsoft.com/office/powerpoint/2010/main" val="90882985"/>
+        <p14:creationId xmlns:p14="http://schemas.microsoft.com/office/powerpoint/2010/main" val="277603083"/>
       </p:ext>
     </p:extLst>
   </p:cSld>
@@ -5524,7 +5524,7 @@
           <p:cNvPr id="1" name="">
             <a:extLst xmlns:a="http://schemas.openxmlformats.org/drawingml/2006/main">
               <a:ext uri="{FF2B5EF4-FFF2-40B4-BE49-F238E27FC236}">
-                <a16:creationId xmlns:a16="http://schemas.microsoft.com/office/drawing/2014/main" id="{735B5312-1311-426D-A0CE-53028F789B5C}"/>
+                <a16:creationId xmlns:a16="http://schemas.microsoft.com/office/drawing/2014/main" id="{CDB0DE99-2469-455F-9DA7-67527B393AF6}"/>
               </a:ext>
             </a:extLst>
           </p:cNvPr>
@@ -5574,7 +5574,7 @@
           <p:cNvPr id="2" name="">
             <a:extLst xmlns:a="http://schemas.openxmlformats.org/drawingml/2006/main">
               <a:ext uri="{FF2B5EF4-FFF2-40B4-BE49-F238E27FC236}">
-                <a16:creationId xmlns:a16="http://schemas.microsoft.com/office/drawing/2014/main" id="{5178B1D4-8F9D-4A0A-8773-4D75902899BC}"/>
+                <a16:creationId xmlns:a16="http://schemas.microsoft.com/office/drawing/2014/main" id="{6BD63508-B86B-47A5-B20B-99A42A5782E5}"/>
               </a:ext>
             </a:extLst>
           </p:cNvPr>
@@ -5624,7 +5624,7 @@
           <p:cNvPr id="3" name="">
             <a:extLst xmlns:a="http://schemas.openxmlformats.org/drawingml/2006/main">
               <a:ext uri="{FF2B5EF4-FFF2-40B4-BE49-F238E27FC236}">
-                <a16:creationId xmlns:a16="http://schemas.microsoft.com/office/drawing/2014/main" id="{DA167DE0-BCF1-4EA1-AB6F-192A88D97EFA}"/>
+                <a16:creationId xmlns:a16="http://schemas.microsoft.com/office/drawing/2014/main" id="{7E1CBD66-5424-456F-8649-0FE031EB80D3}"/>
               </a:ext>
             </a:extLst>
           </p:cNvPr>
@@ -5657,7 +5657,7 @@
           <p:cNvPr id="4" name="">
             <a:extLst xmlns:a="http://schemas.openxmlformats.org/drawingml/2006/main">
               <a:ext uri="{FF2B5EF4-FFF2-40B4-BE49-F238E27FC236}">
-                <a16:creationId xmlns:a16="http://schemas.microsoft.com/office/drawing/2014/main" id="{B9543816-F449-430E-8E81-79AD41CD4313}"/>
+                <a16:creationId xmlns:a16="http://schemas.microsoft.com/office/drawing/2014/main" id="{946C8335-C7A7-4B7B-B341-327B2D863BCE}"/>
               </a:ext>
             </a:extLst>
           </p:cNvPr>
@@ -5707,7 +5707,7 @@
           <p:cNvPr id="5" name="">
             <a:extLst xmlns:a="http://schemas.openxmlformats.org/drawingml/2006/main">
               <a:ext uri="{FF2B5EF4-FFF2-40B4-BE49-F238E27FC236}">
-                <a16:creationId xmlns:a16="http://schemas.microsoft.com/office/drawing/2014/main" id="{36018035-9032-45CE-A3E8-BDC32D73D83D}"/>
+                <a16:creationId xmlns:a16="http://schemas.microsoft.com/office/drawing/2014/main" id="{4EF149D3-89A9-4378-9296-322883BF9E9F}"/>
               </a:ext>
             </a:extLst>
           </p:cNvPr>
@@ -5747,7 +5747,7 @@
                   <a:srgbClr val="111111"/>
                 </a:solidFill>
               </a:rPr>
-              <a:t>Without intervention, the portfolio is likely to stay red-heavy next month because delay, cost, and blocker pressure are all elevated at the same time.</a:t>
+              <a:t>The portfolio should remain mixed next month, but several amber projects could still move red if recovery plans are not enforced.</a:t>
             </a:r>
           </a:p>
         </p:txBody>
@@ -5757,7 +5757,7 @@
           <p:cNvPr id="6" name="">
             <a:extLst xmlns:a="http://schemas.openxmlformats.org/drawingml/2006/main">
               <a:ext uri="{FF2B5EF4-FFF2-40B4-BE49-F238E27FC236}">
-                <a16:creationId xmlns:a16="http://schemas.microsoft.com/office/drawing/2014/main" id="{49F23B08-9FD6-42D6-B806-BFAE536AE8A2}"/>
+                <a16:creationId xmlns:a16="http://schemas.microsoft.com/office/drawing/2014/main" id="{699044A9-B538-4745-B0AA-A09946AA4DD4}"/>
               </a:ext>
             </a:extLst>
           </p:cNvPr>
@@ -5790,7 +5790,7 @@
           <p:cNvPr id="7" name="">
             <a:extLst xmlns:a="http://schemas.openxmlformats.org/drawingml/2006/main">
               <a:ext uri="{FF2B5EF4-FFF2-40B4-BE49-F238E27FC236}">
-                <a16:creationId xmlns:a16="http://schemas.microsoft.com/office/drawing/2014/main" id="{DD055F8E-5008-4064-A06D-27B6A5D9FF9D}"/>
+                <a16:creationId xmlns:a16="http://schemas.microsoft.com/office/drawing/2014/main" id="{1FDDC6A6-7D0A-446B-B29A-22B54C6A24AF}"/>
               </a:ext>
             </a:extLst>
           </p:cNvPr>
@@ -5840,7 +5840,7 @@
           <p:cNvPr id="8" name="">
             <a:extLst xmlns:a="http://schemas.openxmlformats.org/drawingml/2006/main">
               <a:ext uri="{FF2B5EF4-FFF2-40B4-BE49-F238E27FC236}">
-                <a16:creationId xmlns:a16="http://schemas.microsoft.com/office/drawing/2014/main" id="{28A1B7EE-CE4C-4627-971B-735C064F4D07}"/>
+                <a16:creationId xmlns:a16="http://schemas.microsoft.com/office/drawing/2014/main" id="{9CD9F01F-483E-4E5F-BE55-45EBF2FE3A9B}"/>
               </a:ext>
             </a:extLst>
           </p:cNvPr>
@@ -5902,7 +5902,7 @@
                   <a:srgbClr val="111111"/>
                 </a:solidFill>
               </a:rPr>
-              <a:t>2. A tighter burn-versus-progress review should help contain the 0 projects currently spending ahead of delivery progress.</a:t>
+              <a:t>2. A tighter burn-versus-progress review should help contain the 2 projects currently spending ahead of delivery progress.</a:t>
             </a:r>
           </a:p>
           <a:p xmlns:a="http://schemas.openxmlformats.org/drawingml/2006/main">
@@ -5924,7 +5924,7 @@
                   <a:srgbClr val="111111"/>
                 </a:solidFill>
               </a:rPr>
-              <a:t>3. Daily blocker escalation and better status hygiene should improve confidence on the 0 heavily blocked projects and narrow the 0.4-point reporting gap in Zycus - UniSan S2P Implementation.</a:t>
+              <a:t>3. Daily blocker escalation and better status hygiene should improve confidence on the 1 heavily blocked projects and narrow the 0.0-point reporting gap in the leading red project.</a:t>
             </a:r>
           </a:p>
         </p:txBody>
@@ -5934,7 +5934,7 @@
           <p:cNvPr id="9" name="">
             <a:extLst xmlns:a="http://schemas.openxmlformats.org/drawingml/2006/main">
               <a:ext uri="{FF2B5EF4-FFF2-40B4-BE49-F238E27FC236}">
-                <a16:creationId xmlns:a16="http://schemas.microsoft.com/office/drawing/2014/main" id="{63B9896E-3D47-4119-BCB7-45ABBEC2593F}"/>
+                <a16:creationId xmlns:a16="http://schemas.microsoft.com/office/drawing/2014/main" id="{ACBC1E92-F153-414A-A521-25FF5E371A4F}"/>
               </a:ext>
             </a:extLst>
           </p:cNvPr>
@@ -5974,7 +5974,7 @@
                   <a:srgbClr val="111111"/>
                 </a:solidFill>
               </a:rPr>
-              <a:t>Project Plan B should stay on the watchlist next month because it remains Red and still carries a 0-point gap between weekly and task-level progress.</a:t>
+              <a:t>Project Plan B should stay on the watchlist next month because it remains undefined and still carries a 0-point gap between weekly and task-level progress.</a:t>
             </a:r>
           </a:p>
         </p:txBody>
@@ -5984,7 +5984,7 @@
           <p:cNvPr id="10" name="">
             <a:extLst xmlns:a="http://schemas.openxmlformats.org/drawingml/2006/main">
               <a:ext uri="{FF2B5EF4-FFF2-40B4-BE49-F238E27FC236}">
-                <a16:creationId xmlns:a16="http://schemas.microsoft.com/office/drawing/2014/main" id="{88A7669A-D8C7-4D86-A004-D48BFBCA32FC}"/>
+                <a16:creationId xmlns:a16="http://schemas.microsoft.com/office/drawing/2014/main" id="{3E2AD72C-EFDA-4166-9BB2-AE19C0F4DDA5}"/>
               </a:ext>
             </a:extLst>
           </p:cNvPr>
@@ -6032,7 +6032,7 @@
     </p:spTree>
     <p:extLst>
       <p:ext uri="{BB962C8B-B14F-4D97-AF65-F5344CB8AC3E}">
-        <p14:creationId xmlns:p14="http://schemas.microsoft.com/office/powerpoint/2010/main" val="142558885"/>
+        <p14:creationId xmlns:p14="http://schemas.microsoft.com/office/powerpoint/2010/main" val="841503534"/>
       </p:ext>
     </p:extLst>
   </p:cSld>

</xml_diff>

<commit_message>
check how to run and final submit
</commit_message>
<xml_diff>
--- a/deliverables/monthly_executive_deck.pptx
+++ b/deliverables/monthly_executive_deck.pptx
@@ -2,18 +2,18 @@
 <file path=ppt/presentation.xml><?xml version="1.0" encoding="utf-8"?>
 <p:presentation xmlns:p="http://schemas.openxmlformats.org/presentationml/2006/main">
   <p:sldMasterIdLst>
-    <p:sldMasterId xmlns:r="http://schemas.openxmlformats.org/officeDocument/2006/relationships" id="2147483648" r:id="R529563a3bdba4516"/>
+    <p:sldMasterId xmlns:r="http://schemas.openxmlformats.org/officeDocument/2006/relationships" id="2147483648" r:id="R111512d8cb144b6f"/>
   </p:sldMasterIdLst>
   <p:notesMasterIdLst>
-    <p:notesMasterId xmlns:r="http://schemas.openxmlformats.org/officeDocument/2006/relationships" r:id="Rd2c900a869e64714"/>
+    <p:notesMasterId xmlns:r="http://schemas.openxmlformats.org/officeDocument/2006/relationships" r:id="R2025deea10dd4dc1"/>
   </p:notesMasterIdLst>
   <p:sldIdLst>
-    <p:sldId xmlns:r="http://schemas.openxmlformats.org/officeDocument/2006/relationships" id="256" r:id="Rff53846a9772409d"/>
-    <p:sldId xmlns:r="http://schemas.openxmlformats.org/officeDocument/2006/relationships" id="257" r:id="R664ce838f2ee4ab3"/>
-    <p:sldId xmlns:r="http://schemas.openxmlformats.org/officeDocument/2006/relationships" id="258" r:id="R8a1553d990684528"/>
-    <p:sldId xmlns:r="http://schemas.openxmlformats.org/officeDocument/2006/relationships" id="259" r:id="R9e4ff2e18efd4adc"/>
-    <p:sldId xmlns:r="http://schemas.openxmlformats.org/officeDocument/2006/relationships" id="260" r:id="Rc33b3d7397534baa"/>
-    <p:sldId xmlns:r="http://schemas.openxmlformats.org/officeDocument/2006/relationships" id="261" r:id="R71267295d6484496"/>
+    <p:sldId xmlns:r="http://schemas.openxmlformats.org/officeDocument/2006/relationships" id="256" r:id="Ra9ee94e558324245"/>
+    <p:sldId xmlns:r="http://schemas.openxmlformats.org/officeDocument/2006/relationships" id="257" r:id="Rdc77970fa20a4f57"/>
+    <p:sldId xmlns:r="http://schemas.openxmlformats.org/officeDocument/2006/relationships" id="258" r:id="R526c832ad92849ba"/>
+    <p:sldId xmlns:r="http://schemas.openxmlformats.org/officeDocument/2006/relationships" id="259" r:id="R5c6885a53fe349b9"/>
+    <p:sldId xmlns:r="http://schemas.openxmlformats.org/officeDocument/2006/relationships" id="260" r:id="R691fc1cc77294ef0"/>
+    <p:sldId xmlns:r="http://schemas.openxmlformats.org/officeDocument/2006/relationships" id="261" r:id="R3626d2f91f694b2b"/>
   </p:sldIdLst>
   <p:sldSz cx="12192000" cy="6858000"/>
   <p:notesSz cx="6858000" cy="9144000"/>
@@ -936,7 +936,7 @@
   </p:cSld>
   <p:clrMap bg1="lt1" tx1="dk1" bg2="lt2" tx2="dk2" accent1="accent1" accent2="accent2" accent3="accent3" accent4="accent4" accent5="accent5" accent6="accent6" hlink="hlink" folHlink="folHlink"/>
   <p:sldLayoutIdLst>
-    <p:sldLayoutId xmlns:r="http://schemas.openxmlformats.org/officeDocument/2006/relationships" id="2147483649" r:id="R4b84b364cfd84fd9"/>
+    <p:sldLayoutId xmlns:r="http://schemas.openxmlformats.org/officeDocument/2006/relationships" id="2147483649" r:id="R9e5b25b5251042d8"/>
   </p:sldLayoutIdLst>
   <p:txStyles>
     <p:titleStyle>
@@ -1487,7 +1487,7 @@
           <p:cNvPr id="1" name="">
             <a:extLst xmlns:a="http://schemas.openxmlformats.org/drawingml/2006/main">
               <a:ext uri="{FF2B5EF4-FFF2-40B4-BE49-F238E27FC236}">
-                <a16:creationId xmlns:a16="http://schemas.microsoft.com/office/drawing/2014/main" id="{042E6C66-8550-4DF3-84B4-EB1411B0C206}"/>
+                <a16:creationId xmlns:a16="http://schemas.microsoft.com/office/drawing/2014/main" id="{165B3980-0F2B-4E2D-B31F-B71B7AB93510}"/>
               </a:ext>
             </a:extLst>
           </p:cNvPr>
@@ -1537,7 +1537,7 @@
           <p:cNvPr id="2" name="">
             <a:extLst xmlns:a="http://schemas.openxmlformats.org/drawingml/2006/main">
               <a:ext uri="{FF2B5EF4-FFF2-40B4-BE49-F238E27FC236}">
-                <a16:creationId xmlns:a16="http://schemas.microsoft.com/office/drawing/2014/main" id="{C0D3CD98-E07C-49EF-8593-665997BDFCAD}"/>
+                <a16:creationId xmlns:a16="http://schemas.microsoft.com/office/drawing/2014/main" id="{39CFA03C-EA6F-4F81-BED2-4F4972940CD1}"/>
               </a:ext>
             </a:extLst>
           </p:cNvPr>
@@ -1587,7 +1587,7 @@
           <p:cNvPr id="3" name="">
             <a:extLst xmlns:a="http://schemas.openxmlformats.org/drawingml/2006/main">
               <a:ext uri="{FF2B5EF4-FFF2-40B4-BE49-F238E27FC236}">
-                <a16:creationId xmlns:a16="http://schemas.microsoft.com/office/drawing/2014/main" id="{7A5CB27B-D507-4330-98ED-BD6820146A48}"/>
+                <a16:creationId xmlns:a16="http://schemas.microsoft.com/office/drawing/2014/main" id="{EB9712AA-1907-432F-9E60-F138833075EF}"/>
               </a:ext>
             </a:extLst>
           </p:cNvPr>
@@ -1620,7 +1620,7 @@
           <p:cNvPr id="4" name="">
             <a:extLst xmlns:a="http://schemas.openxmlformats.org/drawingml/2006/main">
               <a:ext uri="{FF2B5EF4-FFF2-40B4-BE49-F238E27FC236}">
-                <a16:creationId xmlns:a16="http://schemas.microsoft.com/office/drawing/2014/main" id="{112FBA92-E4B8-45B0-BBF4-11581A9B27B8}"/>
+                <a16:creationId xmlns:a16="http://schemas.microsoft.com/office/drawing/2014/main" id="{018EFFF7-4151-4F9C-AF49-63FA6842492D}"/>
               </a:ext>
             </a:extLst>
           </p:cNvPr>
@@ -1660,7 +1660,7 @@
                   <a:srgbClr val="111111"/>
                 </a:solidFill>
               </a:rPr>
-              <a:t>2</a:t>
+              <a:t>8</a:t>
             </a:r>
           </a:p>
         </p:txBody>
@@ -1670,7 +1670,7 @@
           <p:cNvPr id="5" name="">
             <a:extLst xmlns:a="http://schemas.openxmlformats.org/drawingml/2006/main">
               <a:ext uri="{FF2B5EF4-FFF2-40B4-BE49-F238E27FC236}">
-                <a16:creationId xmlns:a16="http://schemas.microsoft.com/office/drawing/2014/main" id="{EF964660-ADEE-45F5-AB0F-BAAF07B380AF}"/>
+                <a16:creationId xmlns:a16="http://schemas.microsoft.com/office/drawing/2014/main" id="{A564ED85-E7CC-47CB-AAC2-DF6E554C022D}"/>
               </a:ext>
             </a:extLst>
           </p:cNvPr>
@@ -1720,7 +1720,7 @@
           <p:cNvPr id="6" name="">
             <a:extLst xmlns:a="http://schemas.openxmlformats.org/drawingml/2006/main">
               <a:ext uri="{FF2B5EF4-FFF2-40B4-BE49-F238E27FC236}">
-                <a16:creationId xmlns:a16="http://schemas.microsoft.com/office/drawing/2014/main" id="{7D689B52-E968-44C4-BB95-F020AD7C4688}"/>
+                <a16:creationId xmlns:a16="http://schemas.microsoft.com/office/drawing/2014/main" id="{026E1EB9-7A90-419B-94CA-486B2FF3EFA2}"/>
               </a:ext>
             </a:extLst>
           </p:cNvPr>
@@ -1753,7 +1753,7 @@
           <p:cNvPr id="7" name="">
             <a:extLst xmlns:a="http://schemas.openxmlformats.org/drawingml/2006/main">
               <a:ext uri="{FF2B5EF4-FFF2-40B4-BE49-F238E27FC236}">
-                <a16:creationId xmlns:a16="http://schemas.microsoft.com/office/drawing/2014/main" id="{2A49EDDB-E864-4CA6-A90C-1C7445176DB4}"/>
+                <a16:creationId xmlns:a16="http://schemas.microsoft.com/office/drawing/2014/main" id="{F53C5D7D-3525-46EC-B7DA-486A8B7AF149}"/>
               </a:ext>
             </a:extLst>
           </p:cNvPr>
@@ -1793,7 +1793,7 @@
                   <a:srgbClr val="111111"/>
                 </a:solidFill>
               </a:rPr>
-              <a:t>0</a:t>
+              <a:t>1</a:t>
             </a:r>
           </a:p>
         </p:txBody>
@@ -1803,7 +1803,7 @@
           <p:cNvPr id="8" name="">
             <a:extLst xmlns:a="http://schemas.openxmlformats.org/drawingml/2006/main">
               <a:ext uri="{FF2B5EF4-FFF2-40B4-BE49-F238E27FC236}">
-                <a16:creationId xmlns:a16="http://schemas.microsoft.com/office/drawing/2014/main" id="{9D7875AB-8D10-4000-B554-73856B6230B5}"/>
+                <a16:creationId xmlns:a16="http://schemas.microsoft.com/office/drawing/2014/main" id="{3C073969-4B0C-499D-A0D0-66185FEDDD26}"/>
               </a:ext>
             </a:extLst>
           </p:cNvPr>
@@ -1853,7 +1853,7 @@
           <p:cNvPr id="9" name="">
             <a:extLst xmlns:a="http://schemas.openxmlformats.org/drawingml/2006/main">
               <a:ext uri="{FF2B5EF4-FFF2-40B4-BE49-F238E27FC236}">
-                <a16:creationId xmlns:a16="http://schemas.microsoft.com/office/drawing/2014/main" id="{EB1B4ADD-4ED3-4ABC-898B-BAE22D9A2157}"/>
+                <a16:creationId xmlns:a16="http://schemas.microsoft.com/office/drawing/2014/main" id="{44057E15-FAB1-468D-88BB-6C42C560FE2A}"/>
               </a:ext>
             </a:extLst>
           </p:cNvPr>
@@ -1886,7 +1886,7 @@
           <p:cNvPr id="10" name="">
             <a:extLst xmlns:a="http://schemas.openxmlformats.org/drawingml/2006/main">
               <a:ext uri="{FF2B5EF4-FFF2-40B4-BE49-F238E27FC236}">
-                <a16:creationId xmlns:a16="http://schemas.microsoft.com/office/drawing/2014/main" id="{F6B7820A-1A25-41E3-9FF9-268736C23575}"/>
+                <a16:creationId xmlns:a16="http://schemas.microsoft.com/office/drawing/2014/main" id="{6C21F8FC-9D13-453F-9206-C069B049FCC4}"/>
               </a:ext>
             </a:extLst>
           </p:cNvPr>
@@ -1926,7 +1926,7 @@
                   <a:srgbClr val="111111"/>
                 </a:solidFill>
               </a:rPr>
-              <a:t>0</a:t>
+              <a:t>2</a:t>
             </a:r>
           </a:p>
         </p:txBody>
@@ -1936,7 +1936,7 @@
           <p:cNvPr id="11" name="">
             <a:extLst xmlns:a="http://schemas.openxmlformats.org/drawingml/2006/main">
               <a:ext uri="{FF2B5EF4-FFF2-40B4-BE49-F238E27FC236}">
-                <a16:creationId xmlns:a16="http://schemas.microsoft.com/office/drawing/2014/main" id="{13A850C1-7D07-40D1-96E5-378329798D55}"/>
+                <a16:creationId xmlns:a16="http://schemas.microsoft.com/office/drawing/2014/main" id="{6103016F-8DD9-43CF-9CFF-926B218FABBA}"/>
               </a:ext>
             </a:extLst>
           </p:cNvPr>
@@ -1986,7 +1986,7 @@
           <p:cNvPr id="12" name="">
             <a:extLst xmlns:a="http://schemas.openxmlformats.org/drawingml/2006/main">
               <a:ext uri="{FF2B5EF4-FFF2-40B4-BE49-F238E27FC236}">
-                <a16:creationId xmlns:a16="http://schemas.microsoft.com/office/drawing/2014/main" id="{BA02C0CA-A501-4967-B275-FF4F043B59A3}"/>
+                <a16:creationId xmlns:a16="http://schemas.microsoft.com/office/drawing/2014/main" id="{C68D055C-21C4-4CBD-8CC7-788E7FB55080}"/>
               </a:ext>
             </a:extLst>
           </p:cNvPr>
@@ -2019,7 +2019,7 @@
           <p:cNvPr id="13" name="">
             <a:extLst xmlns:a="http://schemas.openxmlformats.org/drawingml/2006/main">
               <a:ext uri="{FF2B5EF4-FFF2-40B4-BE49-F238E27FC236}">
-                <a16:creationId xmlns:a16="http://schemas.microsoft.com/office/drawing/2014/main" id="{A0AFB1D2-B823-409A-BFEA-B601768E66E3}"/>
+                <a16:creationId xmlns:a16="http://schemas.microsoft.com/office/drawing/2014/main" id="{39A93A1C-2F30-4177-96F2-A5910D8583C0}"/>
               </a:ext>
             </a:extLst>
           </p:cNvPr>
@@ -2059,7 +2059,7 @@
                   <a:srgbClr val="D9481C"/>
                 </a:solidFill>
               </a:rPr>
-              <a:t>2</a:t>
+              <a:t>5</a:t>
             </a:r>
           </a:p>
         </p:txBody>
@@ -2069,7 +2069,7 @@
           <p:cNvPr id="14" name="">
             <a:extLst xmlns:a="http://schemas.openxmlformats.org/drawingml/2006/main">
               <a:ext uri="{FF2B5EF4-FFF2-40B4-BE49-F238E27FC236}">
-                <a16:creationId xmlns:a16="http://schemas.microsoft.com/office/drawing/2014/main" id="{CB8BC324-C3BA-4030-9561-D8EF2AF5F0AE}"/>
+                <a16:creationId xmlns:a16="http://schemas.microsoft.com/office/drawing/2014/main" id="{3250D225-B726-4FB2-BA04-9638ABF8A000}"/>
               </a:ext>
             </a:extLst>
           </p:cNvPr>
@@ -2119,7 +2119,7 @@
           <p:cNvPr id="15" name="">
             <a:extLst xmlns:a="http://schemas.openxmlformats.org/drawingml/2006/main">
               <a:ext uri="{FF2B5EF4-FFF2-40B4-BE49-F238E27FC236}">
-                <a16:creationId xmlns:a16="http://schemas.microsoft.com/office/drawing/2014/main" id="{CF2B7ECF-C4F9-4725-8813-6D77C2B46599}"/>
+                <a16:creationId xmlns:a16="http://schemas.microsoft.com/office/drawing/2014/main" id="{265E3461-6807-48BC-905D-099B52171E58}"/>
               </a:ext>
             </a:extLst>
           </p:cNvPr>
@@ -2152,7 +2152,7 @@
           <p:cNvPr id="16" name="">
             <a:extLst xmlns:a="http://schemas.openxmlformats.org/drawingml/2006/main">
               <a:ext uri="{FF2B5EF4-FFF2-40B4-BE49-F238E27FC236}">
-                <a16:creationId xmlns:a16="http://schemas.microsoft.com/office/drawing/2014/main" id="{4D7CAC33-D166-47C9-BBDF-A647A929AB4A}"/>
+                <a16:creationId xmlns:a16="http://schemas.microsoft.com/office/drawing/2014/main" id="{EB4B0D30-8FEF-4A51-AE44-B0AAB3DA36BE}"/>
               </a:ext>
             </a:extLst>
           </p:cNvPr>
@@ -2192,7 +2192,7 @@
                   <a:srgbClr val="111111"/>
                 </a:solidFill>
               </a:rPr>
-              <a:t>100% of analyzed views are currently red, which indicates that schedule recovery and execution control need executive attention before the next client reporting cycle.</a:t>
+              <a:t>62.5% of analyzed views are currently red, which indicates that schedule recovery and execution control need executive attention before the next client reporting cycle.</a:t>
             </a:r>
           </a:p>
         </p:txBody>
@@ -2202,7 +2202,7 @@
           <p:cNvPr id="17" name="">
             <a:extLst xmlns:a="http://schemas.openxmlformats.org/drawingml/2006/main">
               <a:ext uri="{FF2B5EF4-FFF2-40B4-BE49-F238E27FC236}">
-                <a16:creationId xmlns:a16="http://schemas.microsoft.com/office/drawing/2014/main" id="{FD0A9328-A006-405A-9911-AB795BACFBEE}"/>
+                <a16:creationId xmlns:a16="http://schemas.microsoft.com/office/drawing/2014/main" id="{A963FC3F-D53A-4F2C-A4D5-BEF64716DE51}"/>
               </a:ext>
             </a:extLst>
           </p:cNvPr>
@@ -2235,7 +2235,7 @@
           <p:cNvPr id="18" name="">
             <a:extLst xmlns:a="http://schemas.openxmlformats.org/drawingml/2006/main">
               <a:ext uri="{FF2B5EF4-FFF2-40B4-BE49-F238E27FC236}">
-                <a16:creationId xmlns:a16="http://schemas.microsoft.com/office/drawing/2014/main" id="{9782D17B-F7B2-4908-9960-EBE791DB9653}"/>
+                <a16:creationId xmlns:a16="http://schemas.microsoft.com/office/drawing/2014/main" id="{7B437CA1-C9B6-4813-A681-5DBE2DFA620C}"/>
               </a:ext>
             </a:extLst>
           </p:cNvPr>
@@ -2285,7 +2285,7 @@
           <p:cNvPr id="19" name="">
             <a:extLst xmlns:a="http://schemas.openxmlformats.org/drawingml/2006/main">
               <a:ext uri="{FF2B5EF4-FFF2-40B4-BE49-F238E27FC236}">
-                <a16:creationId xmlns:a16="http://schemas.microsoft.com/office/drawing/2014/main" id="{90659EB6-CEC6-4700-8543-DF289F774BA0}"/>
+                <a16:creationId xmlns:a16="http://schemas.microsoft.com/office/drawing/2014/main" id="{0A6722C7-D07B-41EA-B113-FB0804F3ADA5}"/>
               </a:ext>
             </a:extLst>
           </p:cNvPr>
@@ -2325,7 +2325,7 @@
                   <a:srgbClr val="111111"/>
                 </a:solidFill>
               </a:rPr>
-              <a:t>Risk is the most common lead driver.</a:t>
+              <a:t>Schedule is the most common lead driver.</a:t>
             </a:r>
           </a:p>
           <a:p xmlns:a="http://schemas.openxmlformats.org/drawingml/2006/main">
@@ -2347,7 +2347,7 @@
                   <a:srgbClr val="111111"/>
                 </a:solidFill>
               </a:rPr>
-              <a:t>Schedule pressure is the next-most common concern across the current plans.</a:t>
+              <a:t>Milestone pressure is the next-most common concern across the current plans.</a:t>
             </a:r>
           </a:p>
           <a:p xmlns:a="http://schemas.openxmlformats.org/drawingml/2006/main">
@@ -2369,7 +2369,7 @@
                   <a:srgbClr val="111111"/>
                 </a:solidFill>
               </a:rPr>
-              <a:t>UniSan S2P implementation remains red and should stay on the next escalation review list.</a:t>
+              <a:t>CRM Upgrade remains red and should stay on the next escalation review list.</a:t>
             </a:r>
           </a:p>
         </p:txBody>
@@ -2379,7 +2379,7 @@
           <p:cNvPr id="20" name="">
             <a:extLst xmlns:a="http://schemas.openxmlformats.org/drawingml/2006/main">
               <a:ext uri="{FF2B5EF4-FFF2-40B4-BE49-F238E27FC236}">
-                <a16:creationId xmlns:a16="http://schemas.microsoft.com/office/drawing/2014/main" id="{E51C9CC3-FE36-470A-BB90-C38B7040DFFC}"/>
+                <a16:creationId xmlns:a16="http://schemas.microsoft.com/office/drawing/2014/main" id="{867CE744-DE52-4286-8510-D825F9949253}"/>
               </a:ext>
             </a:extLst>
           </p:cNvPr>
@@ -2427,7 +2427,7 @@
     </p:spTree>
     <p:extLst>
       <p:ext uri="{BB962C8B-B14F-4D97-AF65-F5344CB8AC3E}">
-        <p14:creationId xmlns:p14="http://schemas.microsoft.com/office/powerpoint/2010/main" val="954447338"/>
+        <p14:creationId xmlns:p14="http://schemas.microsoft.com/office/powerpoint/2010/main" val="666396884"/>
       </p:ext>
     </p:extLst>
   </p:cSld>
@@ -2458,7 +2458,7 @@
           <p:cNvPr id="1" name="">
             <a:extLst xmlns:a="http://schemas.openxmlformats.org/drawingml/2006/main">
               <a:ext uri="{FF2B5EF4-FFF2-40B4-BE49-F238E27FC236}">
-                <a16:creationId xmlns:a16="http://schemas.microsoft.com/office/drawing/2014/main" id="{3CDDC86E-B162-4517-9527-2C44D1B9FD09}"/>
+                <a16:creationId xmlns:a16="http://schemas.microsoft.com/office/drawing/2014/main" id="{3A304806-866C-4858-B379-CF4ADCD6F48E}"/>
               </a:ext>
             </a:extLst>
           </p:cNvPr>
@@ -2508,7 +2508,7 @@
           <p:cNvPr id="2" name="">
             <a:extLst xmlns:a="http://schemas.openxmlformats.org/drawingml/2006/main">
               <a:ext uri="{FF2B5EF4-FFF2-40B4-BE49-F238E27FC236}">
-                <a16:creationId xmlns:a16="http://schemas.microsoft.com/office/drawing/2014/main" id="{29B70D72-AF15-4D9C-B0F4-915124ADA248}"/>
+                <a16:creationId xmlns:a16="http://schemas.microsoft.com/office/drawing/2014/main" id="{EDFF285E-05E5-4FFB-9213-BC10CCA5DBB1}"/>
               </a:ext>
             </a:extLst>
           </p:cNvPr>
@@ -2558,7 +2558,7 @@
           <p:cNvPr id="3" name="">
             <a:extLst xmlns:a="http://schemas.openxmlformats.org/drawingml/2006/main">
               <a:ext uri="{FF2B5EF4-FFF2-40B4-BE49-F238E27FC236}">
-                <a16:creationId xmlns:a16="http://schemas.microsoft.com/office/drawing/2014/main" id="{BEDB6D53-06BC-4715-9E74-E978D19EC69D}"/>
+                <a16:creationId xmlns:a16="http://schemas.microsoft.com/office/drawing/2014/main" id="{396483BD-2373-47DF-9B61-02AE98A6A892}"/>
               </a:ext>
             </a:extLst>
           </p:cNvPr>
@@ -2591,7 +2591,7 @@
           <p:cNvPr id="4" name="">
             <a:extLst xmlns:a="http://schemas.openxmlformats.org/drawingml/2006/main">
               <a:ext uri="{FF2B5EF4-FFF2-40B4-BE49-F238E27FC236}">
-                <a16:creationId xmlns:a16="http://schemas.microsoft.com/office/drawing/2014/main" id="{5FB0E00B-2A3A-4829-8432-A813DC7BA5C7}"/>
+                <a16:creationId xmlns:a16="http://schemas.microsoft.com/office/drawing/2014/main" id="{0FB1748F-1FAF-494B-856B-AE64C897F5F9}"/>
               </a:ext>
             </a:extLst>
           </p:cNvPr>
@@ -2641,7 +2641,7 @@
           <p:cNvPr id="5" name="">
             <a:extLst xmlns:a="http://schemas.openxmlformats.org/drawingml/2006/main">
               <a:ext uri="{FF2B5EF4-FFF2-40B4-BE49-F238E27FC236}">
-                <a16:creationId xmlns:a16="http://schemas.microsoft.com/office/drawing/2014/main" id="{A591E264-4A4F-4B57-9E80-30D194D7BB7E}"/>
+                <a16:creationId xmlns:a16="http://schemas.microsoft.com/office/drawing/2014/main" id="{AA0F0325-EE69-4896-A5FD-263BFF5859F2}"/>
               </a:ext>
             </a:extLst>
           </p:cNvPr>
@@ -2674,7 +2674,7 @@
           <p:cNvPr id="6" name="">
             <a:extLst xmlns:a="http://schemas.openxmlformats.org/drawingml/2006/main">
               <a:ext uri="{FF2B5EF4-FFF2-40B4-BE49-F238E27FC236}">
-                <a16:creationId xmlns:a16="http://schemas.microsoft.com/office/drawing/2014/main" id="{AA82193C-3C38-4D3C-88DF-32FFDAF14679}"/>
+                <a16:creationId xmlns:a16="http://schemas.microsoft.com/office/drawing/2014/main" id="{74BB3516-F627-4F68-A5FB-2DD0E9BD915A}"/>
               </a:ext>
             </a:extLst>
           </p:cNvPr>
@@ -2714,7 +2714,7 @@
                   <a:srgbClr val="111111"/>
                 </a:solidFill>
               </a:rPr>
-              <a:t>0</a:t>
+              <a:t>1</a:t>
             </a:r>
           </a:p>
         </p:txBody>
@@ -2724,7 +2724,7 @@
           <p:cNvPr id="7" name="">
             <a:extLst xmlns:a="http://schemas.openxmlformats.org/drawingml/2006/main">
               <a:ext uri="{FF2B5EF4-FFF2-40B4-BE49-F238E27FC236}">
-                <a16:creationId xmlns:a16="http://schemas.microsoft.com/office/drawing/2014/main" id="{84F5DE68-165B-4527-8471-D66DC6E4335D}"/>
+                <a16:creationId xmlns:a16="http://schemas.microsoft.com/office/drawing/2014/main" id="{FF9A8173-9D9C-406B-AC36-DF3F8EA71298}"/>
               </a:ext>
             </a:extLst>
           </p:cNvPr>
@@ -2774,7 +2774,7 @@
           <p:cNvPr id="8" name="">
             <a:extLst xmlns:a="http://schemas.openxmlformats.org/drawingml/2006/main">
               <a:ext uri="{FF2B5EF4-FFF2-40B4-BE49-F238E27FC236}">
-                <a16:creationId xmlns:a16="http://schemas.microsoft.com/office/drawing/2014/main" id="{175E45F1-58AF-4743-ABA0-169EB5652E4D}"/>
+                <a16:creationId xmlns:a16="http://schemas.microsoft.com/office/drawing/2014/main" id="{DC179804-F9BF-4794-9A6B-573088BBD8F1}"/>
               </a:ext>
             </a:extLst>
           </p:cNvPr>
@@ -2807,7 +2807,7 @@
           <p:cNvPr id="9" name="">
             <a:extLst xmlns:a="http://schemas.openxmlformats.org/drawingml/2006/main">
               <a:ext uri="{FF2B5EF4-FFF2-40B4-BE49-F238E27FC236}">
-                <a16:creationId xmlns:a16="http://schemas.microsoft.com/office/drawing/2014/main" id="{A7C7A243-D57E-4585-BA82-BD95298C035C}"/>
+                <a16:creationId xmlns:a16="http://schemas.microsoft.com/office/drawing/2014/main" id="{74F8D327-15C1-4B3F-980C-26CA52B4CEB3}"/>
               </a:ext>
             </a:extLst>
           </p:cNvPr>
@@ -2847,7 +2847,7 @@
                   <a:srgbClr val="111111"/>
                 </a:solidFill>
               </a:rPr>
-              <a:t>0</a:t>
+              <a:t>2</a:t>
             </a:r>
           </a:p>
         </p:txBody>
@@ -2857,7 +2857,7 @@
           <p:cNvPr id="10" name="">
             <a:extLst xmlns:a="http://schemas.openxmlformats.org/drawingml/2006/main">
               <a:ext uri="{FF2B5EF4-FFF2-40B4-BE49-F238E27FC236}">
-                <a16:creationId xmlns:a16="http://schemas.microsoft.com/office/drawing/2014/main" id="{631465B3-DF7B-4557-9EE6-02355E6C950D}"/>
+                <a16:creationId xmlns:a16="http://schemas.microsoft.com/office/drawing/2014/main" id="{26404C3D-36CA-4CFA-90E9-39FDA96046B3}"/>
               </a:ext>
             </a:extLst>
           </p:cNvPr>
@@ -2907,7 +2907,7 @@
           <p:cNvPr id="11" name="">
             <a:extLst xmlns:a="http://schemas.openxmlformats.org/drawingml/2006/main">
               <a:ext uri="{FF2B5EF4-FFF2-40B4-BE49-F238E27FC236}">
-                <a16:creationId xmlns:a16="http://schemas.microsoft.com/office/drawing/2014/main" id="{E9245572-814E-480B-B647-2C4DECEDFCD5}"/>
+                <a16:creationId xmlns:a16="http://schemas.microsoft.com/office/drawing/2014/main" id="{99D824A4-8503-44D5-8023-66563D5DC4E7}"/>
               </a:ext>
             </a:extLst>
           </p:cNvPr>
@@ -2940,7 +2940,7 @@
           <p:cNvPr id="12" name="">
             <a:extLst xmlns:a="http://schemas.openxmlformats.org/drawingml/2006/main">
               <a:ext uri="{FF2B5EF4-FFF2-40B4-BE49-F238E27FC236}">
-                <a16:creationId xmlns:a16="http://schemas.microsoft.com/office/drawing/2014/main" id="{8AD10A43-5D78-4185-BAD7-4051BDB891D2}"/>
+                <a16:creationId xmlns:a16="http://schemas.microsoft.com/office/drawing/2014/main" id="{701B0802-BB9A-45FE-A4A8-65DE1C29D558}"/>
               </a:ext>
             </a:extLst>
           </p:cNvPr>
@@ -2980,7 +2980,7 @@
                   <a:srgbClr val="D9481C"/>
                 </a:solidFill>
               </a:rPr>
-              <a:t>2</a:t>
+              <a:t>5</a:t>
             </a:r>
           </a:p>
         </p:txBody>
@@ -2990,7 +2990,7 @@
           <p:cNvPr id="13" name="">
             <a:extLst xmlns:a="http://schemas.openxmlformats.org/drawingml/2006/main">
               <a:ext uri="{FF2B5EF4-FFF2-40B4-BE49-F238E27FC236}">
-                <a16:creationId xmlns:a16="http://schemas.microsoft.com/office/drawing/2014/main" id="{7737C670-2D9E-4095-A373-CD69A8F3C967}"/>
+                <a16:creationId xmlns:a16="http://schemas.microsoft.com/office/drawing/2014/main" id="{F684A0C0-5C55-431F-B941-98A4F8FD7A20}"/>
               </a:ext>
             </a:extLst>
           </p:cNvPr>
@@ -3040,7 +3040,7 @@
           <p:cNvPr id="14" name="">
             <a:extLst xmlns:a="http://schemas.openxmlformats.org/drawingml/2006/main">
               <a:ext uri="{FF2B5EF4-FFF2-40B4-BE49-F238E27FC236}">
-                <a16:creationId xmlns:a16="http://schemas.microsoft.com/office/drawing/2014/main" id="{A9AB6E3E-7F54-43C2-A357-1736FF411D51}"/>
+                <a16:creationId xmlns:a16="http://schemas.microsoft.com/office/drawing/2014/main" id="{1E5555AE-E6B3-470D-940D-6A8B0764512D}"/>
               </a:ext>
             </a:extLst>
           </p:cNvPr>
@@ -3080,7 +3080,7 @@
                   <a:srgbClr val="111111"/>
                 </a:solidFill>
               </a:rPr>
-              <a:t>2 project plans were analyzed in this run, and every current view is red or amber-weighted enough to need active leadership attention.</a:t>
+              <a:t>8 project plans were analyzed in this run, and every current view is red or amber-weighted enough to need active leadership attention.</a:t>
             </a:r>
           </a:p>
         </p:txBody>
@@ -3090,7 +3090,7 @@
           <p:cNvPr id="15" name="">
             <a:extLst xmlns:a="http://schemas.openxmlformats.org/drawingml/2006/main">
               <a:ext uri="{FF2B5EF4-FFF2-40B4-BE49-F238E27FC236}">
-                <a16:creationId xmlns:a16="http://schemas.microsoft.com/office/drawing/2014/main" id="{017C1D6C-BB03-4776-A988-ACCCA6150805}"/>
+                <a16:creationId xmlns:a16="http://schemas.microsoft.com/office/drawing/2014/main" id="{218D5D32-1725-47E6-972A-6E4A4C1498AD}"/>
               </a:ext>
             </a:extLst>
           </p:cNvPr>
@@ -3123,7 +3123,7 @@
           <p:cNvPr id="16" name="">
             <a:extLst xmlns:a="http://schemas.openxmlformats.org/drawingml/2006/main">
               <a:ext uri="{FF2B5EF4-FFF2-40B4-BE49-F238E27FC236}">
-                <a16:creationId xmlns:a16="http://schemas.microsoft.com/office/drawing/2014/main" id="{8522D48E-5281-48F5-AC10-BC7FA4DC5888}"/>
+                <a16:creationId xmlns:a16="http://schemas.microsoft.com/office/drawing/2014/main" id="{9398F22D-2E6E-4020-8B31-744E2988965B}"/>
               </a:ext>
             </a:extLst>
           </p:cNvPr>
@@ -3163,7 +3163,7 @@
                   <a:srgbClr val="111111"/>
                 </a:solidFill>
               </a:rPr>
-              <a:t>53.2/100</a:t>
+              <a:t>57.3/100</a:t>
             </a:r>
           </a:p>
         </p:txBody>
@@ -3173,7 +3173,7 @@
           <p:cNvPr id="17" name="">
             <a:extLst xmlns:a="http://schemas.openxmlformats.org/drawingml/2006/main">
               <a:ext uri="{FF2B5EF4-FFF2-40B4-BE49-F238E27FC236}">
-                <a16:creationId xmlns:a16="http://schemas.microsoft.com/office/drawing/2014/main" id="{61D9C0A1-9D7D-48EF-933F-2BDD75EE5ABE}"/>
+                <a16:creationId xmlns:a16="http://schemas.microsoft.com/office/drawing/2014/main" id="{E3176A9D-CBF7-4B82-9F83-CC4246215266}"/>
               </a:ext>
             </a:extLst>
           </p:cNvPr>
@@ -3223,7 +3223,7 @@
           <p:cNvPr id="18" name="">
             <a:extLst xmlns:a="http://schemas.openxmlformats.org/drawingml/2006/main">
               <a:ext uri="{FF2B5EF4-FFF2-40B4-BE49-F238E27FC236}">
-                <a16:creationId xmlns:a16="http://schemas.microsoft.com/office/drawing/2014/main" id="{7340B791-DB1F-4E01-B67C-E8686D1C610F}"/>
+                <a16:creationId xmlns:a16="http://schemas.microsoft.com/office/drawing/2014/main" id="{246C59D9-FCD7-4C38-AD25-796441FF84A0}"/>
               </a:ext>
             </a:extLst>
           </p:cNvPr>
@@ -3256,7 +3256,7 @@
           <p:cNvPr id="19" name="">
             <a:extLst xmlns:a="http://schemas.openxmlformats.org/drawingml/2006/main">
               <a:ext uri="{FF2B5EF4-FFF2-40B4-BE49-F238E27FC236}">
-                <a16:creationId xmlns:a16="http://schemas.microsoft.com/office/drawing/2014/main" id="{C840EEAE-A332-4372-A81D-B3335FC7E866}"/>
+                <a16:creationId xmlns:a16="http://schemas.microsoft.com/office/drawing/2014/main" id="{424C5EAD-8EA3-4778-992E-2FDF81BAB43A}"/>
               </a:ext>
             </a:extLst>
           </p:cNvPr>
@@ -3306,7 +3306,7 @@
           <p:cNvPr id="20" name="">
             <a:extLst xmlns:a="http://schemas.openxmlformats.org/drawingml/2006/main">
               <a:ext uri="{FF2B5EF4-FFF2-40B4-BE49-F238E27FC236}">
-                <a16:creationId xmlns:a16="http://schemas.microsoft.com/office/drawing/2014/main" id="{ABFCBC9B-204F-4908-BECA-08BD21DEC179}"/>
+                <a16:creationId xmlns:a16="http://schemas.microsoft.com/office/drawing/2014/main" id="{1B368A5C-39F1-49EA-B02B-D483747419E3}"/>
               </a:ext>
             </a:extLst>
           </p:cNvPr>
@@ -3356,7 +3356,7 @@
           <p:cNvPr id="21" name="">
             <a:extLst xmlns:a="http://schemas.openxmlformats.org/drawingml/2006/main">
               <a:ext uri="{FF2B5EF4-FFF2-40B4-BE49-F238E27FC236}">
-                <a16:creationId xmlns:a16="http://schemas.microsoft.com/office/drawing/2014/main" id="{9A14E94A-8B99-4544-9B47-0E9A0708C128}"/>
+                <a16:creationId xmlns:a16="http://schemas.microsoft.com/office/drawing/2014/main" id="{211983A6-7607-4C1F-B450-7C8190E5E404}"/>
               </a:ext>
             </a:extLst>
           </p:cNvPr>
@@ -3396,7 +3396,7 @@
                   <a:srgbClr val="111111"/>
                 </a:solidFill>
               </a:rPr>
-              <a:t>The average score across all 2 analyzed project plans is 53.2/100. Validation against the embedded workbook health labels holds at 50%, which is directionally useful for leadership screening while keeping the reasoning transparent.</a:t>
+              <a:t>The average score across all 8 analyzed project plans is 57.3/100. Validation against the embedded workbook health labels holds at 50%, which is directionally useful for leadership screening while keeping the reasoning transparent.</a:t>
             </a:r>
           </a:p>
         </p:txBody>
@@ -3406,7 +3406,7 @@
           <p:cNvPr id="22" name="">
             <a:extLst xmlns:a="http://schemas.openxmlformats.org/drawingml/2006/main">
               <a:ext uri="{FF2B5EF4-FFF2-40B4-BE49-F238E27FC236}">
-                <a16:creationId xmlns:a16="http://schemas.microsoft.com/office/drawing/2014/main" id="{606A6338-120F-42F8-ABC4-CD68B5865BAC}"/>
+                <a16:creationId xmlns:a16="http://schemas.microsoft.com/office/drawing/2014/main" id="{499D7F45-E164-4DE9-84C4-F40587617837}"/>
               </a:ext>
             </a:extLst>
           </p:cNvPr>
@@ -3454,7 +3454,7 @@
     </p:spTree>
     <p:extLst>
       <p:ext uri="{BB962C8B-B14F-4D97-AF65-F5344CB8AC3E}">
-        <p14:creationId xmlns:p14="http://schemas.microsoft.com/office/powerpoint/2010/main" val="393758007"/>
+        <p14:creationId xmlns:p14="http://schemas.microsoft.com/office/powerpoint/2010/main" val="116493569"/>
       </p:ext>
     </p:extLst>
   </p:cSld>
@@ -3485,7 +3485,7 @@
           <p:cNvPr id="1" name="">
             <a:extLst xmlns:a="http://schemas.openxmlformats.org/drawingml/2006/main">
               <a:ext uri="{FF2B5EF4-FFF2-40B4-BE49-F238E27FC236}">
-                <a16:creationId xmlns:a16="http://schemas.microsoft.com/office/drawing/2014/main" id="{FC972259-7939-40C8-9C8F-C2FDE7BFCB98}"/>
+                <a16:creationId xmlns:a16="http://schemas.microsoft.com/office/drawing/2014/main" id="{D6BC30B9-AE47-4025-B403-6693B4A87DB3}"/>
               </a:ext>
             </a:extLst>
           </p:cNvPr>
@@ -3535,7 +3535,7 @@
           <p:cNvPr id="2" name="">
             <a:extLst xmlns:a="http://schemas.openxmlformats.org/drawingml/2006/main">
               <a:ext uri="{FF2B5EF4-FFF2-40B4-BE49-F238E27FC236}">
-                <a16:creationId xmlns:a16="http://schemas.microsoft.com/office/drawing/2014/main" id="{AAB9D693-73DB-4A24-B130-1D204C8CCE4A}"/>
+                <a16:creationId xmlns:a16="http://schemas.microsoft.com/office/drawing/2014/main" id="{34CBB79B-DAE0-4ECB-B783-C0A06A3B1F0D}"/>
               </a:ext>
             </a:extLst>
           </p:cNvPr>
@@ -3585,7 +3585,7 @@
           <p:cNvPr id="3" name="">
             <a:extLst xmlns:a="http://schemas.openxmlformats.org/drawingml/2006/main">
               <a:ext uri="{FF2B5EF4-FFF2-40B4-BE49-F238E27FC236}">
-                <a16:creationId xmlns:a16="http://schemas.microsoft.com/office/drawing/2014/main" id="{208A095E-9B21-4C9E-A581-C8EEC322CEFB}"/>
+                <a16:creationId xmlns:a16="http://schemas.microsoft.com/office/drawing/2014/main" id="{F6F316AB-2335-4D1D-9974-D34AA1A10C4F}"/>
               </a:ext>
             </a:extLst>
           </p:cNvPr>
@@ -3618,7 +3618,7 @@
           <p:cNvPr id="4" name="">
             <a:extLst xmlns:a="http://schemas.openxmlformats.org/drawingml/2006/main">
               <a:ext uri="{FF2B5EF4-FFF2-40B4-BE49-F238E27FC236}">
-                <a16:creationId xmlns:a16="http://schemas.microsoft.com/office/drawing/2014/main" id="{6638CD8B-70D5-496D-A312-3689D2908F6E}"/>
+                <a16:creationId xmlns:a16="http://schemas.microsoft.com/office/drawing/2014/main" id="{23ADBCBE-D762-465E-AA25-D77E097E1B38}"/>
               </a:ext>
             </a:extLst>
           </p:cNvPr>
@@ -3658,7 +3658,7 @@
                   <a:srgbClr val="111111"/>
                 </a:solidFill>
               </a:rPr>
-              <a:t>0</a:t>
+              <a:t>5</a:t>
             </a:r>
           </a:p>
         </p:txBody>
@@ -3668,7 +3668,7 @@
           <p:cNvPr id="5" name="">
             <a:extLst xmlns:a="http://schemas.openxmlformats.org/drawingml/2006/main">
               <a:ext uri="{FF2B5EF4-FFF2-40B4-BE49-F238E27FC236}">
-                <a16:creationId xmlns:a16="http://schemas.microsoft.com/office/drawing/2014/main" id="{06DCD0DD-AC0E-450F-9026-4B0214EC24EE}"/>
+                <a16:creationId xmlns:a16="http://schemas.microsoft.com/office/drawing/2014/main" id="{01F70E26-C2D8-4AE0-A218-150332F2D1A1}"/>
               </a:ext>
             </a:extLst>
           </p:cNvPr>
@@ -3718,7 +3718,7 @@
           <p:cNvPr id="6" name="">
             <a:extLst xmlns:a="http://schemas.openxmlformats.org/drawingml/2006/main">
               <a:ext uri="{FF2B5EF4-FFF2-40B4-BE49-F238E27FC236}">
-                <a16:creationId xmlns:a16="http://schemas.microsoft.com/office/drawing/2014/main" id="{05AA982F-5449-4DA6-BC18-B3C409D9C967}"/>
+                <a16:creationId xmlns:a16="http://schemas.microsoft.com/office/drawing/2014/main" id="{2D64F1FA-2E9B-4EFD-877F-D0D81D54A08C}"/>
               </a:ext>
             </a:extLst>
           </p:cNvPr>
@@ -3751,7 +3751,7 @@
           <p:cNvPr id="7" name="">
             <a:extLst xmlns:a="http://schemas.openxmlformats.org/drawingml/2006/main">
               <a:ext uri="{FF2B5EF4-FFF2-40B4-BE49-F238E27FC236}">
-                <a16:creationId xmlns:a16="http://schemas.microsoft.com/office/drawing/2014/main" id="{1EF97707-D0BB-424C-8A39-587C1C8B2FDF}"/>
+                <a16:creationId xmlns:a16="http://schemas.microsoft.com/office/drawing/2014/main" id="{0A11FB37-4B51-4DFF-B9D1-EDCAB25ABBB8}"/>
               </a:ext>
             </a:extLst>
           </p:cNvPr>
@@ -3791,7 +3791,7 @@
                   <a:srgbClr val="D9481C"/>
                 </a:solidFill>
               </a:rPr>
-              <a:t>1</a:t>
+              <a:t>2</a:t>
             </a:r>
           </a:p>
         </p:txBody>
@@ -3801,7 +3801,7 @@
           <p:cNvPr id="8" name="">
             <a:extLst xmlns:a="http://schemas.openxmlformats.org/drawingml/2006/main">
               <a:ext uri="{FF2B5EF4-FFF2-40B4-BE49-F238E27FC236}">
-                <a16:creationId xmlns:a16="http://schemas.microsoft.com/office/drawing/2014/main" id="{951BDAF4-F579-4EF8-B3ED-DA15CCD91250}"/>
+                <a16:creationId xmlns:a16="http://schemas.microsoft.com/office/drawing/2014/main" id="{FC4CBD68-59FD-4B28-AB2F-3CB805F16BBA}"/>
               </a:ext>
             </a:extLst>
           </p:cNvPr>
@@ -3851,7 +3851,7 @@
           <p:cNvPr id="9" name="">
             <a:extLst xmlns:a="http://schemas.openxmlformats.org/drawingml/2006/main">
               <a:ext uri="{FF2B5EF4-FFF2-40B4-BE49-F238E27FC236}">
-                <a16:creationId xmlns:a16="http://schemas.microsoft.com/office/drawing/2014/main" id="{A4C46BF7-AC92-4D15-AE97-FF4331651914}"/>
+                <a16:creationId xmlns:a16="http://schemas.microsoft.com/office/drawing/2014/main" id="{6931E6DE-1407-4B27-A897-9D70EA3352A7}"/>
               </a:ext>
             </a:extLst>
           </p:cNvPr>
@@ -3884,7 +3884,7 @@
           <p:cNvPr id="10" name="">
             <a:extLst xmlns:a="http://schemas.openxmlformats.org/drawingml/2006/main">
               <a:ext uri="{FF2B5EF4-FFF2-40B4-BE49-F238E27FC236}">
-                <a16:creationId xmlns:a16="http://schemas.microsoft.com/office/drawing/2014/main" id="{ACD74BD1-7037-486B-8699-7DA6BBACB295}"/>
+                <a16:creationId xmlns:a16="http://schemas.microsoft.com/office/drawing/2014/main" id="{D9F2CF80-6DFB-4D4A-935B-3D0F8910F4AB}"/>
               </a:ext>
             </a:extLst>
           </p:cNvPr>
@@ -3924,7 +3924,7 @@
                   <a:srgbClr val="111111"/>
                 </a:solidFill>
               </a:rPr>
-              <a:t>2</a:t>
+              <a:t>3</a:t>
             </a:r>
           </a:p>
         </p:txBody>
@@ -3934,7 +3934,7 @@
           <p:cNvPr id="11" name="">
             <a:extLst xmlns:a="http://schemas.openxmlformats.org/drawingml/2006/main">
               <a:ext uri="{FF2B5EF4-FFF2-40B4-BE49-F238E27FC236}">
-                <a16:creationId xmlns:a16="http://schemas.microsoft.com/office/drawing/2014/main" id="{E4DC04E0-EBFA-4E89-A760-932F49AD5075}"/>
+                <a16:creationId xmlns:a16="http://schemas.microsoft.com/office/drawing/2014/main" id="{A0E28A65-2370-4F1D-94A0-E925220A2802}"/>
               </a:ext>
             </a:extLst>
           </p:cNvPr>
@@ -3984,7 +3984,7 @@
           <p:cNvPr id="12" name="">
             <a:extLst xmlns:a="http://schemas.openxmlformats.org/drawingml/2006/main">
               <a:ext uri="{FF2B5EF4-FFF2-40B4-BE49-F238E27FC236}">
-                <a16:creationId xmlns:a16="http://schemas.microsoft.com/office/drawing/2014/main" id="{BDD5D46C-3511-4638-8582-56FC29D03930}"/>
+                <a16:creationId xmlns:a16="http://schemas.microsoft.com/office/drawing/2014/main" id="{66D79AD6-02C9-4FE0-ABBD-EDDC4AB506F6}"/>
               </a:ext>
             </a:extLst>
           </p:cNvPr>
@@ -4017,7 +4017,7 @@
           <p:cNvPr id="13" name="">
             <a:extLst xmlns:a="http://schemas.openxmlformats.org/drawingml/2006/main">
               <a:ext uri="{FF2B5EF4-FFF2-40B4-BE49-F238E27FC236}">
-                <a16:creationId xmlns:a16="http://schemas.microsoft.com/office/drawing/2014/main" id="{151E7F36-2DB8-40D0-9B14-EA0740D315EB}"/>
+                <a16:creationId xmlns:a16="http://schemas.microsoft.com/office/drawing/2014/main" id="{9F56C9C5-EF7A-43EA-864D-F53DEF1A8224}"/>
               </a:ext>
             </a:extLst>
           </p:cNvPr>
@@ -4057,7 +4057,7 @@
                   <a:srgbClr val="111111"/>
                 </a:solidFill>
               </a:rPr>
-              <a:t>0</a:t>
+              <a:t>5</a:t>
             </a:r>
           </a:p>
         </p:txBody>
@@ -4067,7 +4067,7 @@
           <p:cNvPr id="14" name="">
             <a:extLst xmlns:a="http://schemas.openxmlformats.org/drawingml/2006/main">
               <a:ext uri="{FF2B5EF4-FFF2-40B4-BE49-F238E27FC236}">
-                <a16:creationId xmlns:a16="http://schemas.microsoft.com/office/drawing/2014/main" id="{9A38F687-832E-492E-941C-A51E69A1D6FD}"/>
+                <a16:creationId xmlns:a16="http://schemas.microsoft.com/office/drawing/2014/main" id="{C173B515-9D2C-4F36-8D30-41E62E2DF4A3}"/>
               </a:ext>
             </a:extLst>
           </p:cNvPr>
@@ -4117,7 +4117,7 @@
           <p:cNvPr id="15" name="">
             <a:extLst xmlns:a="http://schemas.openxmlformats.org/drawingml/2006/main">
               <a:ext uri="{FF2B5EF4-FFF2-40B4-BE49-F238E27FC236}">
-                <a16:creationId xmlns:a16="http://schemas.microsoft.com/office/drawing/2014/main" id="{B5EA8E64-296C-4C77-8F78-64D21C3A2DB8}"/>
+                <a16:creationId xmlns:a16="http://schemas.microsoft.com/office/drawing/2014/main" id="{BAF3DEAD-8F53-4B89-9418-43BDA6AB3974}"/>
               </a:ext>
             </a:extLst>
           </p:cNvPr>
@@ -4150,7 +4150,7 @@
           <p:cNvPr id="16" name="">
             <a:extLst xmlns:a="http://schemas.openxmlformats.org/drawingml/2006/main">
               <a:ext uri="{FF2B5EF4-FFF2-40B4-BE49-F238E27FC236}">
-                <a16:creationId xmlns:a16="http://schemas.microsoft.com/office/drawing/2014/main" id="{C6A11A1F-DBF2-4385-B9B5-9ECF2F1A64D0}"/>
+                <a16:creationId xmlns:a16="http://schemas.microsoft.com/office/drawing/2014/main" id="{FBA7E7B4-FEE3-4BE5-878D-B9BAF3BF49CA}"/>
               </a:ext>
             </a:extLst>
           </p:cNvPr>
@@ -4200,7 +4200,7 @@
           <p:cNvPr id="17" name="">
             <a:extLst xmlns:a="http://schemas.openxmlformats.org/drawingml/2006/main">
               <a:ext uri="{FF2B5EF4-FFF2-40B4-BE49-F238E27FC236}">
-                <a16:creationId xmlns:a16="http://schemas.microsoft.com/office/drawing/2014/main" id="{2BC2083F-A532-45E7-8C14-69E7FA843A5F}"/>
+                <a16:creationId xmlns:a16="http://schemas.microsoft.com/office/drawing/2014/main" id="{CCB6E154-0F72-47BE-81DC-7CF2976B3BEC}"/>
               </a:ext>
             </a:extLst>
           </p:cNvPr>
@@ -4240,7 +4240,7 @@
                   <a:srgbClr val="111111"/>
                 </a:solidFill>
               </a:rPr>
-              <a:t>1 projects are already more than two weeks behind, and 0 are spending ahead of delivery progress.</a:t>
+              <a:t>2 projects are already more than two weeks behind, and 5 are spending ahead of delivery progress.</a:t>
             </a:r>
           </a:p>
           <a:p xmlns:a="http://schemas.openxmlformats.org/drawingml/2006/main">
@@ -4262,7 +4262,7 @@
                   <a:srgbClr val="111111"/>
                 </a:solidFill>
               </a:rPr>
-              <a:t>0 projects also carry two or more critical blockers, which means the schedule risk is likely to stay elevated unless escalation gets faster.</a:t>
+              <a:t>3 projects also carry two or more critical blockers, which means the schedule risk is likely to stay elevated unless escalation gets faster.</a:t>
             </a:r>
           </a:p>
           <a:p xmlns:a="http://schemas.openxmlformats.org/drawingml/2006/main">
@@ -4294,7 +4294,7 @@
           <p:cNvPr id="18" name="">
             <a:extLst xmlns:a="http://schemas.openxmlformats.org/drawingml/2006/main">
               <a:ext uri="{FF2B5EF4-FFF2-40B4-BE49-F238E27FC236}">
-                <a16:creationId xmlns:a16="http://schemas.microsoft.com/office/drawing/2014/main" id="{6C543C02-7A19-412E-8379-3FCD0E0C0999}"/>
+                <a16:creationId xmlns:a16="http://schemas.microsoft.com/office/drawing/2014/main" id="{6A8BF249-6FEE-4F1D-BF75-D78DAD5E3D2B}"/>
               </a:ext>
             </a:extLst>
           </p:cNvPr>
@@ -4342,7 +4342,7 @@
     </p:spTree>
     <p:extLst>
       <p:ext uri="{BB962C8B-B14F-4D97-AF65-F5344CB8AC3E}">
-        <p14:creationId xmlns:p14="http://schemas.microsoft.com/office/powerpoint/2010/main" val="1961670582"/>
+        <p14:creationId xmlns:p14="http://schemas.microsoft.com/office/powerpoint/2010/main" val="902034728"/>
       </p:ext>
     </p:extLst>
   </p:cSld>
@@ -4373,7 +4373,7 @@
           <p:cNvPr id="1" name="">
             <a:extLst xmlns:a="http://schemas.openxmlformats.org/drawingml/2006/main">
               <a:ext uri="{FF2B5EF4-FFF2-40B4-BE49-F238E27FC236}">
-                <a16:creationId xmlns:a16="http://schemas.microsoft.com/office/drawing/2014/main" id="{46CD2774-AF01-4892-9D50-C8D85F12A439}"/>
+                <a16:creationId xmlns:a16="http://schemas.microsoft.com/office/drawing/2014/main" id="{8F39AAB5-E5F6-4264-841B-67C88F7762E8}"/>
               </a:ext>
             </a:extLst>
           </p:cNvPr>
@@ -4423,7 +4423,7 @@
           <p:cNvPr id="2" name="">
             <a:extLst xmlns:a="http://schemas.openxmlformats.org/drawingml/2006/main">
               <a:ext uri="{FF2B5EF4-FFF2-40B4-BE49-F238E27FC236}">
-                <a16:creationId xmlns:a16="http://schemas.microsoft.com/office/drawing/2014/main" id="{FC510DD7-6611-43B6-B00C-22A26063115C}"/>
+                <a16:creationId xmlns:a16="http://schemas.microsoft.com/office/drawing/2014/main" id="{2CED9132-DA81-4C20-A2DD-DC0D5118C497}"/>
               </a:ext>
             </a:extLst>
           </p:cNvPr>
@@ -4487,7 +4487,7 @@
                 <a:gridCol w="1047750"/>
                 <a:gridCol w="6705600"/>
               </a:tblGrid>
-              <a:tr h="1333500">
+              <a:tr h="666750">
                 <a:tc>
                   <a:txBody>
                     <a:bodyPr/>
@@ -4552,7 +4552,7 @@
                   </a:tcPr>
                 </a:tc>
               </a:tr>
-              <a:tr h="1333500">
+              <a:tr h="666750">
                 <a:tc>
                   <a:txBody>
                     <a:bodyPr/>
@@ -4564,7 +4564,7 @@
                             <a:srgbClr val="111111"/>
                           </a:solidFill>
                         </a:rPr>
-                        <a:t>Zycus - UniSan S2P Implementation</a:t>
+                        <a:t>CRM Upgrade</a:t>
                       </a:r>
                     </a:p>
                   </a:txBody>
@@ -4581,7 +4581,7 @@
                             <a:srgbClr val="111111"/>
                           </a:solidFill>
                         </a:rPr>
-                        <a:t>68.3</a:t>
+                        <a:t>91.1</a:t>
                       </a:r>
                     </a:p>
                   </a:txBody>
@@ -4598,14 +4598,14 @@
                             <a:srgbClr val="111111"/>
                           </a:solidFill>
                         </a:rPr>
-                        <a:t>About 61% of the plan duration has elapsed, while blended progress is 44% and 23% of due tasks are still incomplete</a:t>
+                        <a:t>Progress trails plan by 26 points and the project is 18 days behind schedule</a:t>
                       </a:r>
                     </a:p>
                   </a:txBody>
                   <a:tcPr marL="91440" marR="91440" marT="45720" marB="45720"/>
                 </a:tc>
               </a:tr>
-              <a:tr h="1333500">
+              <a:tr h="666750">
                 <a:tc>
                   <a:txBody>
                     <a:bodyPr/>
@@ -4617,7 +4617,7 @@
                             <a:srgbClr val="111111"/>
                           </a:solidFill>
                         </a:rPr>
-                        <a:t>Zycus - Titan S2P Implementation</a:t>
+                        <a:t>Vendor Risk Platform</a:t>
                       </a:r>
                     </a:p>
                   </a:txBody>
@@ -4634,7 +4634,7 @@
                             <a:srgbClr val="111111"/>
                           </a:solidFill>
                         </a:rPr>
-                        <a:t>38.1</a:t>
+                        <a:t>85.2</a:t>
                       </a:r>
                     </a:p>
                   </a:txBody>
@@ -4651,7 +4651,166 @@
                             <a:srgbClr val="111111"/>
                           </a:solidFill>
                         </a:rPr>
-                        <a:t>The plan carries 16 critical risks and 24 high risks</a:t>
+                        <a:t>Progress trails plan by 23 points and the project is 21 days behind schedule</a:t>
+                      </a:r>
+                    </a:p>
+                  </a:txBody>
+                  <a:tcPr marL="91440" marR="91440" marT="45720" marB="45720"/>
+                </a:tc>
+              </a:tr>
+              <a:tr h="666750">
+                <a:tc>
+                  <a:txBody>
+                    <a:bodyPr/>
+                    <a:lstStyle/>
+                    <a:p>
+                      <a:r>
+                        <a:rPr sz="975">
+                          <a:solidFill>
+                            <a:srgbClr val="111111"/>
+                          </a:solidFill>
+                        </a:rPr>
+                        <a:t>Contract Lifecycle Mgmt</a:t>
+                      </a:r>
+                    </a:p>
+                  </a:txBody>
+                  <a:tcPr marL="91440" marR="91440" marT="45720" marB="45720"/>
+                </a:tc>
+                <a:tc>
+                  <a:txBody>
+                    <a:bodyPr/>
+                    <a:lstStyle/>
+                    <a:p>
+                      <a:r>
+                        <a:rPr sz="975">
+                          <a:solidFill>
+                            <a:srgbClr val="111111"/>
+                          </a:solidFill>
+                        </a:rPr>
+                        <a:t>84.4</a:t>
+                      </a:r>
+                    </a:p>
+                  </a:txBody>
+                  <a:tcPr marL="91440" marR="91440" marT="45720" marB="45720"/>
+                </a:tc>
+                <a:tc>
+                  <a:txBody>
+                    <a:bodyPr/>
+                    <a:lstStyle/>
+                    <a:p>
+                      <a:r>
+                        <a:rPr sz="975">
+                          <a:solidFill>
+                            <a:srgbClr val="111111"/>
+                          </a:solidFill>
+                        </a:rPr>
+                        <a:t>Progress trails plan by 14 points and the project is 14 days behind schedule</a:t>
+                      </a:r>
+                    </a:p>
+                  </a:txBody>
+                  <a:tcPr marL="91440" marR="91440" marT="45720" marB="45720"/>
+                </a:tc>
+              </a:tr>
+              <a:tr h="666750">
+                <a:tc>
+                  <a:txBody>
+                    <a:bodyPr/>
+                    <a:lstStyle/>
+                    <a:p>
+                      <a:r>
+                        <a:rPr sz="975">
+                          <a:solidFill>
+                            <a:srgbClr val="111111"/>
+                          </a:solidFill>
+                        </a:rPr>
+                        <a:t>ERP Migration</a:t>
+                      </a:r>
+                    </a:p>
+                  </a:txBody>
+                  <a:tcPr marL="91440" marR="91440" marT="45720" marB="45720"/>
+                </a:tc>
+                <a:tc>
+                  <a:txBody>
+                    <a:bodyPr/>
+                    <a:lstStyle/>
+                    <a:p>
+                      <a:r>
+                        <a:rPr sz="975">
+                          <a:solidFill>
+                            <a:srgbClr val="111111"/>
+                          </a:solidFill>
+                        </a:rPr>
+                        <a:t>74.4</a:t>
+                      </a:r>
+                    </a:p>
+                  </a:txBody>
+                  <a:tcPr marL="91440" marR="91440" marT="45720" marB="45720"/>
+                </a:tc>
+                <a:tc>
+                  <a:txBody>
+                    <a:bodyPr/>
+                    <a:lstStyle/>
+                    <a:p>
+                      <a:r>
+                        <a:rPr sz="975">
+                          <a:solidFill>
+                            <a:srgbClr val="111111"/>
+                          </a:solidFill>
+                        </a:rPr>
+                        <a:t>Progress trails plan by 15 points and the project is 12 days behind schedule</a:t>
+                      </a:r>
+                    </a:p>
+                  </a:txBody>
+                  <a:tcPr marL="91440" marR="91440" marT="45720" marB="45720"/>
+                </a:tc>
+              </a:tr>
+              <a:tr h="666750">
+                <a:tc>
+                  <a:txBody>
+                    <a:bodyPr/>
+                    <a:lstStyle/>
+                    <a:p>
+                      <a:r>
+                        <a:rPr sz="975">
+                          <a:solidFill>
+                            <a:srgbClr val="111111"/>
+                          </a:solidFill>
+                        </a:rPr>
+                        <a:t>Data Lake Modernization</a:t>
+                      </a:r>
+                    </a:p>
+                  </a:txBody>
+                  <a:tcPr marL="91440" marR="91440" marT="45720" marB="45720"/>
+                </a:tc>
+                <a:tc>
+                  <a:txBody>
+                    <a:bodyPr/>
+                    <a:lstStyle/>
+                    <a:p>
+                      <a:r>
+                        <a:rPr sz="975">
+                          <a:solidFill>
+                            <a:srgbClr val="111111"/>
+                          </a:solidFill>
+                        </a:rPr>
+                        <a:t>27.9</a:t>
+                      </a:r>
+                    </a:p>
+                  </a:txBody>
+                  <a:tcPr marL="91440" marR="91440" marT="45720" marB="45720"/>
+                </a:tc>
+                <a:tc>
+                  <a:txBody>
+                    <a:bodyPr/>
+                    <a:lstStyle/>
+                    <a:p>
+                      <a:r>
+                        <a:rPr sz="975">
+                          <a:solidFill>
+                            <a:srgbClr val="111111"/>
+                          </a:solidFill>
+                        </a:rPr>
+                        <a:t>40% of milestones are marked delayed and 80% are overdue as of 2026-07-09</a:t>
                       </a:r>
                     </a:p>
                   </a:txBody>
@@ -4667,7 +4826,7 @@
           <p:cNvPr id="4" name="">
             <a:extLst xmlns:a="http://schemas.openxmlformats.org/drawingml/2006/main">
               <a:ext uri="{FF2B5EF4-FFF2-40B4-BE49-F238E27FC236}">
-                <a16:creationId xmlns:a16="http://schemas.microsoft.com/office/drawing/2014/main" id="{90A88D6E-596C-4068-871A-C874F2B0340A}"/>
+                <a16:creationId xmlns:a16="http://schemas.microsoft.com/office/drawing/2014/main" id="{0F38B6ED-4F72-414C-9700-AACEE4F07FA2}"/>
               </a:ext>
             </a:extLst>
           </p:cNvPr>
@@ -4717,7 +4876,7 @@
           <p:cNvPr id="5" name="">
             <a:extLst xmlns:a="http://schemas.openxmlformats.org/drawingml/2006/main">
               <a:ext uri="{FF2B5EF4-FFF2-40B4-BE49-F238E27FC236}">
-                <a16:creationId xmlns:a16="http://schemas.microsoft.com/office/drawing/2014/main" id="{3F552F1F-45E7-451C-A699-AFC338E3F454}"/>
+                <a16:creationId xmlns:a16="http://schemas.microsoft.com/office/drawing/2014/main" id="{1C97F556-5E2B-4927-B5B8-3AC9B8C92990}"/>
               </a:ext>
             </a:extLst>
           </p:cNvPr>
@@ -4765,7 +4924,7 @@
     </p:spTree>
     <p:extLst>
       <p:ext uri="{BB962C8B-B14F-4D97-AF65-F5344CB8AC3E}">
-        <p14:creationId xmlns:p14="http://schemas.microsoft.com/office/powerpoint/2010/main" val="1584078203"/>
+        <p14:creationId xmlns:p14="http://schemas.microsoft.com/office/powerpoint/2010/main" val="1703562412"/>
       </p:ext>
     </p:extLst>
   </p:cSld>
@@ -4796,7 +4955,7 @@
           <p:cNvPr id="1" name="">
             <a:extLst xmlns:a="http://schemas.openxmlformats.org/drawingml/2006/main">
               <a:ext uri="{FF2B5EF4-FFF2-40B4-BE49-F238E27FC236}">
-                <a16:creationId xmlns:a16="http://schemas.microsoft.com/office/drawing/2014/main" id="{9D688EEA-AE40-4C1C-97E2-56FA11B68A4B}"/>
+                <a16:creationId xmlns:a16="http://schemas.microsoft.com/office/drawing/2014/main" id="{92F1980A-83A8-4EB6-9126-94DD0417E75E}"/>
               </a:ext>
             </a:extLst>
           </p:cNvPr>
@@ -4846,7 +5005,7 @@
           <p:cNvPr id="2" name="">
             <a:extLst xmlns:a="http://schemas.openxmlformats.org/drawingml/2006/main">
               <a:ext uri="{FF2B5EF4-FFF2-40B4-BE49-F238E27FC236}">
-                <a16:creationId xmlns:a16="http://schemas.microsoft.com/office/drawing/2014/main" id="{BEFEB790-8CA0-4987-90CD-87FDD4FA1061}"/>
+                <a16:creationId xmlns:a16="http://schemas.microsoft.com/office/drawing/2014/main" id="{ACAD31E6-1B56-45E7-A860-342A94CD9161}"/>
               </a:ext>
             </a:extLst>
           </p:cNvPr>
@@ -4896,7 +5055,7 @@
           <p:cNvPr id="3" name="">
             <a:extLst xmlns:a="http://schemas.openxmlformats.org/drawingml/2006/main">
               <a:ext uri="{FF2B5EF4-FFF2-40B4-BE49-F238E27FC236}">
-                <a16:creationId xmlns:a16="http://schemas.microsoft.com/office/drawing/2014/main" id="{0BAECBEB-8294-47BB-8B2E-A1D97F20DFBD}"/>
+                <a16:creationId xmlns:a16="http://schemas.microsoft.com/office/drawing/2014/main" id="{B3FA3AB5-D788-457D-B834-64B699C635A8}"/>
               </a:ext>
             </a:extLst>
           </p:cNvPr>
@@ -4929,7 +5088,7 @@
           <p:cNvPr id="4" name="">
             <a:extLst xmlns:a="http://schemas.openxmlformats.org/drawingml/2006/main">
               <a:ext uri="{FF2B5EF4-FFF2-40B4-BE49-F238E27FC236}">
-                <a16:creationId xmlns:a16="http://schemas.microsoft.com/office/drawing/2014/main" id="{1EA7787F-789A-4486-B550-9E0F41600396}"/>
+                <a16:creationId xmlns:a16="http://schemas.microsoft.com/office/drawing/2014/main" id="{1F1ABC53-B87A-49F5-855B-AC93E14D2EE1}"/>
               </a:ext>
             </a:extLst>
           </p:cNvPr>
@@ -4979,7 +5138,7 @@
           <p:cNvPr id="5" name="">
             <a:extLst xmlns:a="http://schemas.openxmlformats.org/drawingml/2006/main">
               <a:ext uri="{FF2B5EF4-FFF2-40B4-BE49-F238E27FC236}">
-                <a16:creationId xmlns:a16="http://schemas.microsoft.com/office/drawing/2014/main" id="{D2CBFF85-C147-461F-9F69-B9F5DA68AA06}"/>
+                <a16:creationId xmlns:a16="http://schemas.microsoft.com/office/drawing/2014/main" id="{2C78E8B8-2B74-4EEC-A051-3A48C5AC7F2D}"/>
               </a:ext>
             </a:extLst>
           </p:cNvPr>
@@ -5029,7 +5188,7 @@
           <p:cNvPr id="6" name="">
             <a:extLst xmlns:a="http://schemas.openxmlformats.org/drawingml/2006/main">
               <a:ext uri="{FF2B5EF4-FFF2-40B4-BE49-F238E27FC236}">
-                <a16:creationId xmlns:a16="http://schemas.microsoft.com/office/drawing/2014/main" id="{13212DF7-7EA7-4F9C-B4A9-C1D5C57AC01D}"/>
+                <a16:creationId xmlns:a16="http://schemas.microsoft.com/office/drawing/2014/main" id="{734C3580-6FEE-4C31-8B54-08CAF1015704}"/>
               </a:ext>
             </a:extLst>
           </p:cNvPr>
@@ -5079,7 +5238,7 @@
           <p:cNvPr id="7" name="">
             <a:extLst xmlns:a="http://schemas.openxmlformats.org/drawingml/2006/main">
               <a:ext uri="{FF2B5EF4-FFF2-40B4-BE49-F238E27FC236}">
-                <a16:creationId xmlns:a16="http://schemas.microsoft.com/office/drawing/2014/main" id="{733C432C-F0AC-4B9A-8C74-FEC73A4BCECC}"/>
+                <a16:creationId xmlns:a16="http://schemas.microsoft.com/office/drawing/2014/main" id="{EBEAD70F-F028-49BF-B834-1AED0877F1D9}"/>
               </a:ext>
             </a:extLst>
           </p:cNvPr>
@@ -5112,7 +5271,7 @@
           <p:cNvPr id="8" name="">
             <a:extLst xmlns:a="http://schemas.openxmlformats.org/drawingml/2006/main">
               <a:ext uri="{FF2B5EF4-FFF2-40B4-BE49-F238E27FC236}">
-                <a16:creationId xmlns:a16="http://schemas.microsoft.com/office/drawing/2014/main" id="{4E6F4469-CC31-4C5E-91F6-7572546515FC}"/>
+                <a16:creationId xmlns:a16="http://schemas.microsoft.com/office/drawing/2014/main" id="{7F3FF97F-EA45-4142-9335-35F75D41A1C6}"/>
               </a:ext>
             </a:extLst>
           </p:cNvPr>
@@ -5162,7 +5321,7 @@
           <p:cNvPr id="9" name="">
             <a:extLst xmlns:a="http://schemas.openxmlformats.org/drawingml/2006/main">
               <a:ext uri="{FF2B5EF4-FFF2-40B4-BE49-F238E27FC236}">
-                <a16:creationId xmlns:a16="http://schemas.microsoft.com/office/drawing/2014/main" id="{FE1B7AEE-2A96-4A6F-B3DB-BFB8FF99D473}"/>
+                <a16:creationId xmlns:a16="http://schemas.microsoft.com/office/drawing/2014/main" id="{2D97873D-D886-41CC-A9B0-FF5868D36570}"/>
               </a:ext>
             </a:extLst>
           </p:cNvPr>
@@ -5212,7 +5371,7 @@
           <p:cNvPr id="10" name="">
             <a:extLst xmlns:a="http://schemas.openxmlformats.org/drawingml/2006/main">
               <a:ext uri="{FF2B5EF4-FFF2-40B4-BE49-F238E27FC236}">
-                <a16:creationId xmlns:a16="http://schemas.microsoft.com/office/drawing/2014/main" id="{666D81C2-4F8A-4D26-B1FE-37580946E09F}"/>
+                <a16:creationId xmlns:a16="http://schemas.microsoft.com/office/drawing/2014/main" id="{F1170BBA-0698-4BF0-838C-BED15EAFB04E}"/>
               </a:ext>
             </a:extLst>
           </p:cNvPr>
@@ -5262,7 +5421,7 @@
           <p:cNvPr id="11" name="">
             <a:extLst xmlns:a="http://schemas.openxmlformats.org/drawingml/2006/main">
               <a:ext uri="{FF2B5EF4-FFF2-40B4-BE49-F238E27FC236}">
-                <a16:creationId xmlns:a16="http://schemas.microsoft.com/office/drawing/2014/main" id="{1C4BF866-81E6-4CD3-9142-93D883D694E3}"/>
+                <a16:creationId xmlns:a16="http://schemas.microsoft.com/office/drawing/2014/main" id="{2D748C19-3BCE-45CC-B38B-274E600A1148}"/>
               </a:ext>
             </a:extLst>
           </p:cNvPr>
@@ -5295,7 +5454,7 @@
           <p:cNvPr id="12" name="">
             <a:extLst xmlns:a="http://schemas.openxmlformats.org/drawingml/2006/main">
               <a:ext uri="{FF2B5EF4-FFF2-40B4-BE49-F238E27FC236}">
-                <a16:creationId xmlns:a16="http://schemas.microsoft.com/office/drawing/2014/main" id="{A4F623ED-0763-4BB7-B7BA-A61D3C49FAB4}"/>
+                <a16:creationId xmlns:a16="http://schemas.microsoft.com/office/drawing/2014/main" id="{27DF163C-C301-46FB-BE31-E6C76359B46B}"/>
               </a:ext>
             </a:extLst>
           </p:cNvPr>
@@ -5345,7 +5504,7 @@
           <p:cNvPr id="13" name="">
             <a:extLst xmlns:a="http://schemas.openxmlformats.org/drawingml/2006/main">
               <a:ext uri="{FF2B5EF4-FFF2-40B4-BE49-F238E27FC236}">
-                <a16:creationId xmlns:a16="http://schemas.microsoft.com/office/drawing/2014/main" id="{27A86DDE-1E44-40B9-8746-23813E0D579A}"/>
+                <a16:creationId xmlns:a16="http://schemas.microsoft.com/office/drawing/2014/main" id="{D588FF96-021B-425B-801F-57699766924A}"/>
               </a:ext>
             </a:extLst>
           </p:cNvPr>
@@ -5395,7 +5554,7 @@
           <p:cNvPr id="14" name="">
             <a:extLst xmlns:a="http://schemas.openxmlformats.org/drawingml/2006/main">
               <a:ext uri="{FF2B5EF4-FFF2-40B4-BE49-F238E27FC236}">
-                <a16:creationId xmlns:a16="http://schemas.microsoft.com/office/drawing/2014/main" id="{2CAD6783-66FE-4B37-A666-39AF787F5952}"/>
+                <a16:creationId xmlns:a16="http://schemas.microsoft.com/office/drawing/2014/main" id="{12F195F2-9F67-4EA2-A0BB-0AD406732525}"/>
               </a:ext>
             </a:extLst>
           </p:cNvPr>
@@ -5445,7 +5604,7 @@
           <p:cNvPr id="15" name="">
             <a:extLst xmlns:a="http://schemas.openxmlformats.org/drawingml/2006/main">
               <a:ext uri="{FF2B5EF4-FFF2-40B4-BE49-F238E27FC236}">
-                <a16:creationId xmlns:a16="http://schemas.microsoft.com/office/drawing/2014/main" id="{1478899E-89D6-4535-9BB4-3B1264C24256}"/>
+                <a16:creationId xmlns:a16="http://schemas.microsoft.com/office/drawing/2014/main" id="{B2CC6B07-C0A2-4173-AC32-976330EF3541}"/>
               </a:ext>
             </a:extLst>
           </p:cNvPr>
@@ -5493,7 +5652,7 @@
     </p:spTree>
     <p:extLst>
       <p:ext uri="{BB962C8B-B14F-4D97-AF65-F5344CB8AC3E}">
-        <p14:creationId xmlns:p14="http://schemas.microsoft.com/office/powerpoint/2010/main" val="1559295212"/>
+        <p14:creationId xmlns:p14="http://schemas.microsoft.com/office/powerpoint/2010/main" val="1539242775"/>
       </p:ext>
     </p:extLst>
   </p:cSld>
@@ -5524,7 +5683,7 @@
           <p:cNvPr id="1" name="">
             <a:extLst xmlns:a="http://schemas.openxmlformats.org/drawingml/2006/main">
               <a:ext uri="{FF2B5EF4-FFF2-40B4-BE49-F238E27FC236}">
-                <a16:creationId xmlns:a16="http://schemas.microsoft.com/office/drawing/2014/main" id="{FA4AAC4B-130D-4CA1-8E87-83EA49CF65C1}"/>
+                <a16:creationId xmlns:a16="http://schemas.microsoft.com/office/drawing/2014/main" id="{E6C4C5F6-CA13-4E04-9797-FD66CA8B92B2}"/>
               </a:ext>
             </a:extLst>
           </p:cNvPr>
@@ -5574,7 +5733,7 @@
           <p:cNvPr id="2" name="">
             <a:extLst xmlns:a="http://schemas.openxmlformats.org/drawingml/2006/main">
               <a:ext uri="{FF2B5EF4-FFF2-40B4-BE49-F238E27FC236}">
-                <a16:creationId xmlns:a16="http://schemas.microsoft.com/office/drawing/2014/main" id="{643FCA80-608E-4DE1-B6F1-F4257C2E2406}"/>
+                <a16:creationId xmlns:a16="http://schemas.microsoft.com/office/drawing/2014/main" id="{7D711277-4963-4C99-9F10-00FEA674653F}"/>
               </a:ext>
             </a:extLst>
           </p:cNvPr>
@@ -5624,7 +5783,7 @@
           <p:cNvPr id="3" name="">
             <a:extLst xmlns:a="http://schemas.openxmlformats.org/drawingml/2006/main">
               <a:ext uri="{FF2B5EF4-FFF2-40B4-BE49-F238E27FC236}">
-                <a16:creationId xmlns:a16="http://schemas.microsoft.com/office/drawing/2014/main" id="{B5288273-5502-4C93-9590-CF9B9BD56439}"/>
+                <a16:creationId xmlns:a16="http://schemas.microsoft.com/office/drawing/2014/main" id="{F36DA50B-03EB-4738-B3B7-F2D96CA6FC33}"/>
               </a:ext>
             </a:extLst>
           </p:cNvPr>
@@ -5657,7 +5816,7 @@
           <p:cNvPr id="4" name="">
             <a:extLst xmlns:a="http://schemas.openxmlformats.org/drawingml/2006/main">
               <a:ext uri="{FF2B5EF4-FFF2-40B4-BE49-F238E27FC236}">
-                <a16:creationId xmlns:a16="http://schemas.microsoft.com/office/drawing/2014/main" id="{84D88232-4DD9-428D-B5C4-9126E4B533A7}"/>
+                <a16:creationId xmlns:a16="http://schemas.microsoft.com/office/drawing/2014/main" id="{BF77F44B-652C-4C1C-90B1-F6347CCAEE8A}"/>
               </a:ext>
             </a:extLst>
           </p:cNvPr>
@@ -5707,7 +5866,7 @@
           <p:cNvPr id="5" name="">
             <a:extLst xmlns:a="http://schemas.openxmlformats.org/drawingml/2006/main">
               <a:ext uri="{FF2B5EF4-FFF2-40B4-BE49-F238E27FC236}">
-                <a16:creationId xmlns:a16="http://schemas.microsoft.com/office/drawing/2014/main" id="{48B8DA44-FBF1-4732-96F8-7A3F4BE1C7AF}"/>
+                <a16:creationId xmlns:a16="http://schemas.microsoft.com/office/drawing/2014/main" id="{B27A469F-BDC9-4450-86C8-2A44AEA847AE}"/>
               </a:ext>
             </a:extLst>
           </p:cNvPr>
@@ -5747,7 +5906,7 @@
                   <a:srgbClr val="111111"/>
                 </a:solidFill>
               </a:rPr>
-              <a:t>Without intervention, the portfolio is likely to stay red-heavy next month because delay, cost, and blocker pressure are all elevated at the same time.</a:t>
+              <a:t>The portfolio should remain mixed next month, but several amber projects could still move red if recovery plans are not enforced.</a:t>
             </a:r>
           </a:p>
         </p:txBody>
@@ -5757,7 +5916,7 @@
           <p:cNvPr id="6" name="">
             <a:extLst xmlns:a="http://schemas.openxmlformats.org/drawingml/2006/main">
               <a:ext uri="{FF2B5EF4-FFF2-40B4-BE49-F238E27FC236}">
-                <a16:creationId xmlns:a16="http://schemas.microsoft.com/office/drawing/2014/main" id="{8402C23A-0F44-4523-B637-55EB21545AF2}"/>
+                <a16:creationId xmlns:a16="http://schemas.microsoft.com/office/drawing/2014/main" id="{1F499FC4-BD6D-4570-9FE0-C6681861F524}"/>
               </a:ext>
             </a:extLst>
           </p:cNvPr>
@@ -5790,7 +5949,7 @@
           <p:cNvPr id="7" name="">
             <a:extLst xmlns:a="http://schemas.openxmlformats.org/drawingml/2006/main">
               <a:ext uri="{FF2B5EF4-FFF2-40B4-BE49-F238E27FC236}">
-                <a16:creationId xmlns:a16="http://schemas.microsoft.com/office/drawing/2014/main" id="{F5F6274D-6993-4DE0-BC7D-63973CD3AC10}"/>
+                <a16:creationId xmlns:a16="http://schemas.microsoft.com/office/drawing/2014/main" id="{8FE4CE85-3ADF-4EC2-89DF-7C91B8306603}"/>
               </a:ext>
             </a:extLst>
           </p:cNvPr>
@@ -5840,7 +5999,7 @@
           <p:cNvPr id="8" name="">
             <a:extLst xmlns:a="http://schemas.openxmlformats.org/drawingml/2006/main">
               <a:ext uri="{FF2B5EF4-FFF2-40B4-BE49-F238E27FC236}">
-                <a16:creationId xmlns:a16="http://schemas.microsoft.com/office/drawing/2014/main" id="{D5901ACF-62F0-442F-88B9-5126128EC22C}"/>
+                <a16:creationId xmlns:a16="http://schemas.microsoft.com/office/drawing/2014/main" id="{1A4765BF-AA67-4209-93E4-8D7BE4FF52A8}"/>
               </a:ext>
             </a:extLst>
           </p:cNvPr>
@@ -5880,7 +6039,7 @@
                   <a:srgbClr val="111111"/>
                 </a:solidFill>
               </a:rPr>
-              <a:t>1. Re-baselining the top five red projects should slow further schedule deterioration across the 1 projects already delayed by more than 14 days.</a:t>
+              <a:t>1. Re-baselining the top five red projects should slow further schedule deterioration across the 2 projects already delayed by more than 14 days.</a:t>
             </a:r>
           </a:p>
           <a:p xmlns:a="http://schemas.openxmlformats.org/drawingml/2006/main">
@@ -5902,7 +6061,7 @@
                   <a:srgbClr val="111111"/>
                 </a:solidFill>
               </a:rPr>
-              <a:t>2. A tighter burn-versus-progress review should help contain the 0 projects currently spending ahead of delivery progress.</a:t>
+              <a:t>2. A tighter burn-versus-progress review should help contain the 5 projects currently spending ahead of delivery progress.</a:t>
             </a:r>
           </a:p>
           <a:p xmlns:a="http://schemas.openxmlformats.org/drawingml/2006/main">
@@ -5924,7 +6083,7 @@
                   <a:srgbClr val="111111"/>
                 </a:solidFill>
               </a:rPr>
-              <a:t>3. Daily blocker escalation and better status hygiene should improve confidence on the 0 heavily blocked projects and narrow the 0.4-point reporting gap in Zycus - UniSan S2P Implementation.</a:t>
+              <a:t>3. Daily blocker escalation and better status hygiene should improve confidence on the 3 heavily blocked projects and narrow the 0.0-point reporting gap in the leading red project.</a:t>
             </a:r>
           </a:p>
         </p:txBody>
@@ -5934,7 +6093,7 @@
           <p:cNvPr id="9" name="">
             <a:extLst xmlns:a="http://schemas.openxmlformats.org/drawingml/2006/main">
               <a:ext uri="{FF2B5EF4-FFF2-40B4-BE49-F238E27FC236}">
-                <a16:creationId xmlns:a16="http://schemas.microsoft.com/office/drawing/2014/main" id="{069AB757-B554-46F5-B359-1830AFF6A6CD}"/>
+                <a16:creationId xmlns:a16="http://schemas.microsoft.com/office/drawing/2014/main" id="{3A63C5F1-360F-4614-BAC8-54F4143C3948}"/>
               </a:ext>
             </a:extLst>
           </p:cNvPr>
@@ -5974,7 +6133,7 @@
                   <a:srgbClr val="111111"/>
                 </a:solidFill>
               </a:rPr>
-              <a:t>Project Plan B should stay on the watchlist next month because it remains Red and still carries a 0-point gap between weekly and task-level progress.</a:t>
+              <a:t>Project Plan B should stay on the watchlist next month because it remains undefined and still carries a 0-point gap between weekly and task-level progress.</a:t>
             </a:r>
           </a:p>
         </p:txBody>
@@ -5984,7 +6143,7 @@
           <p:cNvPr id="10" name="">
             <a:extLst xmlns:a="http://schemas.openxmlformats.org/drawingml/2006/main">
               <a:ext uri="{FF2B5EF4-FFF2-40B4-BE49-F238E27FC236}">
-                <a16:creationId xmlns:a16="http://schemas.microsoft.com/office/drawing/2014/main" id="{5A84E0A1-39CD-47A2-B4DE-3154F808396B}"/>
+                <a16:creationId xmlns:a16="http://schemas.microsoft.com/office/drawing/2014/main" id="{302577C0-F6C1-4C77-81C0-38003DD62AED}"/>
               </a:ext>
             </a:extLst>
           </p:cNvPr>
@@ -6032,7 +6191,7 @@
     </p:spTree>
     <p:extLst>
       <p:ext uri="{BB962C8B-B14F-4D97-AF65-F5344CB8AC3E}">
-        <p14:creationId xmlns:p14="http://schemas.microsoft.com/office/powerpoint/2010/main" val="1036628094"/>
+        <p14:creationId xmlns:p14="http://schemas.microsoft.com/office/powerpoint/2010/main" val="1326743009"/>
       </p:ext>
     </p:extLst>
   </p:cSld>

</xml_diff>

<commit_message>
last check the pptx file will automatically update or not
</commit_message>
<xml_diff>
--- a/deliverables/monthly_executive_deck.pptx
+++ b/deliverables/monthly_executive_deck.pptx
@@ -2,18 +2,18 @@
 <file path=ppt/presentation.xml><?xml version="1.0" encoding="utf-8"?>
 <p:presentation xmlns:p="http://schemas.openxmlformats.org/presentationml/2006/main">
   <p:sldMasterIdLst>
-    <p:sldMasterId xmlns:r="http://schemas.openxmlformats.org/officeDocument/2006/relationships" id="2147483648" r:id="R111512d8cb144b6f"/>
+    <p:sldMasterId xmlns:r="http://schemas.openxmlformats.org/officeDocument/2006/relationships" id="2147483648" r:id="R565ed5bcb63b4bdf"/>
   </p:sldMasterIdLst>
   <p:notesMasterIdLst>
-    <p:notesMasterId xmlns:r="http://schemas.openxmlformats.org/officeDocument/2006/relationships" r:id="R2025deea10dd4dc1"/>
+    <p:notesMasterId xmlns:r="http://schemas.openxmlformats.org/officeDocument/2006/relationships" r:id="R8e02a1af5e5147c5"/>
   </p:notesMasterIdLst>
   <p:sldIdLst>
-    <p:sldId xmlns:r="http://schemas.openxmlformats.org/officeDocument/2006/relationships" id="256" r:id="Ra9ee94e558324245"/>
-    <p:sldId xmlns:r="http://schemas.openxmlformats.org/officeDocument/2006/relationships" id="257" r:id="Rdc77970fa20a4f57"/>
-    <p:sldId xmlns:r="http://schemas.openxmlformats.org/officeDocument/2006/relationships" id="258" r:id="R526c832ad92849ba"/>
-    <p:sldId xmlns:r="http://schemas.openxmlformats.org/officeDocument/2006/relationships" id="259" r:id="R5c6885a53fe349b9"/>
-    <p:sldId xmlns:r="http://schemas.openxmlformats.org/officeDocument/2006/relationships" id="260" r:id="R691fc1cc77294ef0"/>
-    <p:sldId xmlns:r="http://schemas.openxmlformats.org/officeDocument/2006/relationships" id="261" r:id="R3626d2f91f694b2b"/>
+    <p:sldId xmlns:r="http://schemas.openxmlformats.org/officeDocument/2006/relationships" id="256" r:id="Ra121c8bd052f49ae"/>
+    <p:sldId xmlns:r="http://schemas.openxmlformats.org/officeDocument/2006/relationships" id="257" r:id="R4ab14d5bb97f4f3b"/>
+    <p:sldId xmlns:r="http://schemas.openxmlformats.org/officeDocument/2006/relationships" id="258" r:id="Ra60d4e7917684d3e"/>
+    <p:sldId xmlns:r="http://schemas.openxmlformats.org/officeDocument/2006/relationships" id="259" r:id="R43d159776cae4557"/>
+    <p:sldId xmlns:r="http://schemas.openxmlformats.org/officeDocument/2006/relationships" id="260" r:id="R8356fc7432c04d19"/>
+    <p:sldId xmlns:r="http://schemas.openxmlformats.org/officeDocument/2006/relationships" id="261" r:id="Rb6764d34ae2340a8"/>
   </p:sldIdLst>
   <p:sldSz cx="12192000" cy="6858000"/>
   <p:notesSz cx="6858000" cy="9144000"/>
@@ -936,7 +936,7 @@
   </p:cSld>
   <p:clrMap bg1="lt1" tx1="dk1" bg2="lt2" tx2="dk2" accent1="accent1" accent2="accent2" accent3="accent3" accent4="accent4" accent5="accent5" accent6="accent6" hlink="hlink" folHlink="folHlink"/>
   <p:sldLayoutIdLst>
-    <p:sldLayoutId xmlns:r="http://schemas.openxmlformats.org/officeDocument/2006/relationships" id="2147483649" r:id="R9e5b25b5251042d8"/>
+    <p:sldLayoutId xmlns:r="http://schemas.openxmlformats.org/officeDocument/2006/relationships" id="2147483649" r:id="R8e8db3ad71df4afc"/>
   </p:sldLayoutIdLst>
   <p:txStyles>
     <p:titleStyle>
@@ -1487,7 +1487,7 @@
           <p:cNvPr id="1" name="">
             <a:extLst xmlns:a="http://schemas.openxmlformats.org/drawingml/2006/main">
               <a:ext uri="{FF2B5EF4-FFF2-40B4-BE49-F238E27FC236}">
-                <a16:creationId xmlns:a16="http://schemas.microsoft.com/office/drawing/2014/main" id="{165B3980-0F2B-4E2D-B31F-B71B7AB93510}"/>
+                <a16:creationId xmlns:a16="http://schemas.microsoft.com/office/drawing/2014/main" id="{F54A25EC-A2EB-4BE5-B7FC-C96B5D11269B}"/>
               </a:ext>
             </a:extLst>
           </p:cNvPr>
@@ -1537,7 +1537,7 @@
           <p:cNvPr id="2" name="">
             <a:extLst xmlns:a="http://schemas.openxmlformats.org/drawingml/2006/main">
               <a:ext uri="{FF2B5EF4-FFF2-40B4-BE49-F238E27FC236}">
-                <a16:creationId xmlns:a16="http://schemas.microsoft.com/office/drawing/2014/main" id="{39CFA03C-EA6F-4F81-BED2-4F4972940CD1}"/>
+                <a16:creationId xmlns:a16="http://schemas.microsoft.com/office/drawing/2014/main" id="{7AA4D959-5022-45D6-ACDF-A6EC08FE8B08}"/>
               </a:ext>
             </a:extLst>
           </p:cNvPr>
@@ -1587,7 +1587,7 @@
           <p:cNvPr id="3" name="">
             <a:extLst xmlns:a="http://schemas.openxmlformats.org/drawingml/2006/main">
               <a:ext uri="{FF2B5EF4-FFF2-40B4-BE49-F238E27FC236}">
-                <a16:creationId xmlns:a16="http://schemas.microsoft.com/office/drawing/2014/main" id="{EB9712AA-1907-432F-9E60-F138833075EF}"/>
+                <a16:creationId xmlns:a16="http://schemas.microsoft.com/office/drawing/2014/main" id="{47D6FE76-66F3-4A1F-9F8E-D0088DE42DB2}"/>
               </a:ext>
             </a:extLst>
           </p:cNvPr>
@@ -1620,7 +1620,7 @@
           <p:cNvPr id="4" name="">
             <a:extLst xmlns:a="http://schemas.openxmlformats.org/drawingml/2006/main">
               <a:ext uri="{FF2B5EF4-FFF2-40B4-BE49-F238E27FC236}">
-                <a16:creationId xmlns:a16="http://schemas.microsoft.com/office/drawing/2014/main" id="{018EFFF7-4151-4F9C-AF49-63FA6842492D}"/>
+                <a16:creationId xmlns:a16="http://schemas.microsoft.com/office/drawing/2014/main" id="{07625347-A499-4ABF-A324-8586D1446AF3}"/>
               </a:ext>
             </a:extLst>
           </p:cNvPr>
@@ -1660,7 +1660,7 @@
                   <a:srgbClr val="111111"/>
                 </a:solidFill>
               </a:rPr>
-              <a:t>8</a:t>
+              <a:t>3</a:t>
             </a:r>
           </a:p>
         </p:txBody>
@@ -1670,7 +1670,7 @@
           <p:cNvPr id="5" name="">
             <a:extLst xmlns:a="http://schemas.openxmlformats.org/drawingml/2006/main">
               <a:ext uri="{FF2B5EF4-FFF2-40B4-BE49-F238E27FC236}">
-                <a16:creationId xmlns:a16="http://schemas.microsoft.com/office/drawing/2014/main" id="{A564ED85-E7CC-47CB-AAC2-DF6E554C022D}"/>
+                <a16:creationId xmlns:a16="http://schemas.microsoft.com/office/drawing/2014/main" id="{8AAF2258-F544-418D-9652-1E68CD1B46F9}"/>
               </a:ext>
             </a:extLst>
           </p:cNvPr>
@@ -1720,7 +1720,7 @@
           <p:cNvPr id="6" name="">
             <a:extLst xmlns:a="http://schemas.openxmlformats.org/drawingml/2006/main">
               <a:ext uri="{FF2B5EF4-FFF2-40B4-BE49-F238E27FC236}">
-                <a16:creationId xmlns:a16="http://schemas.microsoft.com/office/drawing/2014/main" id="{026E1EB9-7A90-419B-94CA-486B2FF3EFA2}"/>
+                <a16:creationId xmlns:a16="http://schemas.microsoft.com/office/drawing/2014/main" id="{30CD6A9E-E2FC-4903-A0B6-121EE0126D0D}"/>
               </a:ext>
             </a:extLst>
           </p:cNvPr>
@@ -1753,7 +1753,7 @@
           <p:cNvPr id="7" name="">
             <a:extLst xmlns:a="http://schemas.openxmlformats.org/drawingml/2006/main">
               <a:ext uri="{FF2B5EF4-FFF2-40B4-BE49-F238E27FC236}">
-                <a16:creationId xmlns:a16="http://schemas.microsoft.com/office/drawing/2014/main" id="{F53C5D7D-3525-46EC-B7DA-486A8B7AF149}"/>
+                <a16:creationId xmlns:a16="http://schemas.microsoft.com/office/drawing/2014/main" id="{527DF534-1803-46EB-A806-213BBC34E592}"/>
               </a:ext>
             </a:extLst>
           </p:cNvPr>
@@ -1803,7 +1803,7 @@
           <p:cNvPr id="8" name="">
             <a:extLst xmlns:a="http://schemas.openxmlformats.org/drawingml/2006/main">
               <a:ext uri="{FF2B5EF4-FFF2-40B4-BE49-F238E27FC236}">
-                <a16:creationId xmlns:a16="http://schemas.microsoft.com/office/drawing/2014/main" id="{3C073969-4B0C-499D-A0D0-66185FEDDD26}"/>
+                <a16:creationId xmlns:a16="http://schemas.microsoft.com/office/drawing/2014/main" id="{6D1B4965-8CD4-459C-9283-37502B1D9A17}"/>
               </a:ext>
             </a:extLst>
           </p:cNvPr>
@@ -1853,7 +1853,7 @@
           <p:cNvPr id="9" name="">
             <a:extLst xmlns:a="http://schemas.openxmlformats.org/drawingml/2006/main">
               <a:ext uri="{FF2B5EF4-FFF2-40B4-BE49-F238E27FC236}">
-                <a16:creationId xmlns:a16="http://schemas.microsoft.com/office/drawing/2014/main" id="{44057E15-FAB1-468D-88BB-6C42C560FE2A}"/>
+                <a16:creationId xmlns:a16="http://schemas.microsoft.com/office/drawing/2014/main" id="{93B9EE5D-8265-413F-8208-A09028DE0F80}"/>
               </a:ext>
             </a:extLst>
           </p:cNvPr>
@@ -1886,7 +1886,7 @@
           <p:cNvPr id="10" name="">
             <a:extLst xmlns:a="http://schemas.openxmlformats.org/drawingml/2006/main">
               <a:ext uri="{FF2B5EF4-FFF2-40B4-BE49-F238E27FC236}">
-                <a16:creationId xmlns:a16="http://schemas.microsoft.com/office/drawing/2014/main" id="{6C21F8FC-9D13-453F-9206-C069B049FCC4}"/>
+                <a16:creationId xmlns:a16="http://schemas.microsoft.com/office/drawing/2014/main" id="{A497BD07-4B49-4371-A38E-0ABD0037367F}"/>
               </a:ext>
             </a:extLst>
           </p:cNvPr>
@@ -1926,7 +1926,7 @@
                   <a:srgbClr val="111111"/>
                 </a:solidFill>
               </a:rPr>
-              <a:t>2</a:t>
+              <a:t>0</a:t>
             </a:r>
           </a:p>
         </p:txBody>
@@ -1936,7 +1936,7 @@
           <p:cNvPr id="11" name="">
             <a:extLst xmlns:a="http://schemas.openxmlformats.org/drawingml/2006/main">
               <a:ext uri="{FF2B5EF4-FFF2-40B4-BE49-F238E27FC236}">
-                <a16:creationId xmlns:a16="http://schemas.microsoft.com/office/drawing/2014/main" id="{6103016F-8DD9-43CF-9CFF-926B218FABBA}"/>
+                <a16:creationId xmlns:a16="http://schemas.microsoft.com/office/drawing/2014/main" id="{030BC256-2DA6-4C48-BB3C-CBD9636B4422}"/>
               </a:ext>
             </a:extLst>
           </p:cNvPr>
@@ -1986,7 +1986,7 @@
           <p:cNvPr id="12" name="">
             <a:extLst xmlns:a="http://schemas.openxmlformats.org/drawingml/2006/main">
               <a:ext uri="{FF2B5EF4-FFF2-40B4-BE49-F238E27FC236}">
-                <a16:creationId xmlns:a16="http://schemas.microsoft.com/office/drawing/2014/main" id="{C68D055C-21C4-4CBD-8CC7-788E7FB55080}"/>
+                <a16:creationId xmlns:a16="http://schemas.microsoft.com/office/drawing/2014/main" id="{F7EBF64A-31E3-4885-9CA3-E1976F6AB164}"/>
               </a:ext>
             </a:extLst>
           </p:cNvPr>
@@ -2019,7 +2019,7 @@
           <p:cNvPr id="13" name="">
             <a:extLst xmlns:a="http://schemas.openxmlformats.org/drawingml/2006/main">
               <a:ext uri="{FF2B5EF4-FFF2-40B4-BE49-F238E27FC236}">
-                <a16:creationId xmlns:a16="http://schemas.microsoft.com/office/drawing/2014/main" id="{39A93A1C-2F30-4177-96F2-A5910D8583C0}"/>
+                <a16:creationId xmlns:a16="http://schemas.microsoft.com/office/drawing/2014/main" id="{36D319DD-8877-470E-B6B5-0922EEF2E0EB}"/>
               </a:ext>
             </a:extLst>
           </p:cNvPr>
@@ -2059,7 +2059,7 @@
                   <a:srgbClr val="D9481C"/>
                 </a:solidFill>
               </a:rPr>
-              <a:t>5</a:t>
+              <a:t>2</a:t>
             </a:r>
           </a:p>
         </p:txBody>
@@ -2069,7 +2069,7 @@
           <p:cNvPr id="14" name="">
             <a:extLst xmlns:a="http://schemas.openxmlformats.org/drawingml/2006/main">
               <a:ext uri="{FF2B5EF4-FFF2-40B4-BE49-F238E27FC236}">
-                <a16:creationId xmlns:a16="http://schemas.microsoft.com/office/drawing/2014/main" id="{3250D225-B726-4FB2-BA04-9638ABF8A000}"/>
+                <a16:creationId xmlns:a16="http://schemas.microsoft.com/office/drawing/2014/main" id="{213EAB1F-264A-4A21-9551-DC94BB9D9EFE}"/>
               </a:ext>
             </a:extLst>
           </p:cNvPr>
@@ -2119,7 +2119,7 @@
           <p:cNvPr id="15" name="">
             <a:extLst xmlns:a="http://schemas.openxmlformats.org/drawingml/2006/main">
               <a:ext uri="{FF2B5EF4-FFF2-40B4-BE49-F238E27FC236}">
-                <a16:creationId xmlns:a16="http://schemas.microsoft.com/office/drawing/2014/main" id="{265E3461-6807-48BC-905D-099B52171E58}"/>
+                <a16:creationId xmlns:a16="http://schemas.microsoft.com/office/drawing/2014/main" id="{15DB2955-39CC-4722-B348-AB6B499CAD71}"/>
               </a:ext>
             </a:extLst>
           </p:cNvPr>
@@ -2152,7 +2152,7 @@
           <p:cNvPr id="16" name="">
             <a:extLst xmlns:a="http://schemas.openxmlformats.org/drawingml/2006/main">
               <a:ext uri="{FF2B5EF4-FFF2-40B4-BE49-F238E27FC236}">
-                <a16:creationId xmlns:a16="http://schemas.microsoft.com/office/drawing/2014/main" id="{EB4B0D30-8FEF-4A51-AE44-B0AAB3DA36BE}"/>
+                <a16:creationId xmlns:a16="http://schemas.microsoft.com/office/drawing/2014/main" id="{A3ED4DC4-5F6E-471E-B8B5-A9580709C5D1}"/>
               </a:ext>
             </a:extLst>
           </p:cNvPr>
@@ -2192,7 +2192,7 @@
                   <a:srgbClr val="111111"/>
                 </a:solidFill>
               </a:rPr>
-              <a:t>62.5% of analyzed views are currently red, which indicates that schedule recovery and execution control need executive attention before the next client reporting cycle.</a:t>
+              <a:t>66.7% of analyzed views are currently red, which indicates that schedule recovery and execution control need executive attention before the next client reporting cycle.</a:t>
             </a:r>
           </a:p>
         </p:txBody>
@@ -2202,7 +2202,7 @@
           <p:cNvPr id="17" name="">
             <a:extLst xmlns:a="http://schemas.openxmlformats.org/drawingml/2006/main">
               <a:ext uri="{FF2B5EF4-FFF2-40B4-BE49-F238E27FC236}">
-                <a16:creationId xmlns:a16="http://schemas.microsoft.com/office/drawing/2014/main" id="{A963FC3F-D53A-4F2C-A4D5-BEF64716DE51}"/>
+                <a16:creationId xmlns:a16="http://schemas.microsoft.com/office/drawing/2014/main" id="{15B3DF30-C9EB-4154-A3FF-CFEEA52DED09}"/>
               </a:ext>
             </a:extLst>
           </p:cNvPr>
@@ -2235,7 +2235,7 @@
           <p:cNvPr id="18" name="">
             <a:extLst xmlns:a="http://schemas.openxmlformats.org/drawingml/2006/main">
               <a:ext uri="{FF2B5EF4-FFF2-40B4-BE49-F238E27FC236}">
-                <a16:creationId xmlns:a16="http://schemas.microsoft.com/office/drawing/2014/main" id="{7B437CA1-C9B6-4813-A681-5DBE2DFA620C}"/>
+                <a16:creationId xmlns:a16="http://schemas.microsoft.com/office/drawing/2014/main" id="{FC1D6686-7BCC-48C6-91C9-173015AA13E6}"/>
               </a:ext>
             </a:extLst>
           </p:cNvPr>
@@ -2285,7 +2285,7 @@
           <p:cNvPr id="19" name="">
             <a:extLst xmlns:a="http://schemas.openxmlformats.org/drawingml/2006/main">
               <a:ext uri="{FF2B5EF4-FFF2-40B4-BE49-F238E27FC236}">
-                <a16:creationId xmlns:a16="http://schemas.microsoft.com/office/drawing/2014/main" id="{0A6722C7-D07B-41EA-B113-FB0804F3ADA5}"/>
+                <a16:creationId xmlns:a16="http://schemas.microsoft.com/office/drawing/2014/main" id="{6CFE743F-8F0D-4D76-A861-1BEA44CD686C}"/>
               </a:ext>
             </a:extLst>
           </p:cNvPr>
@@ -2379,7 +2379,7 @@
           <p:cNvPr id="20" name="">
             <a:extLst xmlns:a="http://schemas.openxmlformats.org/drawingml/2006/main">
               <a:ext uri="{FF2B5EF4-FFF2-40B4-BE49-F238E27FC236}">
-                <a16:creationId xmlns:a16="http://schemas.microsoft.com/office/drawing/2014/main" id="{867CE744-DE52-4286-8510-D825F9949253}"/>
+                <a16:creationId xmlns:a16="http://schemas.microsoft.com/office/drawing/2014/main" id="{1AF3E434-1CCB-4A5E-BAA4-F7306FAAFC1D}"/>
               </a:ext>
             </a:extLst>
           </p:cNvPr>
@@ -2427,7 +2427,7 @@
     </p:spTree>
     <p:extLst>
       <p:ext uri="{BB962C8B-B14F-4D97-AF65-F5344CB8AC3E}">
-        <p14:creationId xmlns:p14="http://schemas.microsoft.com/office/powerpoint/2010/main" val="666396884"/>
+        <p14:creationId xmlns:p14="http://schemas.microsoft.com/office/powerpoint/2010/main" val="1789648897"/>
       </p:ext>
     </p:extLst>
   </p:cSld>
@@ -2458,7 +2458,7 @@
           <p:cNvPr id="1" name="">
             <a:extLst xmlns:a="http://schemas.openxmlformats.org/drawingml/2006/main">
               <a:ext uri="{FF2B5EF4-FFF2-40B4-BE49-F238E27FC236}">
-                <a16:creationId xmlns:a16="http://schemas.microsoft.com/office/drawing/2014/main" id="{3A304806-866C-4858-B379-CF4ADCD6F48E}"/>
+                <a16:creationId xmlns:a16="http://schemas.microsoft.com/office/drawing/2014/main" id="{3443A65A-A93C-423E-BC40-24134B392366}"/>
               </a:ext>
             </a:extLst>
           </p:cNvPr>
@@ -2508,7 +2508,7 @@
           <p:cNvPr id="2" name="">
             <a:extLst xmlns:a="http://schemas.openxmlformats.org/drawingml/2006/main">
               <a:ext uri="{FF2B5EF4-FFF2-40B4-BE49-F238E27FC236}">
-                <a16:creationId xmlns:a16="http://schemas.microsoft.com/office/drawing/2014/main" id="{EDFF285E-05E5-4FFB-9213-BC10CCA5DBB1}"/>
+                <a16:creationId xmlns:a16="http://schemas.microsoft.com/office/drawing/2014/main" id="{5330A292-9260-4ECB-9374-8B25F402A116}"/>
               </a:ext>
             </a:extLst>
           </p:cNvPr>
@@ -2558,7 +2558,7 @@
           <p:cNvPr id="3" name="">
             <a:extLst xmlns:a="http://schemas.openxmlformats.org/drawingml/2006/main">
               <a:ext uri="{FF2B5EF4-FFF2-40B4-BE49-F238E27FC236}">
-                <a16:creationId xmlns:a16="http://schemas.microsoft.com/office/drawing/2014/main" id="{396483BD-2373-47DF-9B61-02AE98A6A892}"/>
+                <a16:creationId xmlns:a16="http://schemas.microsoft.com/office/drawing/2014/main" id="{D9263C40-1EEC-4CF4-8077-BEC1F4FD2CF1}"/>
               </a:ext>
             </a:extLst>
           </p:cNvPr>
@@ -2591,7 +2591,7 @@
           <p:cNvPr id="4" name="">
             <a:extLst xmlns:a="http://schemas.openxmlformats.org/drawingml/2006/main">
               <a:ext uri="{FF2B5EF4-FFF2-40B4-BE49-F238E27FC236}">
-                <a16:creationId xmlns:a16="http://schemas.microsoft.com/office/drawing/2014/main" id="{0FB1748F-1FAF-494B-856B-AE64C897F5F9}"/>
+                <a16:creationId xmlns:a16="http://schemas.microsoft.com/office/drawing/2014/main" id="{0F7CC4FA-9B79-41B6-BBD6-3E520CC8ED30}"/>
               </a:ext>
             </a:extLst>
           </p:cNvPr>
@@ -2641,7 +2641,7 @@
           <p:cNvPr id="5" name="">
             <a:extLst xmlns:a="http://schemas.openxmlformats.org/drawingml/2006/main">
               <a:ext uri="{FF2B5EF4-FFF2-40B4-BE49-F238E27FC236}">
-                <a16:creationId xmlns:a16="http://schemas.microsoft.com/office/drawing/2014/main" id="{AA0F0325-EE69-4896-A5FD-263BFF5859F2}"/>
+                <a16:creationId xmlns:a16="http://schemas.microsoft.com/office/drawing/2014/main" id="{8D129480-6446-4ACD-9BC6-E2DC57192A3C}"/>
               </a:ext>
             </a:extLst>
           </p:cNvPr>
@@ -2674,7 +2674,7 @@
           <p:cNvPr id="6" name="">
             <a:extLst xmlns:a="http://schemas.openxmlformats.org/drawingml/2006/main">
               <a:ext uri="{FF2B5EF4-FFF2-40B4-BE49-F238E27FC236}">
-                <a16:creationId xmlns:a16="http://schemas.microsoft.com/office/drawing/2014/main" id="{74BB3516-F627-4F68-A5FB-2DD0E9BD915A}"/>
+                <a16:creationId xmlns:a16="http://schemas.microsoft.com/office/drawing/2014/main" id="{0235B356-A060-4620-9EE8-173D57DAEC93}"/>
               </a:ext>
             </a:extLst>
           </p:cNvPr>
@@ -2724,7 +2724,7 @@
           <p:cNvPr id="7" name="">
             <a:extLst xmlns:a="http://schemas.openxmlformats.org/drawingml/2006/main">
               <a:ext uri="{FF2B5EF4-FFF2-40B4-BE49-F238E27FC236}">
-                <a16:creationId xmlns:a16="http://schemas.microsoft.com/office/drawing/2014/main" id="{FF9A8173-9D9C-406B-AC36-DF3F8EA71298}"/>
+                <a16:creationId xmlns:a16="http://schemas.microsoft.com/office/drawing/2014/main" id="{DB2958B3-D59C-46B7-9D7B-638076648D8F}"/>
               </a:ext>
             </a:extLst>
           </p:cNvPr>
@@ -2774,7 +2774,7 @@
           <p:cNvPr id="8" name="">
             <a:extLst xmlns:a="http://schemas.openxmlformats.org/drawingml/2006/main">
               <a:ext uri="{FF2B5EF4-FFF2-40B4-BE49-F238E27FC236}">
-                <a16:creationId xmlns:a16="http://schemas.microsoft.com/office/drawing/2014/main" id="{DC179804-F9BF-4794-9A6B-573088BBD8F1}"/>
+                <a16:creationId xmlns:a16="http://schemas.microsoft.com/office/drawing/2014/main" id="{E57662CE-19BE-4B7A-95EE-A9559E62A2FD}"/>
               </a:ext>
             </a:extLst>
           </p:cNvPr>
@@ -2807,7 +2807,7 @@
           <p:cNvPr id="9" name="">
             <a:extLst xmlns:a="http://schemas.openxmlformats.org/drawingml/2006/main">
               <a:ext uri="{FF2B5EF4-FFF2-40B4-BE49-F238E27FC236}">
-                <a16:creationId xmlns:a16="http://schemas.microsoft.com/office/drawing/2014/main" id="{74F8D327-15C1-4B3F-980C-26CA52B4CEB3}"/>
+                <a16:creationId xmlns:a16="http://schemas.microsoft.com/office/drawing/2014/main" id="{F76A06A4-C082-4CBB-81A8-812900783312}"/>
               </a:ext>
             </a:extLst>
           </p:cNvPr>
@@ -2847,7 +2847,7 @@
                   <a:srgbClr val="111111"/>
                 </a:solidFill>
               </a:rPr>
-              <a:t>2</a:t>
+              <a:t>0</a:t>
             </a:r>
           </a:p>
         </p:txBody>
@@ -2857,7 +2857,7 @@
           <p:cNvPr id="10" name="">
             <a:extLst xmlns:a="http://schemas.openxmlformats.org/drawingml/2006/main">
               <a:ext uri="{FF2B5EF4-FFF2-40B4-BE49-F238E27FC236}">
-                <a16:creationId xmlns:a16="http://schemas.microsoft.com/office/drawing/2014/main" id="{26404C3D-36CA-4CFA-90E9-39FDA96046B3}"/>
+                <a16:creationId xmlns:a16="http://schemas.microsoft.com/office/drawing/2014/main" id="{AB224FA4-2B30-44CE-AAA8-87410A511EC5}"/>
               </a:ext>
             </a:extLst>
           </p:cNvPr>
@@ -2907,7 +2907,7 @@
           <p:cNvPr id="11" name="">
             <a:extLst xmlns:a="http://schemas.openxmlformats.org/drawingml/2006/main">
               <a:ext uri="{FF2B5EF4-FFF2-40B4-BE49-F238E27FC236}">
-                <a16:creationId xmlns:a16="http://schemas.microsoft.com/office/drawing/2014/main" id="{99D824A4-8503-44D5-8023-66563D5DC4E7}"/>
+                <a16:creationId xmlns:a16="http://schemas.microsoft.com/office/drawing/2014/main" id="{53E8E77D-D7C3-4B42-B2CF-3FBD8FBAF814}"/>
               </a:ext>
             </a:extLst>
           </p:cNvPr>
@@ -2940,7 +2940,7 @@
           <p:cNvPr id="12" name="">
             <a:extLst xmlns:a="http://schemas.openxmlformats.org/drawingml/2006/main">
               <a:ext uri="{FF2B5EF4-FFF2-40B4-BE49-F238E27FC236}">
-                <a16:creationId xmlns:a16="http://schemas.microsoft.com/office/drawing/2014/main" id="{701B0802-BB9A-45FE-A4A8-65DE1C29D558}"/>
+                <a16:creationId xmlns:a16="http://schemas.microsoft.com/office/drawing/2014/main" id="{1BBC3C00-E722-4373-B591-DFDAA72E3D7C}"/>
               </a:ext>
             </a:extLst>
           </p:cNvPr>
@@ -2980,7 +2980,7 @@
                   <a:srgbClr val="D9481C"/>
                 </a:solidFill>
               </a:rPr>
-              <a:t>5</a:t>
+              <a:t>2</a:t>
             </a:r>
           </a:p>
         </p:txBody>
@@ -2990,7 +2990,7 @@
           <p:cNvPr id="13" name="">
             <a:extLst xmlns:a="http://schemas.openxmlformats.org/drawingml/2006/main">
               <a:ext uri="{FF2B5EF4-FFF2-40B4-BE49-F238E27FC236}">
-                <a16:creationId xmlns:a16="http://schemas.microsoft.com/office/drawing/2014/main" id="{F684A0C0-5C55-431F-B941-98A4F8FD7A20}"/>
+                <a16:creationId xmlns:a16="http://schemas.microsoft.com/office/drawing/2014/main" id="{CFC4B69D-37D4-4A54-8089-DE2ADA1407FA}"/>
               </a:ext>
             </a:extLst>
           </p:cNvPr>
@@ -3040,7 +3040,7 @@
           <p:cNvPr id="14" name="">
             <a:extLst xmlns:a="http://schemas.openxmlformats.org/drawingml/2006/main">
               <a:ext uri="{FF2B5EF4-FFF2-40B4-BE49-F238E27FC236}">
-                <a16:creationId xmlns:a16="http://schemas.microsoft.com/office/drawing/2014/main" id="{1E5555AE-E6B3-470D-940D-6A8B0764512D}"/>
+                <a16:creationId xmlns:a16="http://schemas.microsoft.com/office/drawing/2014/main" id="{B0AC165F-A94A-4B78-A40B-4F3AFD3C555D}"/>
               </a:ext>
             </a:extLst>
           </p:cNvPr>
@@ -3080,7 +3080,7 @@
                   <a:srgbClr val="111111"/>
                 </a:solidFill>
               </a:rPr>
-              <a:t>8 project plans were analyzed in this run, and every current view is red or amber-weighted enough to need active leadership attention.</a:t>
+              <a:t>3 project plans were analyzed in this run, and every current view is red or amber-weighted enough to need active leadership attention.</a:t>
             </a:r>
           </a:p>
         </p:txBody>
@@ -3090,7 +3090,7 @@
           <p:cNvPr id="15" name="">
             <a:extLst xmlns:a="http://schemas.openxmlformats.org/drawingml/2006/main">
               <a:ext uri="{FF2B5EF4-FFF2-40B4-BE49-F238E27FC236}">
-                <a16:creationId xmlns:a16="http://schemas.microsoft.com/office/drawing/2014/main" id="{218D5D32-1725-47E6-972A-6E4A4C1498AD}"/>
+                <a16:creationId xmlns:a16="http://schemas.microsoft.com/office/drawing/2014/main" id="{063A4592-A478-4B47-AF60-4EEB772ECEE6}"/>
               </a:ext>
             </a:extLst>
           </p:cNvPr>
@@ -3123,7 +3123,7 @@
           <p:cNvPr id="16" name="">
             <a:extLst xmlns:a="http://schemas.openxmlformats.org/drawingml/2006/main">
               <a:ext uri="{FF2B5EF4-FFF2-40B4-BE49-F238E27FC236}">
-                <a16:creationId xmlns:a16="http://schemas.microsoft.com/office/drawing/2014/main" id="{9398F22D-2E6E-4020-8B31-744E2988965B}"/>
+                <a16:creationId xmlns:a16="http://schemas.microsoft.com/office/drawing/2014/main" id="{03024638-A8AE-4F7D-BCB0-15F56F48B6A4}"/>
               </a:ext>
             </a:extLst>
           </p:cNvPr>
@@ -3163,7 +3163,7 @@
                   <a:srgbClr val="111111"/>
                 </a:solidFill>
               </a:rPr>
-              <a:t>57.3/100</a:t>
+              <a:t>62.1/100</a:t>
             </a:r>
           </a:p>
         </p:txBody>
@@ -3173,7 +3173,7 @@
           <p:cNvPr id="17" name="">
             <a:extLst xmlns:a="http://schemas.openxmlformats.org/drawingml/2006/main">
               <a:ext uri="{FF2B5EF4-FFF2-40B4-BE49-F238E27FC236}">
-                <a16:creationId xmlns:a16="http://schemas.microsoft.com/office/drawing/2014/main" id="{E3176A9D-CBF7-4B82-9F83-CC4246215266}"/>
+                <a16:creationId xmlns:a16="http://schemas.microsoft.com/office/drawing/2014/main" id="{09F0D468-AE58-4BF1-B515-A9335F6ED043}"/>
               </a:ext>
             </a:extLst>
           </p:cNvPr>
@@ -3223,7 +3223,7 @@
           <p:cNvPr id="18" name="">
             <a:extLst xmlns:a="http://schemas.openxmlformats.org/drawingml/2006/main">
               <a:ext uri="{FF2B5EF4-FFF2-40B4-BE49-F238E27FC236}">
-                <a16:creationId xmlns:a16="http://schemas.microsoft.com/office/drawing/2014/main" id="{246C59D9-FCD7-4C38-AD25-796441FF84A0}"/>
+                <a16:creationId xmlns:a16="http://schemas.microsoft.com/office/drawing/2014/main" id="{2A3EBBD7-ED12-456D-9170-709D252D3CFB}"/>
               </a:ext>
             </a:extLst>
           </p:cNvPr>
@@ -3256,7 +3256,7 @@
           <p:cNvPr id="19" name="">
             <a:extLst xmlns:a="http://schemas.openxmlformats.org/drawingml/2006/main">
               <a:ext uri="{FF2B5EF4-FFF2-40B4-BE49-F238E27FC236}">
-                <a16:creationId xmlns:a16="http://schemas.microsoft.com/office/drawing/2014/main" id="{424C5EAD-8EA3-4778-992E-2FDF81BAB43A}"/>
+                <a16:creationId xmlns:a16="http://schemas.microsoft.com/office/drawing/2014/main" id="{8A1DB778-82CF-40A0-96EE-0418388DF65F}"/>
               </a:ext>
             </a:extLst>
           </p:cNvPr>
@@ -3296,7 +3296,7 @@
                   <a:srgbClr val="D9481C"/>
                 </a:solidFill>
               </a:rPr>
-              <a:t>50%</a:t>
+              <a:t>67%</a:t>
             </a:r>
           </a:p>
         </p:txBody>
@@ -3306,7 +3306,7 @@
           <p:cNvPr id="20" name="">
             <a:extLst xmlns:a="http://schemas.openxmlformats.org/drawingml/2006/main">
               <a:ext uri="{FF2B5EF4-FFF2-40B4-BE49-F238E27FC236}">
-                <a16:creationId xmlns:a16="http://schemas.microsoft.com/office/drawing/2014/main" id="{1B368A5C-39F1-49EA-B02B-D483747419E3}"/>
+                <a16:creationId xmlns:a16="http://schemas.microsoft.com/office/drawing/2014/main" id="{44A32E49-6894-4FB5-85D5-BC5F6AB148BC}"/>
               </a:ext>
             </a:extLst>
           </p:cNvPr>
@@ -3356,7 +3356,7 @@
           <p:cNvPr id="21" name="">
             <a:extLst xmlns:a="http://schemas.openxmlformats.org/drawingml/2006/main">
               <a:ext uri="{FF2B5EF4-FFF2-40B4-BE49-F238E27FC236}">
-                <a16:creationId xmlns:a16="http://schemas.microsoft.com/office/drawing/2014/main" id="{211983A6-7607-4C1F-B450-7C8190E5E404}"/>
+                <a16:creationId xmlns:a16="http://schemas.microsoft.com/office/drawing/2014/main" id="{EA5ACED0-FFA9-4F46-A920-A934C67BD7EE}"/>
               </a:ext>
             </a:extLst>
           </p:cNvPr>
@@ -3396,7 +3396,7 @@
                   <a:srgbClr val="111111"/>
                 </a:solidFill>
               </a:rPr>
-              <a:t>The average score across all 8 analyzed project plans is 57.3/100. Validation against the embedded workbook health labels holds at 50%, which is directionally useful for leadership screening while keeping the reasoning transparent.</a:t>
+              <a:t>The average score across all 3 analyzed project plans is 62.1/100. Validation against the embedded workbook health labels holds at 67%, which is directionally useful for leadership screening while keeping the reasoning transparent.</a:t>
             </a:r>
           </a:p>
         </p:txBody>
@@ -3406,7 +3406,7 @@
           <p:cNvPr id="22" name="">
             <a:extLst xmlns:a="http://schemas.openxmlformats.org/drawingml/2006/main">
               <a:ext uri="{FF2B5EF4-FFF2-40B4-BE49-F238E27FC236}">
-                <a16:creationId xmlns:a16="http://schemas.microsoft.com/office/drawing/2014/main" id="{499D7F45-E164-4DE9-84C4-F40587617837}"/>
+                <a16:creationId xmlns:a16="http://schemas.microsoft.com/office/drawing/2014/main" id="{0F001F3D-3B23-4A78-9F3A-E53DEF74A179}"/>
               </a:ext>
             </a:extLst>
           </p:cNvPr>
@@ -3454,7 +3454,7 @@
     </p:spTree>
     <p:extLst>
       <p:ext uri="{BB962C8B-B14F-4D97-AF65-F5344CB8AC3E}">
-        <p14:creationId xmlns:p14="http://schemas.microsoft.com/office/powerpoint/2010/main" val="116493569"/>
+        <p14:creationId xmlns:p14="http://schemas.microsoft.com/office/powerpoint/2010/main" val="661277098"/>
       </p:ext>
     </p:extLst>
   </p:cSld>
@@ -3485,7 +3485,7 @@
           <p:cNvPr id="1" name="">
             <a:extLst xmlns:a="http://schemas.openxmlformats.org/drawingml/2006/main">
               <a:ext uri="{FF2B5EF4-FFF2-40B4-BE49-F238E27FC236}">
-                <a16:creationId xmlns:a16="http://schemas.microsoft.com/office/drawing/2014/main" id="{D6BC30B9-AE47-4025-B403-6693B4A87DB3}"/>
+                <a16:creationId xmlns:a16="http://schemas.microsoft.com/office/drawing/2014/main" id="{A689F2BF-A3BC-4A86-9FF6-1578C4392F6D}"/>
               </a:ext>
             </a:extLst>
           </p:cNvPr>
@@ -3535,7 +3535,7 @@
           <p:cNvPr id="2" name="">
             <a:extLst xmlns:a="http://schemas.openxmlformats.org/drawingml/2006/main">
               <a:ext uri="{FF2B5EF4-FFF2-40B4-BE49-F238E27FC236}">
-                <a16:creationId xmlns:a16="http://schemas.microsoft.com/office/drawing/2014/main" id="{34CBB79B-DAE0-4ECB-B783-C0A06A3B1F0D}"/>
+                <a16:creationId xmlns:a16="http://schemas.microsoft.com/office/drawing/2014/main" id="{F1ED5D9A-8343-479A-B901-D2CBA6E4A961}"/>
               </a:ext>
             </a:extLst>
           </p:cNvPr>
@@ -3585,7 +3585,7 @@
           <p:cNvPr id="3" name="">
             <a:extLst xmlns:a="http://schemas.openxmlformats.org/drawingml/2006/main">
               <a:ext uri="{FF2B5EF4-FFF2-40B4-BE49-F238E27FC236}">
-                <a16:creationId xmlns:a16="http://schemas.microsoft.com/office/drawing/2014/main" id="{F6F316AB-2335-4D1D-9974-D34AA1A10C4F}"/>
+                <a16:creationId xmlns:a16="http://schemas.microsoft.com/office/drawing/2014/main" id="{A86B176A-B52F-4FFC-9D7D-B53B24B89E69}"/>
               </a:ext>
             </a:extLst>
           </p:cNvPr>
@@ -3618,7 +3618,7 @@
           <p:cNvPr id="4" name="">
             <a:extLst xmlns:a="http://schemas.openxmlformats.org/drawingml/2006/main">
               <a:ext uri="{FF2B5EF4-FFF2-40B4-BE49-F238E27FC236}">
-                <a16:creationId xmlns:a16="http://schemas.microsoft.com/office/drawing/2014/main" id="{23ADBCBE-D762-465E-AA25-D77E097E1B38}"/>
+                <a16:creationId xmlns:a16="http://schemas.microsoft.com/office/drawing/2014/main" id="{B0336DE6-A189-4D1F-9F96-20301491844D}"/>
               </a:ext>
             </a:extLst>
           </p:cNvPr>
@@ -3658,7 +3658,7 @@
                   <a:srgbClr val="111111"/>
                 </a:solidFill>
               </a:rPr>
-              <a:t>5</a:t>
+              <a:t>2</a:t>
             </a:r>
           </a:p>
         </p:txBody>
@@ -3668,7 +3668,7 @@
           <p:cNvPr id="5" name="">
             <a:extLst xmlns:a="http://schemas.openxmlformats.org/drawingml/2006/main">
               <a:ext uri="{FF2B5EF4-FFF2-40B4-BE49-F238E27FC236}">
-                <a16:creationId xmlns:a16="http://schemas.microsoft.com/office/drawing/2014/main" id="{01F70E26-C2D8-4AE0-A218-150332F2D1A1}"/>
+                <a16:creationId xmlns:a16="http://schemas.microsoft.com/office/drawing/2014/main" id="{F1BE7CF0-10F3-498B-B498-E0C72177B5BC}"/>
               </a:ext>
             </a:extLst>
           </p:cNvPr>
@@ -3718,7 +3718,7 @@
           <p:cNvPr id="6" name="">
             <a:extLst xmlns:a="http://schemas.openxmlformats.org/drawingml/2006/main">
               <a:ext uri="{FF2B5EF4-FFF2-40B4-BE49-F238E27FC236}">
-                <a16:creationId xmlns:a16="http://schemas.microsoft.com/office/drawing/2014/main" id="{2D64F1FA-2E9B-4EFD-877F-D0D81D54A08C}"/>
+                <a16:creationId xmlns:a16="http://schemas.microsoft.com/office/drawing/2014/main" id="{CB59E573-B25A-4558-9ECF-A6540BAFE9DE}"/>
               </a:ext>
             </a:extLst>
           </p:cNvPr>
@@ -3751,7 +3751,7 @@
           <p:cNvPr id="7" name="">
             <a:extLst xmlns:a="http://schemas.openxmlformats.org/drawingml/2006/main">
               <a:ext uri="{FF2B5EF4-FFF2-40B4-BE49-F238E27FC236}">
-                <a16:creationId xmlns:a16="http://schemas.microsoft.com/office/drawing/2014/main" id="{0A11FB37-4B51-4DFF-B9D1-EDCAB25ABBB8}"/>
+                <a16:creationId xmlns:a16="http://schemas.microsoft.com/office/drawing/2014/main" id="{51205DE4-67E5-4321-B761-6243D3878C8D}"/>
               </a:ext>
             </a:extLst>
           </p:cNvPr>
@@ -3791,7 +3791,7 @@
                   <a:srgbClr val="D9481C"/>
                 </a:solidFill>
               </a:rPr>
-              <a:t>2</a:t>
+              <a:t>1</a:t>
             </a:r>
           </a:p>
         </p:txBody>
@@ -3801,7 +3801,7 @@
           <p:cNvPr id="8" name="">
             <a:extLst xmlns:a="http://schemas.openxmlformats.org/drawingml/2006/main">
               <a:ext uri="{FF2B5EF4-FFF2-40B4-BE49-F238E27FC236}">
-                <a16:creationId xmlns:a16="http://schemas.microsoft.com/office/drawing/2014/main" id="{FC4CBD68-59FD-4B28-AB2F-3CB805F16BBA}"/>
+                <a16:creationId xmlns:a16="http://schemas.microsoft.com/office/drawing/2014/main" id="{771F5D9C-E927-4AA7-830B-0A937B2BB850}"/>
               </a:ext>
             </a:extLst>
           </p:cNvPr>
@@ -3851,7 +3851,7 @@
           <p:cNvPr id="9" name="">
             <a:extLst xmlns:a="http://schemas.openxmlformats.org/drawingml/2006/main">
               <a:ext uri="{FF2B5EF4-FFF2-40B4-BE49-F238E27FC236}">
-                <a16:creationId xmlns:a16="http://schemas.microsoft.com/office/drawing/2014/main" id="{6931E6DE-1407-4B27-A897-9D70EA3352A7}"/>
+                <a16:creationId xmlns:a16="http://schemas.microsoft.com/office/drawing/2014/main" id="{87242A6F-0FC4-4EF6-B59E-F985FF45348E}"/>
               </a:ext>
             </a:extLst>
           </p:cNvPr>
@@ -3884,7 +3884,7 @@
           <p:cNvPr id="10" name="">
             <a:extLst xmlns:a="http://schemas.openxmlformats.org/drawingml/2006/main">
               <a:ext uri="{FF2B5EF4-FFF2-40B4-BE49-F238E27FC236}">
-                <a16:creationId xmlns:a16="http://schemas.microsoft.com/office/drawing/2014/main" id="{D9F2CF80-6DFB-4D4A-935B-3D0F8910F4AB}"/>
+                <a16:creationId xmlns:a16="http://schemas.microsoft.com/office/drawing/2014/main" id="{FFD3A83D-E7B5-4FAC-889C-7B6FFFC40431}"/>
               </a:ext>
             </a:extLst>
           </p:cNvPr>
@@ -3924,7 +3924,7 @@
                   <a:srgbClr val="111111"/>
                 </a:solidFill>
               </a:rPr>
-              <a:t>3</a:t>
+              <a:t>1</a:t>
             </a:r>
           </a:p>
         </p:txBody>
@@ -3934,7 +3934,7 @@
           <p:cNvPr id="11" name="">
             <a:extLst xmlns:a="http://schemas.openxmlformats.org/drawingml/2006/main">
               <a:ext uri="{FF2B5EF4-FFF2-40B4-BE49-F238E27FC236}">
-                <a16:creationId xmlns:a16="http://schemas.microsoft.com/office/drawing/2014/main" id="{A0E28A65-2370-4F1D-94A0-E925220A2802}"/>
+                <a16:creationId xmlns:a16="http://schemas.microsoft.com/office/drawing/2014/main" id="{DCCD21EE-57AA-4982-BA30-8AA671A1BB2D}"/>
               </a:ext>
             </a:extLst>
           </p:cNvPr>
@@ -3984,7 +3984,7 @@
           <p:cNvPr id="12" name="">
             <a:extLst xmlns:a="http://schemas.openxmlformats.org/drawingml/2006/main">
               <a:ext uri="{FF2B5EF4-FFF2-40B4-BE49-F238E27FC236}">
-                <a16:creationId xmlns:a16="http://schemas.microsoft.com/office/drawing/2014/main" id="{66D79AD6-02C9-4FE0-ABBD-EDDC4AB506F6}"/>
+                <a16:creationId xmlns:a16="http://schemas.microsoft.com/office/drawing/2014/main" id="{37F82882-82A2-4326-8BDE-C8BE280D9FA2}"/>
               </a:ext>
             </a:extLst>
           </p:cNvPr>
@@ -4017,7 +4017,7 @@
           <p:cNvPr id="13" name="">
             <a:extLst xmlns:a="http://schemas.openxmlformats.org/drawingml/2006/main">
               <a:ext uri="{FF2B5EF4-FFF2-40B4-BE49-F238E27FC236}">
-                <a16:creationId xmlns:a16="http://schemas.microsoft.com/office/drawing/2014/main" id="{9F56C9C5-EF7A-43EA-864D-F53DEF1A8224}"/>
+                <a16:creationId xmlns:a16="http://schemas.microsoft.com/office/drawing/2014/main" id="{D6445F7E-BD3D-4D29-A6B0-25E0DEBE8E52}"/>
               </a:ext>
             </a:extLst>
           </p:cNvPr>
@@ -4057,7 +4057,7 @@
                   <a:srgbClr val="111111"/>
                 </a:solidFill>
               </a:rPr>
-              <a:t>5</a:t>
+              <a:t>2</a:t>
             </a:r>
           </a:p>
         </p:txBody>
@@ -4067,7 +4067,7 @@
           <p:cNvPr id="14" name="">
             <a:extLst xmlns:a="http://schemas.openxmlformats.org/drawingml/2006/main">
               <a:ext uri="{FF2B5EF4-FFF2-40B4-BE49-F238E27FC236}">
-                <a16:creationId xmlns:a16="http://schemas.microsoft.com/office/drawing/2014/main" id="{C173B515-9D2C-4F36-8D30-41E62E2DF4A3}"/>
+                <a16:creationId xmlns:a16="http://schemas.microsoft.com/office/drawing/2014/main" id="{4DC4B789-4E88-466B-9F60-2B249CB46D2F}"/>
               </a:ext>
             </a:extLst>
           </p:cNvPr>
@@ -4117,7 +4117,7 @@
           <p:cNvPr id="15" name="">
             <a:extLst xmlns:a="http://schemas.openxmlformats.org/drawingml/2006/main">
               <a:ext uri="{FF2B5EF4-FFF2-40B4-BE49-F238E27FC236}">
-                <a16:creationId xmlns:a16="http://schemas.microsoft.com/office/drawing/2014/main" id="{BAF3DEAD-8F53-4B89-9418-43BDA6AB3974}"/>
+                <a16:creationId xmlns:a16="http://schemas.microsoft.com/office/drawing/2014/main" id="{AFEBCD5C-3A46-4E54-8FBD-93D432EAD2B4}"/>
               </a:ext>
             </a:extLst>
           </p:cNvPr>
@@ -4150,7 +4150,7 @@
           <p:cNvPr id="16" name="">
             <a:extLst xmlns:a="http://schemas.openxmlformats.org/drawingml/2006/main">
               <a:ext uri="{FF2B5EF4-FFF2-40B4-BE49-F238E27FC236}">
-                <a16:creationId xmlns:a16="http://schemas.microsoft.com/office/drawing/2014/main" id="{FBA7E7B4-FEE3-4BE5-878D-B9BAF3BF49CA}"/>
+                <a16:creationId xmlns:a16="http://schemas.microsoft.com/office/drawing/2014/main" id="{EC5F644A-9444-4699-B1F1-33517F50A187}"/>
               </a:ext>
             </a:extLst>
           </p:cNvPr>
@@ -4200,7 +4200,7 @@
           <p:cNvPr id="17" name="">
             <a:extLst xmlns:a="http://schemas.openxmlformats.org/drawingml/2006/main">
               <a:ext uri="{FF2B5EF4-FFF2-40B4-BE49-F238E27FC236}">
-                <a16:creationId xmlns:a16="http://schemas.microsoft.com/office/drawing/2014/main" id="{CCB6E154-0F72-47BE-81DC-7CF2976B3BEC}"/>
+                <a16:creationId xmlns:a16="http://schemas.microsoft.com/office/drawing/2014/main" id="{5C877600-A45E-417A-8266-B4B0FFFF0207}"/>
               </a:ext>
             </a:extLst>
           </p:cNvPr>
@@ -4240,7 +4240,7 @@
                   <a:srgbClr val="111111"/>
                 </a:solidFill>
               </a:rPr>
-              <a:t>2 projects are already more than two weeks behind, and 5 are spending ahead of delivery progress.</a:t>
+              <a:t>1 projects are already more than two weeks behind, and 2 are spending ahead of delivery progress.</a:t>
             </a:r>
           </a:p>
           <a:p xmlns:a="http://schemas.openxmlformats.org/drawingml/2006/main">
@@ -4262,7 +4262,7 @@
                   <a:srgbClr val="111111"/>
                 </a:solidFill>
               </a:rPr>
-              <a:t>3 projects also carry two or more critical blockers, which means the schedule risk is likely to stay elevated unless escalation gets faster.</a:t>
+              <a:t>1 projects also carry two or more critical blockers, which means the schedule risk is likely to stay elevated unless escalation gets faster.</a:t>
             </a:r>
           </a:p>
           <a:p xmlns:a="http://schemas.openxmlformats.org/drawingml/2006/main">
@@ -4294,7 +4294,7 @@
           <p:cNvPr id="18" name="">
             <a:extLst xmlns:a="http://schemas.openxmlformats.org/drawingml/2006/main">
               <a:ext uri="{FF2B5EF4-FFF2-40B4-BE49-F238E27FC236}">
-                <a16:creationId xmlns:a16="http://schemas.microsoft.com/office/drawing/2014/main" id="{6A8BF249-6FEE-4F1D-BF75-D78DAD5E3D2B}"/>
+                <a16:creationId xmlns:a16="http://schemas.microsoft.com/office/drawing/2014/main" id="{48C05591-E96D-4ED7-AA9C-D6B765D40940}"/>
               </a:ext>
             </a:extLst>
           </p:cNvPr>
@@ -4342,7 +4342,7 @@
     </p:spTree>
     <p:extLst>
       <p:ext uri="{BB962C8B-B14F-4D97-AF65-F5344CB8AC3E}">
-        <p14:creationId xmlns:p14="http://schemas.microsoft.com/office/powerpoint/2010/main" val="902034728"/>
+        <p14:creationId xmlns:p14="http://schemas.microsoft.com/office/powerpoint/2010/main" val="754115266"/>
       </p:ext>
     </p:extLst>
   </p:cSld>
@@ -4373,7 +4373,7 @@
           <p:cNvPr id="1" name="">
             <a:extLst xmlns:a="http://schemas.openxmlformats.org/drawingml/2006/main">
               <a:ext uri="{FF2B5EF4-FFF2-40B4-BE49-F238E27FC236}">
-                <a16:creationId xmlns:a16="http://schemas.microsoft.com/office/drawing/2014/main" id="{8F39AAB5-E5F6-4264-841B-67C88F7762E8}"/>
+                <a16:creationId xmlns:a16="http://schemas.microsoft.com/office/drawing/2014/main" id="{B37793CC-7FE2-4378-87D0-934AE638EFF5}"/>
               </a:ext>
             </a:extLst>
           </p:cNvPr>
@@ -4423,7 +4423,7 @@
           <p:cNvPr id="2" name="">
             <a:extLst xmlns:a="http://schemas.openxmlformats.org/drawingml/2006/main">
               <a:ext uri="{FF2B5EF4-FFF2-40B4-BE49-F238E27FC236}">
-                <a16:creationId xmlns:a16="http://schemas.microsoft.com/office/drawing/2014/main" id="{2CED9132-DA81-4C20-A2DD-DC0D5118C497}"/>
+                <a16:creationId xmlns:a16="http://schemas.microsoft.com/office/drawing/2014/main" id="{256E1DA2-01BF-4834-81EF-121A4AB7FB0B}"/>
               </a:ext>
             </a:extLst>
           </p:cNvPr>
@@ -4487,7 +4487,7 @@
                 <a:gridCol w="1047750"/>
                 <a:gridCol w="6705600"/>
               </a:tblGrid>
-              <a:tr h="666750">
+              <a:tr h="1333500">
                 <a:tc>
                   <a:txBody>
                     <a:bodyPr/>
@@ -4552,7 +4552,7 @@
                   </a:tcPr>
                 </a:tc>
               </a:tr>
-              <a:tr h="666750">
+              <a:tr h="1333500">
                 <a:tc>
                   <a:txBody>
                     <a:bodyPr/>
@@ -4605,113 +4605,7 @@
                   <a:tcPr marL="91440" marR="91440" marT="45720" marB="45720"/>
                 </a:tc>
               </a:tr>
-              <a:tr h="666750">
-                <a:tc>
-                  <a:txBody>
-                    <a:bodyPr/>
-                    <a:lstStyle/>
-                    <a:p>
-                      <a:r>
-                        <a:rPr sz="975">
-                          <a:solidFill>
-                            <a:srgbClr val="111111"/>
-                          </a:solidFill>
-                        </a:rPr>
-                        <a:t>Vendor Risk Platform</a:t>
-                      </a:r>
-                    </a:p>
-                  </a:txBody>
-                  <a:tcPr marL="91440" marR="91440" marT="45720" marB="45720"/>
-                </a:tc>
-                <a:tc>
-                  <a:txBody>
-                    <a:bodyPr/>
-                    <a:lstStyle/>
-                    <a:p>
-                      <a:r>
-                        <a:rPr sz="975">
-                          <a:solidFill>
-                            <a:srgbClr val="111111"/>
-                          </a:solidFill>
-                        </a:rPr>
-                        <a:t>85.2</a:t>
-                      </a:r>
-                    </a:p>
-                  </a:txBody>
-                  <a:tcPr marL="91440" marR="91440" marT="45720" marB="45720"/>
-                </a:tc>
-                <a:tc>
-                  <a:txBody>
-                    <a:bodyPr/>
-                    <a:lstStyle/>
-                    <a:p>
-                      <a:r>
-                        <a:rPr sz="975">
-                          <a:solidFill>
-                            <a:srgbClr val="111111"/>
-                          </a:solidFill>
-                        </a:rPr>
-                        <a:t>Progress trails plan by 23 points and the project is 21 days behind schedule</a:t>
-                      </a:r>
-                    </a:p>
-                  </a:txBody>
-                  <a:tcPr marL="91440" marR="91440" marT="45720" marB="45720"/>
-                </a:tc>
-              </a:tr>
-              <a:tr h="666750">
-                <a:tc>
-                  <a:txBody>
-                    <a:bodyPr/>
-                    <a:lstStyle/>
-                    <a:p>
-                      <a:r>
-                        <a:rPr sz="975">
-                          <a:solidFill>
-                            <a:srgbClr val="111111"/>
-                          </a:solidFill>
-                        </a:rPr>
-                        <a:t>Contract Lifecycle Mgmt</a:t>
-                      </a:r>
-                    </a:p>
-                  </a:txBody>
-                  <a:tcPr marL="91440" marR="91440" marT="45720" marB="45720"/>
-                </a:tc>
-                <a:tc>
-                  <a:txBody>
-                    <a:bodyPr/>
-                    <a:lstStyle/>
-                    <a:p>
-                      <a:r>
-                        <a:rPr sz="975">
-                          <a:solidFill>
-                            <a:srgbClr val="111111"/>
-                          </a:solidFill>
-                        </a:rPr>
-                        <a:t>84.4</a:t>
-                      </a:r>
-                    </a:p>
-                  </a:txBody>
-                  <a:tcPr marL="91440" marR="91440" marT="45720" marB="45720"/>
-                </a:tc>
-                <a:tc>
-                  <a:txBody>
-                    <a:bodyPr/>
-                    <a:lstStyle/>
-                    <a:p>
-                      <a:r>
-                        <a:rPr sz="975">
-                          <a:solidFill>
-                            <a:srgbClr val="111111"/>
-                          </a:solidFill>
-                        </a:rPr>
-                        <a:t>Progress trails plan by 14 points and the project is 14 days behind schedule</a:t>
-                      </a:r>
-                    </a:p>
-                  </a:txBody>
-                  <a:tcPr marL="91440" marR="91440" marT="45720" marB="45720"/>
-                </a:tc>
-              </a:tr>
-              <a:tr h="666750">
+              <a:tr h="1333500">
                 <a:tc>
                   <a:txBody>
                     <a:bodyPr/>
@@ -4764,59 +4658,6 @@
                   <a:tcPr marL="91440" marR="91440" marT="45720" marB="45720"/>
                 </a:tc>
               </a:tr>
-              <a:tr h="666750">
-                <a:tc>
-                  <a:txBody>
-                    <a:bodyPr/>
-                    <a:lstStyle/>
-                    <a:p>
-                      <a:r>
-                        <a:rPr sz="975">
-                          <a:solidFill>
-                            <a:srgbClr val="111111"/>
-                          </a:solidFill>
-                        </a:rPr>
-                        <a:t>Data Lake Modernization</a:t>
-                      </a:r>
-                    </a:p>
-                  </a:txBody>
-                  <a:tcPr marL="91440" marR="91440" marT="45720" marB="45720"/>
-                </a:tc>
-                <a:tc>
-                  <a:txBody>
-                    <a:bodyPr/>
-                    <a:lstStyle/>
-                    <a:p>
-                      <a:r>
-                        <a:rPr sz="975">
-                          <a:solidFill>
-                            <a:srgbClr val="111111"/>
-                          </a:solidFill>
-                        </a:rPr>
-                        <a:t>27.9</a:t>
-                      </a:r>
-                    </a:p>
-                  </a:txBody>
-                  <a:tcPr marL="91440" marR="91440" marT="45720" marB="45720"/>
-                </a:tc>
-                <a:tc>
-                  <a:txBody>
-                    <a:bodyPr/>
-                    <a:lstStyle/>
-                    <a:p>
-                      <a:r>
-                        <a:rPr sz="975">
-                          <a:solidFill>
-                            <a:srgbClr val="111111"/>
-                          </a:solidFill>
-                        </a:rPr>
-                        <a:t>40% of milestones are marked delayed and 80% are overdue as of 2026-07-09</a:t>
-                      </a:r>
-                    </a:p>
-                  </a:txBody>
-                  <a:tcPr marL="91440" marR="91440" marT="45720" marB="45720"/>
-                </a:tc>
-              </a:tr>
             </a:tbl>
           </a:graphicData>
         </a:graphic>
@@ -4826,7 +4667,7 @@
           <p:cNvPr id="4" name="">
             <a:extLst xmlns:a="http://schemas.openxmlformats.org/drawingml/2006/main">
               <a:ext uri="{FF2B5EF4-FFF2-40B4-BE49-F238E27FC236}">
-                <a16:creationId xmlns:a16="http://schemas.microsoft.com/office/drawing/2014/main" id="{0F38B6ED-4F72-414C-9700-AACEE4F07FA2}"/>
+                <a16:creationId xmlns:a16="http://schemas.microsoft.com/office/drawing/2014/main" id="{271E84CD-E883-45D7-9A49-2E6D5DC29B19}"/>
               </a:ext>
             </a:extLst>
           </p:cNvPr>
@@ -4876,7 +4717,7 @@
           <p:cNvPr id="5" name="">
             <a:extLst xmlns:a="http://schemas.openxmlformats.org/drawingml/2006/main">
               <a:ext uri="{FF2B5EF4-FFF2-40B4-BE49-F238E27FC236}">
-                <a16:creationId xmlns:a16="http://schemas.microsoft.com/office/drawing/2014/main" id="{1C97F556-5E2B-4927-B5B8-3AC9B8C92990}"/>
+                <a16:creationId xmlns:a16="http://schemas.microsoft.com/office/drawing/2014/main" id="{3FF10B07-FDCD-4EFD-8EDE-9CE93AFFABAB}"/>
               </a:ext>
             </a:extLst>
           </p:cNvPr>
@@ -4924,7 +4765,7 @@
     </p:spTree>
     <p:extLst>
       <p:ext uri="{BB962C8B-B14F-4D97-AF65-F5344CB8AC3E}">
-        <p14:creationId xmlns:p14="http://schemas.microsoft.com/office/powerpoint/2010/main" val="1703562412"/>
+        <p14:creationId xmlns:p14="http://schemas.microsoft.com/office/powerpoint/2010/main" val="533843240"/>
       </p:ext>
     </p:extLst>
   </p:cSld>
@@ -4955,7 +4796,7 @@
           <p:cNvPr id="1" name="">
             <a:extLst xmlns:a="http://schemas.openxmlformats.org/drawingml/2006/main">
               <a:ext uri="{FF2B5EF4-FFF2-40B4-BE49-F238E27FC236}">
-                <a16:creationId xmlns:a16="http://schemas.microsoft.com/office/drawing/2014/main" id="{92F1980A-83A8-4EB6-9126-94DD0417E75E}"/>
+                <a16:creationId xmlns:a16="http://schemas.microsoft.com/office/drawing/2014/main" id="{2A8A8087-BC35-45AD-A40B-BE23D9E21DB2}"/>
               </a:ext>
             </a:extLst>
           </p:cNvPr>
@@ -5005,7 +4846,7 @@
           <p:cNvPr id="2" name="">
             <a:extLst xmlns:a="http://schemas.openxmlformats.org/drawingml/2006/main">
               <a:ext uri="{FF2B5EF4-FFF2-40B4-BE49-F238E27FC236}">
-                <a16:creationId xmlns:a16="http://schemas.microsoft.com/office/drawing/2014/main" id="{ACAD31E6-1B56-45E7-A860-342A94CD9161}"/>
+                <a16:creationId xmlns:a16="http://schemas.microsoft.com/office/drawing/2014/main" id="{3115BF07-AE11-4986-8C8E-D14D84A7A537}"/>
               </a:ext>
             </a:extLst>
           </p:cNvPr>
@@ -5055,7 +4896,7 @@
           <p:cNvPr id="3" name="">
             <a:extLst xmlns:a="http://schemas.openxmlformats.org/drawingml/2006/main">
               <a:ext uri="{FF2B5EF4-FFF2-40B4-BE49-F238E27FC236}">
-                <a16:creationId xmlns:a16="http://schemas.microsoft.com/office/drawing/2014/main" id="{B3FA3AB5-D788-457D-B834-64B699C635A8}"/>
+                <a16:creationId xmlns:a16="http://schemas.microsoft.com/office/drawing/2014/main" id="{D3452FBF-F3A6-4AAB-BC26-C033D9F9469E}"/>
               </a:ext>
             </a:extLst>
           </p:cNvPr>
@@ -5088,7 +4929,7 @@
           <p:cNvPr id="4" name="">
             <a:extLst xmlns:a="http://schemas.openxmlformats.org/drawingml/2006/main">
               <a:ext uri="{FF2B5EF4-FFF2-40B4-BE49-F238E27FC236}">
-                <a16:creationId xmlns:a16="http://schemas.microsoft.com/office/drawing/2014/main" id="{1F1ABC53-B87A-49F5-855B-AC93E14D2EE1}"/>
+                <a16:creationId xmlns:a16="http://schemas.microsoft.com/office/drawing/2014/main" id="{66ECBE79-A969-4405-88F8-4C382D93EE02}"/>
               </a:ext>
             </a:extLst>
           </p:cNvPr>
@@ -5138,7 +4979,7 @@
           <p:cNvPr id="5" name="">
             <a:extLst xmlns:a="http://schemas.openxmlformats.org/drawingml/2006/main">
               <a:ext uri="{FF2B5EF4-FFF2-40B4-BE49-F238E27FC236}">
-                <a16:creationId xmlns:a16="http://schemas.microsoft.com/office/drawing/2014/main" id="{2C78E8B8-2B74-4EEC-A051-3A48C5AC7F2D}"/>
+                <a16:creationId xmlns:a16="http://schemas.microsoft.com/office/drawing/2014/main" id="{3C53CA57-7674-4AC7-B3BC-44B57EBDA4AB}"/>
               </a:ext>
             </a:extLst>
           </p:cNvPr>
@@ -5188,7 +5029,7 @@
           <p:cNvPr id="6" name="">
             <a:extLst xmlns:a="http://schemas.openxmlformats.org/drawingml/2006/main">
               <a:ext uri="{FF2B5EF4-FFF2-40B4-BE49-F238E27FC236}">
-                <a16:creationId xmlns:a16="http://schemas.microsoft.com/office/drawing/2014/main" id="{734C3580-6FEE-4C31-8B54-08CAF1015704}"/>
+                <a16:creationId xmlns:a16="http://schemas.microsoft.com/office/drawing/2014/main" id="{297B1DA5-201C-4041-BFBF-05FA18B0AF9B}"/>
               </a:ext>
             </a:extLst>
           </p:cNvPr>
@@ -5238,7 +5079,7 @@
           <p:cNvPr id="7" name="">
             <a:extLst xmlns:a="http://schemas.openxmlformats.org/drawingml/2006/main">
               <a:ext uri="{FF2B5EF4-FFF2-40B4-BE49-F238E27FC236}">
-                <a16:creationId xmlns:a16="http://schemas.microsoft.com/office/drawing/2014/main" id="{EBEAD70F-F028-49BF-B834-1AED0877F1D9}"/>
+                <a16:creationId xmlns:a16="http://schemas.microsoft.com/office/drawing/2014/main" id="{1EDA5736-1AD0-4622-828F-E2A2E664DCBE}"/>
               </a:ext>
             </a:extLst>
           </p:cNvPr>
@@ -5271,7 +5112,7 @@
           <p:cNvPr id="8" name="">
             <a:extLst xmlns:a="http://schemas.openxmlformats.org/drawingml/2006/main">
               <a:ext uri="{FF2B5EF4-FFF2-40B4-BE49-F238E27FC236}">
-                <a16:creationId xmlns:a16="http://schemas.microsoft.com/office/drawing/2014/main" id="{7F3FF97F-EA45-4142-9335-35F75D41A1C6}"/>
+                <a16:creationId xmlns:a16="http://schemas.microsoft.com/office/drawing/2014/main" id="{E3F12CCE-7635-4F3E-AD25-6C8EEB24F928}"/>
               </a:ext>
             </a:extLst>
           </p:cNvPr>
@@ -5321,7 +5162,7 @@
           <p:cNvPr id="9" name="">
             <a:extLst xmlns:a="http://schemas.openxmlformats.org/drawingml/2006/main">
               <a:ext uri="{FF2B5EF4-FFF2-40B4-BE49-F238E27FC236}">
-                <a16:creationId xmlns:a16="http://schemas.microsoft.com/office/drawing/2014/main" id="{2D97873D-D886-41CC-A9B0-FF5868D36570}"/>
+                <a16:creationId xmlns:a16="http://schemas.microsoft.com/office/drawing/2014/main" id="{B81E3015-E200-4E28-8483-38CB997ED995}"/>
               </a:ext>
             </a:extLst>
           </p:cNvPr>
@@ -5371,7 +5212,7 @@
           <p:cNvPr id="10" name="">
             <a:extLst xmlns:a="http://schemas.openxmlformats.org/drawingml/2006/main">
               <a:ext uri="{FF2B5EF4-FFF2-40B4-BE49-F238E27FC236}">
-                <a16:creationId xmlns:a16="http://schemas.microsoft.com/office/drawing/2014/main" id="{F1170BBA-0698-4BF0-838C-BED15EAFB04E}"/>
+                <a16:creationId xmlns:a16="http://schemas.microsoft.com/office/drawing/2014/main" id="{551243D1-6479-4D02-8CC1-CB124FA2C7BF}"/>
               </a:ext>
             </a:extLst>
           </p:cNvPr>
@@ -5421,7 +5262,7 @@
           <p:cNvPr id="11" name="">
             <a:extLst xmlns:a="http://schemas.openxmlformats.org/drawingml/2006/main">
               <a:ext uri="{FF2B5EF4-FFF2-40B4-BE49-F238E27FC236}">
-                <a16:creationId xmlns:a16="http://schemas.microsoft.com/office/drawing/2014/main" id="{2D748C19-3BCE-45CC-B38B-274E600A1148}"/>
+                <a16:creationId xmlns:a16="http://schemas.microsoft.com/office/drawing/2014/main" id="{F39B5D7E-8724-4BD1-B2D7-9A8376C60C66}"/>
               </a:ext>
             </a:extLst>
           </p:cNvPr>
@@ -5454,7 +5295,7 @@
           <p:cNvPr id="12" name="">
             <a:extLst xmlns:a="http://schemas.openxmlformats.org/drawingml/2006/main">
               <a:ext uri="{FF2B5EF4-FFF2-40B4-BE49-F238E27FC236}">
-                <a16:creationId xmlns:a16="http://schemas.microsoft.com/office/drawing/2014/main" id="{27DF163C-C301-46FB-BE31-E6C76359B46B}"/>
+                <a16:creationId xmlns:a16="http://schemas.microsoft.com/office/drawing/2014/main" id="{CF7104BB-FBE7-45A3-8B26-3FC6742F68CE}"/>
               </a:ext>
             </a:extLst>
           </p:cNvPr>
@@ -5504,7 +5345,7 @@
           <p:cNvPr id="13" name="">
             <a:extLst xmlns:a="http://schemas.openxmlformats.org/drawingml/2006/main">
               <a:ext uri="{FF2B5EF4-FFF2-40B4-BE49-F238E27FC236}">
-                <a16:creationId xmlns:a16="http://schemas.microsoft.com/office/drawing/2014/main" id="{D588FF96-021B-425B-801F-57699766924A}"/>
+                <a16:creationId xmlns:a16="http://schemas.microsoft.com/office/drawing/2014/main" id="{693702A5-D6D0-453E-B1BD-FEDD6F24CF7A}"/>
               </a:ext>
             </a:extLst>
           </p:cNvPr>
@@ -5554,7 +5395,7 @@
           <p:cNvPr id="14" name="">
             <a:extLst xmlns:a="http://schemas.openxmlformats.org/drawingml/2006/main">
               <a:ext uri="{FF2B5EF4-FFF2-40B4-BE49-F238E27FC236}">
-                <a16:creationId xmlns:a16="http://schemas.microsoft.com/office/drawing/2014/main" id="{12F195F2-9F67-4EA2-A0BB-0AD406732525}"/>
+                <a16:creationId xmlns:a16="http://schemas.microsoft.com/office/drawing/2014/main" id="{AEBF3B00-75A3-4F6F-BC44-9B9205B7D2A1}"/>
               </a:ext>
             </a:extLst>
           </p:cNvPr>
@@ -5604,7 +5445,7 @@
           <p:cNvPr id="15" name="">
             <a:extLst xmlns:a="http://schemas.openxmlformats.org/drawingml/2006/main">
               <a:ext uri="{FF2B5EF4-FFF2-40B4-BE49-F238E27FC236}">
-                <a16:creationId xmlns:a16="http://schemas.microsoft.com/office/drawing/2014/main" id="{B2CC6B07-C0A2-4173-AC32-976330EF3541}"/>
+                <a16:creationId xmlns:a16="http://schemas.microsoft.com/office/drawing/2014/main" id="{35AB4391-6089-49BF-A09E-B03EA56CD245}"/>
               </a:ext>
             </a:extLst>
           </p:cNvPr>
@@ -5652,7 +5493,7 @@
     </p:spTree>
     <p:extLst>
       <p:ext uri="{BB962C8B-B14F-4D97-AF65-F5344CB8AC3E}">
-        <p14:creationId xmlns:p14="http://schemas.microsoft.com/office/powerpoint/2010/main" val="1539242775"/>
+        <p14:creationId xmlns:p14="http://schemas.microsoft.com/office/powerpoint/2010/main" val="1325948663"/>
       </p:ext>
     </p:extLst>
   </p:cSld>
@@ -5683,7 +5524,7 @@
           <p:cNvPr id="1" name="">
             <a:extLst xmlns:a="http://schemas.openxmlformats.org/drawingml/2006/main">
               <a:ext uri="{FF2B5EF4-FFF2-40B4-BE49-F238E27FC236}">
-                <a16:creationId xmlns:a16="http://schemas.microsoft.com/office/drawing/2014/main" id="{E6C4C5F6-CA13-4E04-9797-FD66CA8B92B2}"/>
+                <a16:creationId xmlns:a16="http://schemas.microsoft.com/office/drawing/2014/main" id="{BDDF3982-9DE8-462F-89EB-FA0C8CAD1E82}"/>
               </a:ext>
             </a:extLst>
           </p:cNvPr>
@@ -5733,7 +5574,7 @@
           <p:cNvPr id="2" name="">
             <a:extLst xmlns:a="http://schemas.openxmlformats.org/drawingml/2006/main">
               <a:ext uri="{FF2B5EF4-FFF2-40B4-BE49-F238E27FC236}">
-                <a16:creationId xmlns:a16="http://schemas.microsoft.com/office/drawing/2014/main" id="{7D711277-4963-4C99-9F10-00FEA674653F}"/>
+                <a16:creationId xmlns:a16="http://schemas.microsoft.com/office/drawing/2014/main" id="{A00D006C-7CF2-49F2-A343-29DD39F99FF2}"/>
               </a:ext>
             </a:extLst>
           </p:cNvPr>
@@ -5783,7 +5624,7 @@
           <p:cNvPr id="3" name="">
             <a:extLst xmlns:a="http://schemas.openxmlformats.org/drawingml/2006/main">
               <a:ext uri="{FF2B5EF4-FFF2-40B4-BE49-F238E27FC236}">
-                <a16:creationId xmlns:a16="http://schemas.microsoft.com/office/drawing/2014/main" id="{F36DA50B-03EB-4738-B3B7-F2D96CA6FC33}"/>
+                <a16:creationId xmlns:a16="http://schemas.microsoft.com/office/drawing/2014/main" id="{50C75EE6-8DD5-427E-AA6D-B61654D9393B}"/>
               </a:ext>
             </a:extLst>
           </p:cNvPr>
@@ -5816,7 +5657,7 @@
           <p:cNvPr id="4" name="">
             <a:extLst xmlns:a="http://schemas.openxmlformats.org/drawingml/2006/main">
               <a:ext uri="{FF2B5EF4-FFF2-40B4-BE49-F238E27FC236}">
-                <a16:creationId xmlns:a16="http://schemas.microsoft.com/office/drawing/2014/main" id="{BF77F44B-652C-4C1C-90B1-F6347CCAEE8A}"/>
+                <a16:creationId xmlns:a16="http://schemas.microsoft.com/office/drawing/2014/main" id="{D8595767-886A-46B1-BC6F-5141AD477FB0}"/>
               </a:ext>
             </a:extLst>
           </p:cNvPr>
@@ -5866,7 +5707,7 @@
           <p:cNvPr id="5" name="">
             <a:extLst xmlns:a="http://schemas.openxmlformats.org/drawingml/2006/main">
               <a:ext uri="{FF2B5EF4-FFF2-40B4-BE49-F238E27FC236}">
-                <a16:creationId xmlns:a16="http://schemas.microsoft.com/office/drawing/2014/main" id="{B27A469F-BDC9-4450-86C8-2A44AEA847AE}"/>
+                <a16:creationId xmlns:a16="http://schemas.microsoft.com/office/drawing/2014/main" id="{014C2CBD-1B35-4328-9851-AD871C78F248}"/>
               </a:ext>
             </a:extLst>
           </p:cNvPr>
@@ -5916,7 +5757,7 @@
           <p:cNvPr id="6" name="">
             <a:extLst xmlns:a="http://schemas.openxmlformats.org/drawingml/2006/main">
               <a:ext uri="{FF2B5EF4-FFF2-40B4-BE49-F238E27FC236}">
-                <a16:creationId xmlns:a16="http://schemas.microsoft.com/office/drawing/2014/main" id="{1F499FC4-BD6D-4570-9FE0-C6681861F524}"/>
+                <a16:creationId xmlns:a16="http://schemas.microsoft.com/office/drawing/2014/main" id="{157E48D9-D51C-4E57-BB1C-BD02582CD532}"/>
               </a:ext>
             </a:extLst>
           </p:cNvPr>
@@ -5949,7 +5790,7 @@
           <p:cNvPr id="7" name="">
             <a:extLst xmlns:a="http://schemas.openxmlformats.org/drawingml/2006/main">
               <a:ext uri="{FF2B5EF4-FFF2-40B4-BE49-F238E27FC236}">
-                <a16:creationId xmlns:a16="http://schemas.microsoft.com/office/drawing/2014/main" id="{8FE4CE85-3ADF-4EC2-89DF-7C91B8306603}"/>
+                <a16:creationId xmlns:a16="http://schemas.microsoft.com/office/drawing/2014/main" id="{8FFF4073-0D9B-4E8C-88CC-A82757A93EEB}"/>
               </a:ext>
             </a:extLst>
           </p:cNvPr>
@@ -5999,7 +5840,7 @@
           <p:cNvPr id="8" name="">
             <a:extLst xmlns:a="http://schemas.openxmlformats.org/drawingml/2006/main">
               <a:ext uri="{FF2B5EF4-FFF2-40B4-BE49-F238E27FC236}">
-                <a16:creationId xmlns:a16="http://schemas.microsoft.com/office/drawing/2014/main" id="{1A4765BF-AA67-4209-93E4-8D7BE4FF52A8}"/>
+                <a16:creationId xmlns:a16="http://schemas.microsoft.com/office/drawing/2014/main" id="{A7D272D2-B416-43BF-9F3E-0400B6F6EE14}"/>
               </a:ext>
             </a:extLst>
           </p:cNvPr>
@@ -6039,7 +5880,7 @@
                   <a:srgbClr val="111111"/>
                 </a:solidFill>
               </a:rPr>
-              <a:t>1. Re-baselining the top five red projects should slow further schedule deterioration across the 2 projects already delayed by more than 14 days.</a:t>
+              <a:t>1. Re-baselining the top five red projects should slow further schedule deterioration across the 1 projects already delayed by more than 14 days.</a:t>
             </a:r>
           </a:p>
           <a:p xmlns:a="http://schemas.openxmlformats.org/drawingml/2006/main">
@@ -6061,7 +5902,7 @@
                   <a:srgbClr val="111111"/>
                 </a:solidFill>
               </a:rPr>
-              <a:t>2. A tighter burn-versus-progress review should help contain the 5 projects currently spending ahead of delivery progress.</a:t>
+              <a:t>2. A tighter burn-versus-progress review should help contain the 2 projects currently spending ahead of delivery progress.</a:t>
             </a:r>
           </a:p>
           <a:p xmlns:a="http://schemas.openxmlformats.org/drawingml/2006/main">
@@ -6083,7 +5924,7 @@
                   <a:srgbClr val="111111"/>
                 </a:solidFill>
               </a:rPr>
-              <a:t>3. Daily blocker escalation and better status hygiene should improve confidence on the 3 heavily blocked projects and narrow the 0.0-point reporting gap in the leading red project.</a:t>
+              <a:t>3. Daily blocker escalation and better status hygiene should improve confidence on the 1 heavily blocked projects and narrow the 0.0-point reporting gap in the leading red project.</a:t>
             </a:r>
           </a:p>
         </p:txBody>
@@ -6093,7 +5934,7 @@
           <p:cNvPr id="9" name="">
             <a:extLst xmlns:a="http://schemas.openxmlformats.org/drawingml/2006/main">
               <a:ext uri="{FF2B5EF4-FFF2-40B4-BE49-F238E27FC236}">
-                <a16:creationId xmlns:a16="http://schemas.microsoft.com/office/drawing/2014/main" id="{3A63C5F1-360F-4614-BAC8-54F4143C3948}"/>
+                <a16:creationId xmlns:a16="http://schemas.microsoft.com/office/drawing/2014/main" id="{43A173F7-AACD-4865-9F3A-7B45404E84E8}"/>
               </a:ext>
             </a:extLst>
           </p:cNvPr>
@@ -6143,7 +5984,7 @@
           <p:cNvPr id="10" name="">
             <a:extLst xmlns:a="http://schemas.openxmlformats.org/drawingml/2006/main">
               <a:ext uri="{FF2B5EF4-FFF2-40B4-BE49-F238E27FC236}">
-                <a16:creationId xmlns:a16="http://schemas.microsoft.com/office/drawing/2014/main" id="{302577C0-F6C1-4C77-81C0-38003DD62AED}"/>
+                <a16:creationId xmlns:a16="http://schemas.microsoft.com/office/drawing/2014/main" id="{206C3210-C374-4202-A762-AAD5A5C01EA6}"/>
               </a:ext>
             </a:extLst>
           </p:cNvPr>
@@ -6191,7 +6032,7 @@
     </p:spTree>
     <p:extLst>
       <p:ext uri="{BB962C8B-B14F-4D97-AF65-F5344CB8AC3E}">
-        <p14:creationId xmlns:p14="http://schemas.microsoft.com/office/powerpoint/2010/main" val="1326743009"/>
+        <p14:creationId xmlns:p14="http://schemas.microsoft.com/office/powerpoint/2010/main" val="302518405"/>
       </p:ext>
     </p:extLst>
   </p:cSld>

</xml_diff>